<commit_message>
Simplify the account handoff deck
</commit_message>
<xml_diff>
--- a/examples/terrapin-account-deck.pptx
+++ b/examples/terrapin-account-deck.pptx
@@ -2,41 +2,39 @@
 <file path=ppt/presentation.xml><?xml version="1.0" encoding="utf-8"?>
 <p:presentation xmlns:p="http://schemas.openxmlformats.org/presentationml/2006/main" embedTrueTypeFonts="1" saveSubsetFonts="0">
   <p:sldMasterIdLst>
-    <p:sldMasterId xmlns:r="http://schemas.openxmlformats.org/officeDocument/2006/relationships" id="2147483648" r:id="Re627d37504fe4ed0"/>
+    <p:sldMasterId xmlns:r="http://schemas.openxmlformats.org/officeDocument/2006/relationships" id="2147483648" r:id="Reff342ed1c384f13"/>
   </p:sldMasterIdLst>
   <p:notesMasterIdLst>
-    <p:notesMasterId xmlns:r="http://schemas.openxmlformats.org/officeDocument/2006/relationships" r:id="Rf207c6b9877c48a4"/>
+    <p:notesMasterId xmlns:r="http://schemas.openxmlformats.org/officeDocument/2006/relationships" r:id="Rc6ac4cd241074af1"/>
   </p:notesMasterIdLst>
   <p:sldIdLst>
-    <p:sldId xmlns:r="http://schemas.openxmlformats.org/officeDocument/2006/relationships" id="256" r:id="Raca11c4ca44e47ac"/>
-    <p:sldId xmlns:r="http://schemas.openxmlformats.org/officeDocument/2006/relationships" id="257" r:id="R6d37f69b9d4941f0"/>
-    <p:sldId xmlns:r="http://schemas.openxmlformats.org/officeDocument/2006/relationships" id="258" r:id="R89994139c9834bcd"/>
-    <p:sldId xmlns:r="http://schemas.openxmlformats.org/officeDocument/2006/relationships" id="259" r:id="Rb1a2f9b26f234493"/>
-    <p:sldId xmlns:r="http://schemas.openxmlformats.org/officeDocument/2006/relationships" id="260" r:id="R93b4187823c24368"/>
+    <p:sldId xmlns:r="http://schemas.openxmlformats.org/officeDocument/2006/relationships" id="256" r:id="R114d313ea81642be"/>
+    <p:sldId xmlns:r="http://schemas.openxmlformats.org/officeDocument/2006/relationships" id="257" r:id="R2ecd76d24f8543c2"/>
+    <p:sldId xmlns:r="http://schemas.openxmlformats.org/officeDocument/2006/relationships" id="258" r:id="Rd9f66bb8311b443a"/>
   </p:sldIdLst>
   <p:sldSz cx="12192000" cy="6858000"/>
   <p:notesSz cx="6858000" cy="9144000"/>
   <p:embeddedFontLst>
     <p:embeddedFont>
       <p:font typeface="Inter"/>
-      <p:regular xmlns:r="http://schemas.openxmlformats.org/officeDocument/2006/relationships" r:id="R649ea43289e54c8c"/>
-      <p:bold xmlns:r="http://schemas.openxmlformats.org/officeDocument/2006/relationships" r:id="R417b3c997bf34e1e"/>
+      <p:regular xmlns:r="http://schemas.openxmlformats.org/officeDocument/2006/relationships" r:id="Ree231feb1c7e4178"/>
+      <p:bold xmlns:r="http://schemas.openxmlformats.org/officeDocument/2006/relationships" r:id="Rebe415936e70417f"/>
     </p:embeddedFont>
     <p:embeddedFont>
       <p:font typeface="Inter Medium"/>
-      <p:regular xmlns:r="http://schemas.openxmlformats.org/officeDocument/2006/relationships" r:id="Rc8fcc19b85604d07"/>
+      <p:regular xmlns:r="http://schemas.openxmlformats.org/officeDocument/2006/relationships" r:id="R1864f48476bb4541"/>
     </p:embeddedFont>
     <p:embeddedFont>
       <p:font typeface="Inter SemiBold"/>
-      <p:regular xmlns:r="http://schemas.openxmlformats.org/officeDocument/2006/relationships" r:id="Ra02fa427e1fd4f13"/>
-      <p:bold xmlns:r="http://schemas.openxmlformats.org/officeDocument/2006/relationships" r:id="R2330ebdb65f94979"/>
+      <p:regular xmlns:r="http://schemas.openxmlformats.org/officeDocument/2006/relationships" r:id="R0c07254420bd4750"/>
+      <p:bold xmlns:r="http://schemas.openxmlformats.org/officeDocument/2006/relationships" r:id="Rf622ae5d220c48f3"/>
     </p:embeddedFont>
     <p:embeddedFont>
       <p:font typeface="OpenAI Sans"/>
-      <p:regular xmlns:r="http://schemas.openxmlformats.org/officeDocument/2006/relationships" r:id="R9f48d405c05546de"/>
-      <p:bold xmlns:r="http://schemas.openxmlformats.org/officeDocument/2006/relationships" r:id="R2abaaf7a2c6548d1"/>
-      <p:italic xmlns:r="http://schemas.openxmlformats.org/officeDocument/2006/relationships" r:id="Ra2045c0842ed40ed"/>
-      <p:boldItalic xmlns:r="http://schemas.openxmlformats.org/officeDocument/2006/relationships" r:id="R88ea513927dc44ce"/>
+      <p:regular xmlns:r="http://schemas.openxmlformats.org/officeDocument/2006/relationships" r:id="R14e7ced036f942ff"/>
+      <p:bold xmlns:r="http://schemas.openxmlformats.org/officeDocument/2006/relationships" r:id="R935507ed41044aaa"/>
+      <p:italic xmlns:r="http://schemas.openxmlformats.org/officeDocument/2006/relationships" r:id="R2e45bd2d0eaa473a"/>
+      <p:boldItalic xmlns:r="http://schemas.openxmlformats.org/officeDocument/2006/relationships" r:id="Ree196c46679747df"/>
     </p:embeddedFont>
   </p:embeddedFontLst>
 </p:presentation>
@@ -960,596 +958,6 @@
 </p:notes>
 </file>
 
-<file path=ppt/notesSlides/notesSlide4.xml><?xml version="1.0" encoding="utf-8"?>
-<p:notes xmlns:p="http://schemas.openxmlformats.org/presentationml/2006/main">
-  <p:cSld>
-    <p:spTree>
-      <p:nvGrpSpPr>
-        <p:cNvPr id="1" name=""/>
-        <p:cNvGrpSpPr/>
-        <p:nvPr/>
-      </p:nvGrpSpPr>
-      <p:grpSpPr>
-        <a:xfrm xmlns:a="http://schemas.openxmlformats.org/drawingml/2006/main"/>
-      </p:grpSpPr>
-      <p:sp>
-        <p:nvSpPr>
-          <p:cNvPr id="2" name="Slide Image Placeholder 1"/>
-          <p:cNvSpPr>
-            <a:spLocks xmlns:a="http://schemas.openxmlformats.org/drawingml/2006/main" noGrp="1"/>
-          </p:cNvSpPr>
-          <p:nvPr>
-            <p:ph type="sldImg" idx="0"/>
-          </p:nvPr>
-        </p:nvSpPr>
-        <p:spPr/>
-      </p:sp>
-      <p:sp>
-        <p:nvSpPr>
-          <p:cNvPr id="3" name="Notes Placeholder 2"/>
-          <p:cNvSpPr>
-            <a:spLocks xmlns:a="http://schemas.openxmlformats.org/drawingml/2006/main" noGrp="1"/>
-          </p:cNvSpPr>
-          <p:nvPr>
-            <p:ph type="body" idx="1"/>
-          </p:nvPr>
-        </p:nvSpPr>
-        <p:spPr/>
-        <p:txBody>
-          <a:bodyPr xmlns:a="http://schemas.openxmlformats.org/drawingml/2006/main"/>
-          <a:lstStyle xmlns:a="http://schemas.openxmlformats.org/drawingml/2006/main"/>
-          <a:p xmlns:a="http://schemas.openxmlformats.org/drawingml/2006/main">
-            <a:r>
-              <a:t>Historical snapshot: terrapin-2026-09-16-sales-implementation</a:t>
-            </a:r>
-          </a:p>
-          <a:p xmlns:a="http://schemas.openxmlformats.org/drawingml/2006/main">
-            <a:r>
-              <a:t>Effective: 2026-09-16T09:00:00-05:00</a:t>
-            </a:r>
-          </a:p>
-          <a:p xmlns:a="http://schemas.openxmlformats.org/drawingml/2006/main">
-            <a:r>
-              <a:t>Recorded: 2026-09-16T10:00:00-05:00</a:t>
-            </a:r>
-          </a:p>
-          <a:p xmlns:a="http://schemas.openxmlformats.org/drawingml/2006/main">
-            <a:r>
-              <a:t>Type: sales_to_implementation</a:t>
-            </a:r>
-          </a:p>
-          <a:p xmlns:a="http://schemas.openxmlformats.org/drawingml/2006/main">
-            <a:r>
-              <a:t>Policy: Sales handoff policy. Sales baseline checks structured prerequisites; internal transfers use a separate receiving-team assessment.</a:t>
-            </a:r>
-          </a:p>
-          <a:p xmlns:a="http://schemas.openxmlformats.org/drawingml/2006/main">
-            <a:r>
-              <a:t>These statements and action statuses describe the handoff at this point in time. Later events do not change this snapshot.</a:t>
-            </a:r>
-          </a:p>
-          <a:p xmlns:a="http://schemas.openxmlformats.org/drawingml/2006/main">
-            <a:r>
-              <a:t/>
-            </a:r>
-          </a:p>
-          <a:p xmlns:a="http://schemas.openxmlformats.org/drawingml/2006/main">
-            <a:r>
-              <a:t>[S1] Original source ID: ownership-september</a:t>
-            </a:r>
-          </a:p>
-          <a:p xmlns:a="http://schemas.openxmlformats.org/drawingml/2006/main">
-            <a:r>
-              <a:t>Fictional internal handoff record</a:t>
-            </a:r>
-          </a:p>
-          <a:p xmlns:a="http://schemas.openxmlformats.org/drawingml/2006/main">
-            <a:r>
-              <a:t>Location: snapshots/2026-09-16-ownership.json</a:t>
-            </a:r>
-          </a:p>
-          <a:p xmlns:a="http://schemas.openxmlformats.org/drawingml/2006/main">
-            <a:r>
-              <a:t>Record: mock-ownership-2026-09-16</a:t>
-            </a:r>
-          </a:p>
-          <a:p xmlns:a="http://schemas.openxmlformats.org/drawingml/2006/main">
-            <a:r>
-              <a:t>Date: 2026-09-16</a:t>
-            </a:r>
-          </a:p>
-          <a:p xmlns:a="http://schemas.openxmlformats.org/drawingml/2006/main">
-            <a:r>
-              <a:t>Excerpt: Samson Delilah transfers internal account ownership to Ruben Cherise in Implementation on September 16, 2026.</a:t>
-            </a:r>
-          </a:p>
-          <a:p xmlns:a="http://schemas.openxmlformats.org/drawingml/2006/main">
-            <a:r>
-              <a:t>SHA-256: 3dc5ef097a53439e3b86a5cd1f2921e75c03ca31e38c8a06403113b9bc4b2b7c</a:t>
-            </a:r>
-          </a:p>
-          <a:p xmlns:a="http://schemas.openxmlformats.org/drawingml/2006/main">
-            <a:r>
-              <a:t/>
-            </a:r>
-          </a:p>
-          <a:p xmlns:a="http://schemas.openxmlformats.org/drawingml/2006/main">
-            <a:r>
-              <a:t>[S2] Original source ID: account</a:t>
-            </a:r>
-          </a:p>
-          <a:p xmlns:a="http://schemas.openxmlformats.org/drawingml/2006/main">
-            <a:r>
-              <a:t>CRM snapshot</a:t>
-            </a:r>
-          </a:p>
-          <a:p xmlns:a="http://schemas.openxmlformats.org/drawingml/2006/main">
-            <a:r>
-              <a:t>Location: snapshots/ready/Account.csv</a:t>
-            </a:r>
-          </a:p>
-          <a:p xmlns:a="http://schemas.openxmlformats.org/drawingml/2006/main">
-            <a:r>
-              <a:t>Record: 0015g00002ABCDeAAH</a:t>
-            </a:r>
-          </a:p>
-          <a:p xmlns:a="http://schemas.openxmlformats.org/drawingml/2006/main">
-            <a:r>
-              <a:t>Date: 2026-09-16</a:t>
-            </a:r>
-          </a:p>
-          <a:p xmlns:a="http://schemas.openxmlformats.org/drawingml/2006/main">
-            <a:r>
-              <a:t>Excerpt: Standardize security operations across six acquired venues and improve executive reporting.</a:t>
-            </a:r>
-          </a:p>
-          <a:p xmlns:a="http://schemas.openxmlformats.org/drawingml/2006/main">
-            <a:r>
-              <a:t>SHA-256: 5ab777a31b94d8506b695c60c417068ff154e5a54fcbc480079d131cbb5a3ea0</a:t>
-            </a:r>
-          </a:p>
-          <a:p xmlns:a="http://schemas.openxmlformats.org/drawingml/2006/main">
-            <a:r>
-              <a:t/>
-            </a:r>
-          </a:p>
-          <a:p xmlns:a="http://schemas.openxmlformats.org/drawingml/2006/main">
-            <a:r>
-              <a:t>[S3] Original source ID: opportunity</a:t>
-            </a:r>
-          </a:p>
-          <a:p xmlns:a="http://schemas.openxmlformats.org/drawingml/2006/main">
-            <a:r>
-              <a:t>CRM snapshot</a:t>
-            </a:r>
-          </a:p>
-          <a:p xmlns:a="http://schemas.openxmlformats.org/drawingml/2006/main">
-            <a:r>
-              <a:t>Location: snapshots/ready/Opportunity.csv</a:t>
-            </a:r>
-          </a:p>
-          <a:p xmlns:a="http://schemas.openxmlformats.org/drawingml/2006/main">
-            <a:r>
-              <a:t>Record: 0065g00003OPP001AAH</a:t>
-            </a:r>
-          </a:p>
-          <a:p xmlns:a="http://schemas.openxmlformats.org/drawingml/2006/main">
-            <a:r>
-              <a:t>Date: 2026-09-16</a:t>
-            </a:r>
-          </a:p>
-          <a:p xmlns:a="http://schemas.openxmlformats.org/drawingml/2006/main">
-            <a:r>
-              <a:t>Excerpt: Agreed 2026-09-10: identity-team notice by 2026-09-18; SSO validation 2026-10-02; corporate pilot starts 2026-10-05; venue rollout starts 2026-11-02 and completes 2026-11-30.</a:t>
-            </a:r>
-          </a:p>
-          <a:p xmlns:a="http://schemas.openxmlformats.org/drawingml/2006/main">
-            <a:r>
-              <a:t>SHA-256: a05e8a265a664ea289e796614b9b0ab6c0156f1a4a7f699e4a3250d47f3c0ef1</a:t>
-            </a:r>
-          </a:p>
-          <a:p xmlns:a="http://schemas.openxmlformats.org/drawingml/2006/main">
-            <a:r>
-              <a:t/>
-            </a:r>
-          </a:p>
-          <a:p xmlns:a="http://schemas.openxmlformats.org/drawingml/2006/main">
-            <a:r>
-              <a:t>[S4] Original source ID: confirmation</a:t>
-            </a:r>
-          </a:p>
-          <a:p xmlns:a="http://schemas.openxmlformats.org/drawingml/2006/main">
-            <a:r>
-              <a:t>Sales Notes snapshot</a:t>
-            </a:r>
-          </a:p>
-          <a:p xmlns:a="http://schemas.openxmlformats.org/drawingml/2006/main">
-            <a:r>
-              <a:t>Location: snapshots/ready/SalesNotes.csv</a:t>
-            </a:r>
-          </a:p>
-          <a:p xmlns:a="http://schemas.openxmlformats.org/drawingml/2006/main">
-            <a:r>
-              <a:t>Record: a0N5g00001NOTE04AAH</a:t>
-            </a:r>
-          </a:p>
-          <a:p xmlns:a="http://schemas.openxmlformats.org/drawingml/2006/main">
-            <a:r>
-              <a:t>Date: 2026-09-10</a:t>
-            </a:r>
-          </a:p>
-          <a:p xmlns:a="http://schemas.openxmlformats.org/drawingml/2006/main">
-            <a:r>
-              <a:t>Excerpt: Scarlet explicitly accepted executive sponsorship and will resolve cross-team escalations. Casey remains technical owner. Scarlet, Casey, and the Wall of Sound implementation lead agreed the rollout plan and planning-support scope: Casey sends identity-team notice by 2026-09-18, providing at least two weeks before SSO validation on 2026-10-02. Corporate pilot begins 2026-10-05; venue rollout begins 2026-11-02 and finishes 2026-11-30. SSO must pass before broad rollout. They agreed that by 2026-11-30 all six venues will report to one dashboard and at least 95% of priority alerts will appear within 15 minutes. By 2026-12-18 mean investigation time must be at most 42 minutes against the agreed 60-minute baseline. The implementation lead accepted initial rollout-planning assistance. Casey will schedule kickoff by 2026-09-17. These specific agreements resolve the open timeline and success-metric questions in the earlier notes.</a:t>
-            </a:r>
-          </a:p>
-          <a:p xmlns:a="http://schemas.openxmlformats.org/drawingml/2006/main">
-            <a:r>
-              <a:t>SHA-256: 172565c494ad895dc163b4f56ac440e6fbe8ce1c7bad2143f516af8b5602bfee</a:t>
-            </a:r>
-          </a:p>
-          <a:p xmlns:a="http://schemas.openxmlformats.org/drawingml/2006/main">
-            <a:r>
-              <a:t/>
-            </a:r>
-          </a:p>
-          <a:p xmlns:a="http://schemas.openxmlformats.org/drawingml/2006/main">
-            <a:r>
-              <a:t>[S5] Original source ID: contact-scarlet</a:t>
-            </a:r>
-          </a:p>
-          <a:p xmlns:a="http://schemas.openxmlformats.org/drawingml/2006/main">
-            <a:r>
-              <a:t>CRM snapshot</a:t>
-            </a:r>
-          </a:p>
-          <a:p xmlns:a="http://schemas.openxmlformats.org/drawingml/2006/main">
-            <a:r>
-              <a:t>Location: snapshots/ready/Contact.csv</a:t>
-            </a:r>
-          </a:p>
-          <a:p xmlns:a="http://schemas.openxmlformats.org/drawingml/2006/main">
-            <a:r>
-              <a:t>Record: 0035g00004CON001AAH</a:t>
-            </a:r>
-          </a:p>
-          <a:p xmlns:a="http://schemas.openxmlformats.org/drawingml/2006/main">
-            <a:r>
-              <a:t>Date: 2026-09-16</a:t>
-            </a:r>
-          </a:p>
-          <a:p xmlns:a="http://schemas.openxmlformats.org/drawingml/2006/main">
-            <a:r>
-              <a:t>Excerpt: Scarlet Begonia — VP, Information Security</a:t>
-            </a:r>
-          </a:p>
-          <a:p xmlns:a="http://schemas.openxmlformats.org/drawingml/2006/main">
-            <a:r>
-              <a:t>SHA-256: 11a3a3a9232cfe856976172d0cf58155b7bf25004af587734a8c330bf2994e5a</a:t>
-            </a:r>
-          </a:p>
-          <a:p xmlns:a="http://schemas.openxmlformats.org/drawingml/2006/main">
-            <a:r>
-              <a:t/>
-            </a:r>
-          </a:p>
-          <a:p xmlns:a="http://schemas.openxmlformats.org/drawingml/2006/main">
-            <a:r>
-              <a:t>[S6] Original source ID: contact-casey</a:t>
-            </a:r>
-          </a:p>
-          <a:p xmlns:a="http://schemas.openxmlformats.org/drawingml/2006/main">
-            <a:r>
-              <a:t>CRM snapshot</a:t>
-            </a:r>
-          </a:p>
-          <a:p xmlns:a="http://schemas.openxmlformats.org/drawingml/2006/main">
-            <a:r>
-              <a:t>Location: snapshots/ready/Contact.csv</a:t>
-            </a:r>
-          </a:p>
-          <a:p xmlns:a="http://schemas.openxmlformats.org/drawingml/2006/main">
-            <a:r>
-              <a:t>Record: 0035g00004CON002AAH</a:t>
-            </a:r>
-          </a:p>
-          <a:p xmlns:a="http://schemas.openxmlformats.org/drawingml/2006/main">
-            <a:r>
-              <a:t>Date: 2026-09-16</a:t>
-            </a:r>
-          </a:p>
-          <a:p xmlns:a="http://schemas.openxmlformats.org/drawingml/2006/main">
-            <a:r>
-              <a:t>Excerpt: Casey Jones — Director, Security Engineering</a:t>
-            </a:r>
-          </a:p>
-          <a:p xmlns:a="http://schemas.openxmlformats.org/drawingml/2006/main">
-            <a:r>
-              <a:t>SHA-256: 11a3a3a9232cfe856976172d0cf58155b7bf25004af587734a8c330bf2994e5a</a:t>
-            </a:r>
-          </a:p>
-          <a:p xmlns:a="http://schemas.openxmlformats.org/drawingml/2006/main">
-            <a:r>
-              <a:t/>
-            </a:r>
-          </a:p>
-          <a:p xmlns:a="http://schemas.openxmlformats.org/drawingml/2006/main">
-            <a:r>
-              <a:t>[S7] Original source ID: contact-jack</a:t>
-            </a:r>
-          </a:p>
-          <a:p xmlns:a="http://schemas.openxmlformats.org/drawingml/2006/main">
-            <a:r>
-              <a:t>CRM snapshot</a:t>
-            </a:r>
-          </a:p>
-          <a:p xmlns:a="http://schemas.openxmlformats.org/drawingml/2006/main">
-            <a:r>
-              <a:t>Location: snapshots/ready/Contact.csv</a:t>
-            </a:r>
-          </a:p>
-          <a:p xmlns:a="http://schemas.openxmlformats.org/drawingml/2006/main">
-            <a:r>
-              <a:t>Record: 0035g00004CON003AAH</a:t>
-            </a:r>
-          </a:p>
-          <a:p xmlns:a="http://schemas.openxmlformats.org/drawingml/2006/main">
-            <a:r>
-              <a:t>Date: 2026-09-16</a:t>
-            </a:r>
-          </a:p>
-          <a:p xmlns:a="http://schemas.openxmlformats.org/drawingml/2006/main">
-            <a:r>
-              <a:t>Excerpt: Jack Straw — Procurement Manager</a:t>
-            </a:r>
-          </a:p>
-          <a:p xmlns:a="http://schemas.openxmlformats.org/drawingml/2006/main">
-            <a:r>
-              <a:t>SHA-256: 11a3a3a9232cfe856976172d0cf58155b7bf25004af587734a8c330bf2994e5a</a:t>
-            </a:r>
-          </a:p>
-        </p:txBody>
-      </p:sp>
-      <p:sp>
-        <p:nvSpPr>
-          <p:cNvPr id="4" name="Slide Number Placeholder 3"/>
-          <p:cNvSpPr>
-            <a:spLocks xmlns:a="http://schemas.openxmlformats.org/drawingml/2006/main" noGrp="1"/>
-          </p:cNvSpPr>
-          <p:nvPr>
-            <p:ph type="sldNum" idx="5"/>
-          </p:nvPr>
-        </p:nvSpPr>
-        <p:spPr/>
-        <p:txBody>
-          <a:bodyPr xmlns:a="http://schemas.openxmlformats.org/drawingml/2006/main"/>
-          <a:lstStyle xmlns:a="http://schemas.openxmlformats.org/drawingml/2006/main"/>
-          <a:p xmlns:a="http://schemas.openxmlformats.org/drawingml/2006/main"/>
-        </p:txBody>
-      </p:sp>
-    </p:spTree>
-  </p:cSld>
-  <p:clrMapOvr>
-    <a:masterClrMapping xmlns:a="http://schemas.openxmlformats.org/drawingml/2006/main"/>
-  </p:clrMapOvr>
-</p:notes>
-</file>
-
-<file path=ppt/notesSlides/notesSlide5.xml><?xml version="1.0" encoding="utf-8"?>
-<p:notes xmlns:p="http://schemas.openxmlformats.org/presentationml/2006/main">
-  <p:cSld>
-    <p:spTree>
-      <p:nvGrpSpPr>
-        <p:cNvPr id="1" name=""/>
-        <p:cNvGrpSpPr/>
-        <p:nvPr/>
-      </p:nvGrpSpPr>
-      <p:grpSpPr>
-        <a:xfrm xmlns:a="http://schemas.openxmlformats.org/drawingml/2006/main"/>
-      </p:grpSpPr>
-      <p:sp>
-        <p:nvSpPr>
-          <p:cNvPr id="2" name="Slide Image Placeholder 1"/>
-          <p:cNvSpPr>
-            <a:spLocks xmlns:a="http://schemas.openxmlformats.org/drawingml/2006/main" noGrp="1"/>
-          </p:cNvSpPr>
-          <p:nvPr>
-            <p:ph type="sldImg" idx="0"/>
-          </p:nvPr>
-        </p:nvSpPr>
-        <p:spPr/>
-      </p:sp>
-      <p:sp>
-        <p:nvSpPr>
-          <p:cNvPr id="3" name="Notes Placeholder 2"/>
-          <p:cNvSpPr>
-            <a:spLocks xmlns:a="http://schemas.openxmlformats.org/drawingml/2006/main" noGrp="1"/>
-          </p:cNvSpPr>
-          <p:nvPr>
-            <p:ph type="body" idx="1"/>
-          </p:nvPr>
-        </p:nvSpPr>
-        <p:spPr/>
-        <p:txBody>
-          <a:bodyPr xmlns:a="http://schemas.openxmlformats.org/drawingml/2006/main"/>
-          <a:lstStyle xmlns:a="http://schemas.openxmlformats.org/drawingml/2006/main"/>
-          <a:p xmlns:a="http://schemas.openxmlformats.org/drawingml/2006/main">
-            <a:r>
-              <a:t>Historical snapshot: terrapin-2026-12-01-implementation-cs</a:t>
-            </a:r>
-          </a:p>
-          <a:p xmlns:a="http://schemas.openxmlformats.org/drawingml/2006/main">
-            <a:r>
-              <a:t>Effective: 2026-12-01T09:00:00-06:00</a:t>
-            </a:r>
-          </a:p>
-          <a:p xmlns:a="http://schemas.openxmlformats.org/drawingml/2006/main">
-            <a:r>
-              <a:t>Recorded: 2026-12-01T10:00:00-06:00</a:t>
-            </a:r>
-          </a:p>
-          <a:p xmlns:a="http://schemas.openxmlformats.org/drawingml/2006/main">
-            <a:r>
-              <a:t>Type: internal_transfer</a:t>
-            </a:r>
-          </a:p>
-          <a:p xmlns:a="http://schemas.openxmlformats.org/drawingml/2006/main">
-            <a:r>
-              <a:t>Policy: Internal transfer policy. Sales baseline checks structured prerequisites; internal transfers use a separate receiving-team assessment.</a:t>
-            </a:r>
-          </a:p>
-          <a:p xmlns:a="http://schemas.openxmlformats.org/drawingml/2006/main">
-            <a:r>
-              <a:t>These statements and action statuses describe the handoff at this point in time. Later events do not change this snapshot.</a:t>
-            </a:r>
-          </a:p>
-          <a:p xmlns:a="http://schemas.openxmlformats.org/drawingml/2006/main">
-            <a:r>
-              <a:t/>
-            </a:r>
-          </a:p>
-          <a:p xmlns:a="http://schemas.openxmlformats.org/drawingml/2006/main">
-            <a:r>
-              <a:t>[S1] Original source ID: ownership-december</a:t>
-            </a:r>
-          </a:p>
-          <a:p xmlns:a="http://schemas.openxmlformats.org/drawingml/2006/main">
-            <a:r>
-              <a:t>Fictional internal handoff record</a:t>
-            </a:r>
-          </a:p>
-          <a:p xmlns:a="http://schemas.openxmlformats.org/drawingml/2006/main">
-            <a:r>
-              <a:t>Location: snapshots/2026-12-01-implementation-transfer.json</a:t>
-            </a:r>
-          </a:p>
-          <a:p xmlns:a="http://schemas.openxmlformats.org/drawingml/2006/main">
-            <a:r>
-              <a:t>Record: mock-ownership-2026-12-01</a:t>
-            </a:r>
-          </a:p>
-          <a:p xmlns:a="http://schemas.openxmlformats.org/drawingml/2006/main">
-            <a:r>
-              <a:t>Date: 2026-12-01</a:t>
-            </a:r>
-          </a:p>
-          <a:p xmlns:a="http://schemas.openxmlformats.org/drawingml/2006/main">
-            <a:r>
-              <a:t>Excerpt: The November 30 implementation review confirms all six venues reporting and 96% of priority alerts within 15 minutes. The December 18 investigation-time target remains due. Training and QBR dates are Not Confirmed.</a:t>
-            </a:r>
-          </a:p>
-          <a:p xmlns:a="http://schemas.openxmlformats.org/drawingml/2006/main">
-            <a:r>
-              <a:t>SHA-256: 918fbd3434dd6572e0b8b6952e4fa410f023669bf7526e2b63c739673803f6f1</a:t>
-            </a:r>
-          </a:p>
-          <a:p xmlns:a="http://schemas.openxmlformats.org/drawingml/2006/main">
-            <a:r>
-              <a:t/>
-            </a:r>
-          </a:p>
-          <a:p xmlns:a="http://schemas.openxmlformats.org/drawingml/2006/main">
-            <a:r>
-              <a:t>[S2] Original source ID: account</a:t>
-            </a:r>
-          </a:p>
-          <a:p xmlns:a="http://schemas.openxmlformats.org/drawingml/2006/main">
-            <a:r>
-              <a:t>CRM snapshot</a:t>
-            </a:r>
-          </a:p>
-          <a:p xmlns:a="http://schemas.openxmlformats.org/drawingml/2006/main">
-            <a:r>
-              <a:t>Location: snapshots/ready/Account.csv</a:t>
-            </a:r>
-          </a:p>
-          <a:p xmlns:a="http://schemas.openxmlformats.org/drawingml/2006/main">
-            <a:r>
-              <a:t>Record: 0015g00002ABCDeAAH</a:t>
-            </a:r>
-          </a:p>
-          <a:p xmlns:a="http://schemas.openxmlformats.org/drawingml/2006/main">
-            <a:r>
-              <a:t>Date: 2026-09-16</a:t>
-            </a:r>
-          </a:p>
-          <a:p xmlns:a="http://schemas.openxmlformats.org/drawingml/2006/main">
-            <a:r>
-              <a:t>Excerpt: Standardize security operations across six acquired venues and improve executive reporting.</a:t>
-            </a:r>
-          </a:p>
-          <a:p xmlns:a="http://schemas.openxmlformats.org/drawingml/2006/main">
-            <a:r>
-              <a:t>SHA-256: 5ab777a31b94d8506b695c60c417068ff154e5a54fcbc480079d131cbb5a3ea0</a:t>
-            </a:r>
-          </a:p>
-          <a:p xmlns:a="http://schemas.openxmlformats.org/drawingml/2006/main">
-            <a:r>
-              <a:t/>
-            </a:r>
-          </a:p>
-          <a:p xmlns:a="http://schemas.openxmlformats.org/drawingml/2006/main">
-            <a:r>
-              <a:t>[S3] Original source ID: confirmation</a:t>
-            </a:r>
-          </a:p>
-          <a:p xmlns:a="http://schemas.openxmlformats.org/drawingml/2006/main">
-            <a:r>
-              <a:t>Sales Notes snapshot</a:t>
-            </a:r>
-          </a:p>
-          <a:p xmlns:a="http://schemas.openxmlformats.org/drawingml/2006/main">
-            <a:r>
-              <a:t>Location: snapshots/ready/SalesNotes.csv</a:t>
-            </a:r>
-          </a:p>
-          <a:p xmlns:a="http://schemas.openxmlformats.org/drawingml/2006/main">
-            <a:r>
-              <a:t>Record: a0N5g00001NOTE04AAH</a:t>
-            </a:r>
-          </a:p>
-          <a:p xmlns:a="http://schemas.openxmlformats.org/drawingml/2006/main">
-            <a:r>
-              <a:t>Date: 2026-09-10</a:t>
-            </a:r>
-          </a:p>
-          <a:p xmlns:a="http://schemas.openxmlformats.org/drawingml/2006/main">
-            <a:r>
-              <a:t>Excerpt: Scarlet explicitly accepted executive sponsorship and will resolve cross-team escalations. Casey remains technical owner. Scarlet, Casey, and the Wall of Sound implementation lead agreed the rollout plan and planning-support scope: Casey sends identity-team notice by 2026-09-18, providing at least two weeks before SSO validation on 2026-10-02. Corporate pilot begins 2026-10-05; venue rollout begins 2026-11-02 and finishes 2026-11-30. SSO must pass before broad rollout. They agreed that by 2026-11-30 all six venues will report to one dashboard and at least 95% of priority alerts will appear within 15 minutes. By 2026-12-18 mean investigation time must be at most 42 minutes against the agreed 60-minute baseline. The implementation lead accepted initial rollout-planning assistance. Casey will schedule kickoff by 2026-09-17. These specific agreements resolve the open timeline and success-metric questions in the earlier notes.</a:t>
-            </a:r>
-          </a:p>
-          <a:p xmlns:a="http://schemas.openxmlformats.org/drawingml/2006/main">
-            <a:r>
-              <a:t>SHA-256: 172565c494ad895dc163b4f56ac440e6fbe8ce1c7bad2143f516af8b5602bfee</a:t>
-            </a:r>
-          </a:p>
-        </p:txBody>
-      </p:sp>
-      <p:sp>
-        <p:nvSpPr>
-          <p:cNvPr id="4" name="Slide Number Placeholder 3"/>
-          <p:cNvSpPr>
-            <a:spLocks xmlns:a="http://schemas.openxmlformats.org/drawingml/2006/main" noGrp="1"/>
-          </p:cNvSpPr>
-          <p:nvPr>
-            <p:ph type="sldNum" idx="5"/>
-          </p:nvPr>
-        </p:nvSpPr>
-        <p:spPr/>
-        <p:txBody>
-          <a:bodyPr xmlns:a="http://schemas.openxmlformats.org/drawingml/2006/main"/>
-          <a:lstStyle xmlns:a="http://schemas.openxmlformats.org/drawingml/2006/main"/>
-          <a:p xmlns:a="http://schemas.openxmlformats.org/drawingml/2006/main"/>
-        </p:txBody>
-      </p:sp>
-    </p:spTree>
-  </p:cSld>
-  <p:clrMapOvr>
-    <a:masterClrMapping xmlns:a="http://schemas.openxmlformats.org/drawingml/2006/main"/>
-  </p:clrMapOvr>
-</p:notes>
-</file>
-
 <file path=ppt/slideLayouts/slideLayout1.xml><?xml version="1.0" encoding="utf-8"?>
 <p:sldLayout xmlns:p="http://schemas.openxmlformats.org/presentationml/2006/main" preserve="1" userDrawn="1">
   <p:cSld name="Title Slide">
@@ -3405,14 +2813,14 @@
   </p:cSld>
   <p:clrMap bg1="dk1" tx1="lt1" bg2="dk2" tx2="lt2" accent1="accent1" accent2="accent2" accent3="accent3" accent4="accent4" accent5="accent5" accent6="accent6" hlink="hlink" folHlink="folHlink"/>
   <p:sldLayoutIdLst>
-    <p:sldLayoutId xmlns:r="http://schemas.openxmlformats.org/officeDocument/2006/relationships" id="2147483649" r:id="R888bb6564b874c98"/>
-    <p:sldLayoutId xmlns:r="http://schemas.openxmlformats.org/officeDocument/2006/relationships" id="2147483650" r:id="R86f21672137e4594"/>
-    <p:sldLayoutId xmlns:r="http://schemas.openxmlformats.org/officeDocument/2006/relationships" id="2147483651" r:id="R04339ae8cda044c4"/>
-    <p:sldLayoutId xmlns:r="http://schemas.openxmlformats.org/officeDocument/2006/relationships" id="2147483652" r:id="R59a8ea6da2914779"/>
-    <p:sldLayoutId xmlns:r="http://schemas.openxmlformats.org/officeDocument/2006/relationships" id="2147483653" r:id="Rb57fb7d86daa491a"/>
-    <p:sldLayoutId xmlns:r="http://schemas.openxmlformats.org/officeDocument/2006/relationships" id="2147483654" r:id="R11a8b89272094137"/>
-    <p:sldLayoutId xmlns:r="http://schemas.openxmlformats.org/officeDocument/2006/relationships" id="2147483655" r:id="R03be1c9eef644f75"/>
-    <p:sldLayoutId xmlns:r="http://schemas.openxmlformats.org/officeDocument/2006/relationships" id="2147483656" r:id="Rd4373067204f4640"/>
+    <p:sldLayoutId xmlns:r="http://schemas.openxmlformats.org/officeDocument/2006/relationships" id="2147483649" r:id="R3c1948d917ce4d8f"/>
+    <p:sldLayoutId xmlns:r="http://schemas.openxmlformats.org/officeDocument/2006/relationships" id="2147483650" r:id="R913beff9e0ef4d43"/>
+    <p:sldLayoutId xmlns:r="http://schemas.openxmlformats.org/officeDocument/2006/relationships" id="2147483651" r:id="R177a0562702447cf"/>
+    <p:sldLayoutId xmlns:r="http://schemas.openxmlformats.org/officeDocument/2006/relationships" id="2147483652" r:id="R01dfaf79d0404a24"/>
+    <p:sldLayoutId xmlns:r="http://schemas.openxmlformats.org/officeDocument/2006/relationships" id="2147483653" r:id="R048d74bea44444a7"/>
+    <p:sldLayoutId xmlns:r="http://schemas.openxmlformats.org/officeDocument/2006/relationships" id="2147483654" r:id="R4773f2df73b84f8c"/>
+    <p:sldLayoutId xmlns:r="http://schemas.openxmlformats.org/officeDocument/2006/relationships" id="2147483655" r:id="Rff24395f4aa54f56"/>
+    <p:sldLayoutId xmlns:r="http://schemas.openxmlformats.org/officeDocument/2006/relationships" id="2147483656" r:id="Rd4ef1987da2247b6"/>
   </p:sldLayoutIdLst>
   <p:hf hdr="0" dt="0"/>
   <p:txStyles>
@@ -4062,10 +3470,10 @@
       </p:grpSpPr>
       <p:sp>
         <p:nvSpPr>
-          <p:cNvPr id="11" name="">
-            <a:extLst xmlns:a="http://schemas.openxmlformats.org/drawingml/2006/main">
-              <a:ext uri="{FF2B5EF4-FFF2-40B4-BE49-F238E27FC236}">
-                <a16:creationId xmlns:a16="http://schemas.microsoft.com/office/drawing/2014/main" id="{8A019B86-DF3C-4AFC-90C7-CE56D800BAF4}"/>
+          <p:cNvPr id="14" name="">
+            <a:extLst xmlns:a="http://schemas.openxmlformats.org/drawingml/2006/main">
+              <a:ext uri="{FF2B5EF4-FFF2-40B4-BE49-F238E27FC236}">
+                <a16:creationId xmlns:a16="http://schemas.microsoft.com/office/drawing/2014/main" id="{613F8D2E-D035-4810-92EF-179EA3A91FC5}"/>
               </a:ext>
             </a:extLst>
           </p:cNvPr>
@@ -4111,7 +3519,7 @@
               </a:defRPr>
             </a:pPr>
             <a:r>
-              <a:t>CURRENT ACCOUNT RECORD</a:t>
+              <a:t>ACCOUNT HANDOFF SUMMARY</a:t>
             </a:r>
           </a:p>
         </p:txBody>
@@ -4121,7 +3529,7 @@
           <p:cNvPr id="2" name="">
             <a:extLst xmlns:a="http://schemas.openxmlformats.org/drawingml/2006/main">
               <a:ext uri="{FF2B5EF4-FFF2-40B4-BE49-F238E27FC236}">
-                <a16:creationId xmlns:a16="http://schemas.microsoft.com/office/drawing/2014/main" id="{6AF60F12-7E3A-4DE5-A2EA-DF5998F8C8A9}"/>
+                <a16:creationId xmlns:a16="http://schemas.microsoft.com/office/drawing/2014/main" id="{95C2AC2E-C931-4DE3-ACF3-2EC4452B0574}"/>
               </a:ext>
             </a:extLst>
           </p:cNvPr>
@@ -4177,7 +3585,7 @@
           <p:cNvPr id="3" name="">
             <a:extLst xmlns:a="http://schemas.openxmlformats.org/drawingml/2006/main">
               <a:ext uri="{FF2B5EF4-FFF2-40B4-BE49-F238E27FC236}">
-                <a16:creationId xmlns:a16="http://schemas.microsoft.com/office/drawing/2014/main" id="{80C35C78-69CA-4A14-B08E-065BF3FD6607}"/>
+                <a16:creationId xmlns:a16="http://schemas.microsoft.com/office/drawing/2014/main" id="{D9D4C6BB-3D77-4281-AAAF-A68402EBA7D8}"/>
               </a:ext>
             </a:extLst>
           </p:cNvPr>
@@ -4233,7 +3641,7 @@
           <p:cNvPr id="4" name="">
             <a:extLst xmlns:a="http://schemas.openxmlformats.org/drawingml/2006/main">
               <a:ext uri="{FF2B5EF4-FFF2-40B4-BE49-F238E27FC236}">
-                <a16:creationId xmlns:a16="http://schemas.microsoft.com/office/drawing/2014/main" id="{46492C1F-73FB-4327-A978-6A424C1D6E37}"/>
+                <a16:creationId xmlns:a16="http://schemas.microsoft.com/office/drawing/2014/main" id="{F9903640-89A2-4D03-85D1-4A278B7337C9}"/>
               </a:ext>
             </a:extLst>
           </p:cNvPr>
@@ -4289,7 +3697,7 @@
           <p:cNvPr id="5" name="">
             <a:extLst xmlns:a="http://schemas.openxmlformats.org/drawingml/2006/main">
               <a:ext uri="{FF2B5EF4-FFF2-40B4-BE49-F238E27FC236}">
-                <a16:creationId xmlns:a16="http://schemas.microsoft.com/office/drawing/2014/main" id="{A6376D8D-07C6-48AA-9CA0-02131CCF15F3}"/>
+                <a16:creationId xmlns:a16="http://schemas.microsoft.com/office/drawing/2014/main" id="{09673A81-6F14-41A9-AEF9-73CB3B84B38D}"/>
               </a:ext>
             </a:extLst>
           </p:cNvPr>
@@ -4300,7 +3708,7 @@
         </p:nvSpPr>
         <p:spPr>
           <a:xfrm xmlns:a="http://schemas.openxmlformats.org/drawingml/2006/main">
-            <a:off x="666750" y="2476500"/>
+            <a:off x="666750" y="2286000"/>
             <a:ext cx="4667250" cy="619125"/>
           </a:xfrm>
           <a:prstGeom xmlns:a="http://schemas.openxmlformats.org/drawingml/2006/main" prst="rect">
@@ -4345,7 +3753,7 @@
           <p:cNvPr id="6" name="">
             <a:extLst xmlns:a="http://schemas.openxmlformats.org/drawingml/2006/main">
               <a:ext uri="{FF2B5EF4-FFF2-40B4-BE49-F238E27FC236}">
-                <a16:creationId xmlns:a16="http://schemas.microsoft.com/office/drawing/2014/main" id="{46B53981-8960-4637-95E1-D256E7A88348}"/>
+                <a16:creationId xmlns:a16="http://schemas.microsoft.com/office/drawing/2014/main" id="{BAED2D03-E2BD-47F0-88B0-BF18242559EE}"/>
               </a:ext>
             </a:extLst>
           </p:cNvPr>
@@ -4356,86 +3764,8 @@
         </p:nvSpPr>
         <p:spPr>
           <a:xfrm xmlns:a="http://schemas.openxmlformats.org/drawingml/2006/main">
-            <a:off x="666750" y="3333750"/>
-            <a:ext cx="7239000" cy="1714500"/>
-          </a:xfrm>
-          <a:prstGeom xmlns:a="http://schemas.openxmlformats.org/drawingml/2006/main" prst="rect">
-            <a:avLst/>
-          </a:prstGeom>
-          <a:noFill xmlns:a="http://schemas.openxmlformats.org/drawingml/2006/main"/>
-          <a:ln xmlns:a="http://schemas.openxmlformats.org/drawingml/2006/main" w="0">
-            <a:noFill/>
-          </a:ln>
-        </p:spPr>
-        <p:txBody>
-          <a:bodyPr xmlns:a="http://schemas.openxmlformats.org/drawingml/2006/main" lIns="0" tIns="0" rIns="0" bIns="0" anchor="t">
-            <a:normAutofit fontScale="100000"/>
-          </a:bodyPr>
-          <a:lstStyle xmlns:a="http://schemas.openxmlformats.org/drawingml/2006/main"/>
-          <a:p xmlns:a="http://schemas.openxmlformats.org/drawingml/2006/main">
-            <a:pPr marL="0" indent="0" algn="l">
-              <a:spcBef>
-                <a:spcPts val="0"/>
-              </a:spcBef>
-              <a:spcAft>
-                <a:spcPts val="0"/>
-              </a:spcAft>
-              <a:buNone/>
-              <a:defRPr sz="1800">
-                <a:solidFill>
-                  <a:srgbClr val="FFFFFF"/>
-                </a:solidFill>
-                <a:latin typeface="Inter"/>
-                <a:ea typeface="Inter"/>
-                <a:cs typeface="Inter"/>
-              </a:defRPr>
-            </a:pPr>
-            <a:r>
-              <a:t>Latest recorded state</a:t>
-            </a:r>
-          </a:p>
-          <a:p xmlns:a="http://schemas.openxmlformats.org/drawingml/2006/main">
-            <a:pPr marL="0" indent="0" algn="l">
-              <a:spcBef>
-                <a:spcPts val="0"/>
-              </a:spcBef>
-              <a:spcAft>
-                <a:spcPts val="0"/>
-              </a:spcAft>
-              <a:buNone/>
-              <a:defRPr sz="1800">
-                <a:solidFill>
-                  <a:srgbClr val="FFFFFF"/>
-                </a:solidFill>
-                <a:latin typeface="Inter"/>
-                <a:ea typeface="Inter"/>
-                <a:cs typeface="Inter"/>
-              </a:defRPr>
-            </a:pPr>
-            <a:r>
-              <a:t>Six venues are reporting and 96% of priority alerts arrive within 15 minutes. Training and QBR dates remain unconfirmed; the Dec 18 goal remains open. [S1, S3]</a:t>
-            </a:r>
-          </a:p>
-        </p:txBody>
-      </p:sp>
-      <p:sp>
-        <p:nvSpPr>
-          <p:cNvPr id="7" name="">
-            <a:extLst xmlns:a="http://schemas.openxmlformats.org/drawingml/2006/main">
-              <a:ext uri="{FF2B5EF4-FFF2-40B4-BE49-F238E27FC236}">
-                <a16:creationId xmlns:a16="http://schemas.microsoft.com/office/drawing/2014/main" id="{B2A7057F-59C9-4569-A94B-39AE079D65EF}"/>
-              </a:ext>
-            </a:extLst>
-          </p:cNvPr>
-          <p:cNvSpPr>
-            <a:spLocks xmlns:a="http://schemas.openxmlformats.org/drawingml/2006/main" noGrp="1"/>
-          </p:cNvSpPr>
-          <p:nvPr/>
-        </p:nvSpPr>
-        <p:spPr>
-          <a:xfrm xmlns:a="http://schemas.openxmlformats.org/drawingml/2006/main">
-            <a:off x="8429625" y="2571750"/>
-            <a:ext cx="2476500" cy="247650"/>
+            <a:off x="666750" y="3238500"/>
+            <a:ext cx="4191000" cy="247650"/>
           </a:xfrm>
           <a:prstGeom xmlns:a="http://schemas.openxmlformats.org/drawingml/2006/main" prst="rect">
             <a:avLst/>
@@ -4469,17 +3799,17 @@
               </a:defRPr>
             </a:pPr>
             <a:r>
-              <a:t>ACCOUNT OWNER</a:t>
-            </a:r>
-          </a:p>
-        </p:txBody>
-      </p:sp>
-      <p:sp>
-        <p:nvSpPr>
-          <p:cNvPr id="8" name="">
-            <a:extLst xmlns:a="http://schemas.openxmlformats.org/drawingml/2006/main">
-              <a:ext uri="{FF2B5EF4-FFF2-40B4-BE49-F238E27FC236}">
-                <a16:creationId xmlns:a16="http://schemas.microsoft.com/office/drawing/2014/main" id="{CC10BBEA-3B92-469B-A184-B0989C92812F}"/>
+              <a:t>CURRENT OWNER</a:t>
+            </a:r>
+          </a:p>
+        </p:txBody>
+      </p:sp>
+      <p:sp>
+        <p:nvSpPr>
+          <p:cNvPr id="7" name="">
+            <a:extLst xmlns:a="http://schemas.openxmlformats.org/drawingml/2006/main">
+              <a:ext uri="{FF2B5EF4-FFF2-40B4-BE49-F238E27FC236}">
+                <a16:creationId xmlns:a16="http://schemas.microsoft.com/office/drawing/2014/main" id="{27367809-FADF-466E-85EF-9EC0557FD197}"/>
               </a:ext>
             </a:extLst>
           </p:cNvPr>
@@ -4490,8 +3820,8 @@
         </p:nvSpPr>
         <p:spPr>
           <a:xfrm xmlns:a="http://schemas.openxmlformats.org/drawingml/2006/main">
-            <a:off x="8429625" y="2905125"/>
-            <a:ext cx="2476500" cy="904875"/>
+            <a:off x="666750" y="3571875"/>
+            <a:ext cx="4191000" cy="619125"/>
           </a:xfrm>
           <a:prstGeom xmlns:a="http://schemas.openxmlformats.org/drawingml/2006/main" prst="rect">
             <a:avLst/>
@@ -4532,10 +3862,10 @@
       </p:sp>
       <p:sp>
         <p:nvSpPr>
-          <p:cNvPr id="9" name="">
-            <a:extLst xmlns:a="http://schemas.openxmlformats.org/drawingml/2006/main">
-              <a:ext uri="{FF2B5EF4-FFF2-40B4-BE49-F238E27FC236}">
-                <a16:creationId xmlns:a16="http://schemas.microsoft.com/office/drawing/2014/main" id="{ACB30E37-5722-4164-95A5-433BEDCB21A3}"/>
+          <p:cNvPr id="8" name="">
+            <a:extLst xmlns:a="http://schemas.openxmlformats.org/drawingml/2006/main">
+              <a:ext uri="{FF2B5EF4-FFF2-40B4-BE49-F238E27FC236}">
+                <a16:creationId xmlns:a16="http://schemas.microsoft.com/office/drawing/2014/main" id="{B9EC8408-CB75-4791-B1B3-DB96BBD2BBF9}"/>
               </a:ext>
             </a:extLst>
           </p:cNvPr>
@@ -4546,8 +3876,8 @@
         </p:nvSpPr>
         <p:spPr>
           <a:xfrm xmlns:a="http://schemas.openxmlformats.org/drawingml/2006/main">
-            <a:off x="8429625" y="4191000"/>
-            <a:ext cx="2476500" cy="247650"/>
+            <a:off x="666750" y="4619625"/>
+            <a:ext cx="4191000" cy="247650"/>
           </a:xfrm>
           <a:prstGeom xmlns:a="http://schemas.openxmlformats.org/drawingml/2006/main" prst="rect">
             <a:avLst/>
@@ -4588,10 +3918,10 @@
       </p:sp>
       <p:sp>
         <p:nvSpPr>
-          <p:cNvPr id="10" name="">
-            <a:extLst xmlns:a="http://schemas.openxmlformats.org/drawingml/2006/main">
-              <a:ext uri="{FF2B5EF4-FFF2-40B4-BE49-F238E27FC236}">
-                <a16:creationId xmlns:a16="http://schemas.microsoft.com/office/drawing/2014/main" id="{CCC37855-2F05-495B-96EF-6E48D171963F}"/>
+          <p:cNvPr id="9" name="">
+            <a:extLst xmlns:a="http://schemas.openxmlformats.org/drawingml/2006/main">
+              <a:ext uri="{FF2B5EF4-FFF2-40B4-BE49-F238E27FC236}">
+                <a16:creationId xmlns:a16="http://schemas.microsoft.com/office/drawing/2014/main" id="{01D12358-E1CA-481B-B23B-DE6EDDCE24A2}"/>
               </a:ext>
             </a:extLst>
           </p:cNvPr>
@@ -4602,8 +3932,8 @@
         </p:nvSpPr>
         <p:spPr>
           <a:xfrm xmlns:a="http://schemas.openxmlformats.org/drawingml/2006/main">
-            <a:off x="8429625" y="4524375"/>
-            <a:ext cx="2476500" cy="809625"/>
+            <a:off x="666750" y="4953000"/>
+            <a:ext cx="4191000" cy="619125"/>
           </a:xfrm>
           <a:prstGeom xmlns:a="http://schemas.openxmlformats.org/drawingml/2006/main" prst="rect">
             <a:avLst/>
@@ -4660,6 +3990,274 @@
             </a:pPr>
             <a:r>
               <a:t>2026-12-01 [S1]</a:t>
+            </a:r>
+          </a:p>
+        </p:txBody>
+      </p:sp>
+      <p:sp>
+        <p:nvSpPr>
+          <p:cNvPr id="10" name="">
+            <a:extLst xmlns:a="http://schemas.openxmlformats.org/drawingml/2006/main">
+              <a:ext uri="{FF2B5EF4-FFF2-40B4-BE49-F238E27FC236}">
+                <a16:creationId xmlns:a16="http://schemas.microsoft.com/office/drawing/2014/main" id="{C4EAFFAC-BAD4-42BD-B7B3-D2F3A56F50CD}"/>
+              </a:ext>
+            </a:extLst>
+          </p:cNvPr>
+          <p:cNvSpPr>
+            <a:spLocks xmlns:a="http://schemas.openxmlformats.org/drawingml/2006/main" noGrp="1"/>
+          </p:cNvSpPr>
+          <p:nvPr/>
+        </p:nvSpPr>
+        <p:spPr>
+          <a:xfrm xmlns:a="http://schemas.openxmlformats.org/drawingml/2006/main">
+            <a:off x="5810250" y="2286000"/>
+            <a:ext cx="4857750" cy="247650"/>
+          </a:xfrm>
+          <a:prstGeom xmlns:a="http://schemas.openxmlformats.org/drawingml/2006/main" prst="rect">
+            <a:avLst/>
+          </a:prstGeom>
+          <a:noFill xmlns:a="http://schemas.openxmlformats.org/drawingml/2006/main"/>
+          <a:ln xmlns:a="http://schemas.openxmlformats.org/drawingml/2006/main" w="0">
+            <a:noFill/>
+          </a:ln>
+        </p:spPr>
+        <p:txBody>
+          <a:bodyPr xmlns:a="http://schemas.openxmlformats.org/drawingml/2006/main" lIns="0" tIns="0" rIns="0" bIns="0" anchor="t">
+            <a:normAutofit fontScale="100000"/>
+          </a:bodyPr>
+          <a:lstStyle xmlns:a="http://schemas.openxmlformats.org/drawingml/2006/main"/>
+          <a:p xmlns:a="http://schemas.openxmlformats.org/drawingml/2006/main">
+            <a:pPr marL="0" indent="0" algn="l">
+              <a:spcBef>
+                <a:spcPts val="0"/>
+              </a:spcBef>
+              <a:spcAft>
+                <a:spcPts val="0"/>
+              </a:spcAft>
+              <a:buNone/>
+              <a:defRPr sz="1125">
+                <a:solidFill>
+                  <a:srgbClr val="BCEF59"/>
+                </a:solidFill>
+                <a:latin typeface="Inter Medium"/>
+                <a:ea typeface="Inter Medium"/>
+                <a:cs typeface="Inter Medium"/>
+              </a:defRPr>
+            </a:pPr>
+            <a:r>
+              <a:t>SOURCE DATA</a:t>
+            </a:r>
+          </a:p>
+        </p:txBody>
+      </p:sp>
+      <p:sp>
+        <p:nvSpPr>
+          <p:cNvPr id="11" name="">
+            <a:extLst xmlns:a="http://schemas.openxmlformats.org/drawingml/2006/main">
+              <a:ext uri="{FF2B5EF4-FFF2-40B4-BE49-F238E27FC236}">
+                <a16:creationId xmlns:a16="http://schemas.microsoft.com/office/drawing/2014/main" id="{F4B00F97-ABA3-4212-9C04-2D87BD9BB316}"/>
+              </a:ext>
+            </a:extLst>
+          </p:cNvPr>
+          <p:cNvSpPr>
+            <a:spLocks xmlns:a="http://schemas.openxmlformats.org/drawingml/2006/main" noGrp="1"/>
+          </p:cNvSpPr>
+          <p:nvPr/>
+        </p:nvSpPr>
+        <p:spPr>
+          <a:xfrm xmlns:a="http://schemas.openxmlformats.org/drawingml/2006/main">
+            <a:off x="5810250" y="2619375"/>
+            <a:ext cx="4857750" cy="1143000"/>
+          </a:xfrm>
+          <a:prstGeom xmlns:a="http://schemas.openxmlformats.org/drawingml/2006/main" prst="rect">
+            <a:avLst/>
+          </a:prstGeom>
+          <a:noFill xmlns:a="http://schemas.openxmlformats.org/drawingml/2006/main"/>
+          <a:ln xmlns:a="http://schemas.openxmlformats.org/drawingml/2006/main" w="0">
+            <a:noFill/>
+          </a:ln>
+        </p:spPr>
+        <p:txBody>
+          <a:bodyPr xmlns:a="http://schemas.openxmlformats.org/drawingml/2006/main" lIns="0" tIns="0" rIns="0" bIns="0" anchor="t">
+            <a:normAutofit fontScale="100000"/>
+          </a:bodyPr>
+          <a:lstStyle xmlns:a="http://schemas.openxmlformats.org/drawingml/2006/main"/>
+          <a:p xmlns:a="http://schemas.openxmlformats.org/drawingml/2006/main">
+            <a:pPr marL="0" indent="0" algn="l">
+              <a:spcBef>
+                <a:spcPts val="0"/>
+              </a:spcBef>
+              <a:spcAft>
+                <a:spcPts val="0"/>
+              </a:spcAft>
+              <a:buNone/>
+              <a:defRPr sz="1575">
+                <a:solidFill>
+                  <a:srgbClr val="FFFFFF"/>
+                </a:solidFill>
+                <a:latin typeface="Inter"/>
+                <a:ea typeface="Inter"/>
+                <a:cs typeface="Inter"/>
+              </a:defRPr>
+            </a:pPr>
+            <a:r>
+              <a:t>Six venues are reporting and 96% of priority alerts arrive within 15 minutes. Training and QBR dates remain unconfirmed; the Dec 18 goal remains open. [S1, S3]</a:t>
+            </a:r>
+          </a:p>
+        </p:txBody>
+      </p:sp>
+      <p:sp>
+        <p:nvSpPr>
+          <p:cNvPr id="12" name="">
+            <a:extLst xmlns:a="http://schemas.openxmlformats.org/drawingml/2006/main">
+              <a:ext uri="{FF2B5EF4-FFF2-40B4-BE49-F238E27FC236}">
+                <a16:creationId xmlns:a16="http://schemas.microsoft.com/office/drawing/2014/main" id="{BA599D18-3175-43EA-84EC-94D027225BC7}"/>
+              </a:ext>
+            </a:extLst>
+          </p:cNvPr>
+          <p:cNvSpPr>
+            <a:spLocks xmlns:a="http://schemas.openxmlformats.org/drawingml/2006/main" noGrp="1"/>
+          </p:cNvSpPr>
+          <p:nvPr/>
+        </p:nvSpPr>
+        <p:spPr>
+          <a:xfrm xmlns:a="http://schemas.openxmlformats.org/drawingml/2006/main">
+            <a:off x="5810250" y="4238625"/>
+            <a:ext cx="4857750" cy="247650"/>
+          </a:xfrm>
+          <a:prstGeom xmlns:a="http://schemas.openxmlformats.org/drawingml/2006/main" prst="rect">
+            <a:avLst/>
+          </a:prstGeom>
+          <a:noFill xmlns:a="http://schemas.openxmlformats.org/drawingml/2006/main"/>
+          <a:ln xmlns:a="http://schemas.openxmlformats.org/drawingml/2006/main" w="0">
+            <a:noFill/>
+          </a:ln>
+        </p:spPr>
+        <p:txBody>
+          <a:bodyPr xmlns:a="http://schemas.openxmlformats.org/drawingml/2006/main" lIns="0" tIns="0" rIns="0" bIns="0" anchor="t">
+            <a:normAutofit fontScale="100000"/>
+          </a:bodyPr>
+          <a:lstStyle xmlns:a="http://schemas.openxmlformats.org/drawingml/2006/main"/>
+          <a:p xmlns:a="http://schemas.openxmlformats.org/drawingml/2006/main">
+            <a:pPr marL="0" indent="0" algn="l">
+              <a:spcBef>
+                <a:spcPts val="0"/>
+              </a:spcBef>
+              <a:spcAft>
+                <a:spcPts val="0"/>
+              </a:spcAft>
+              <a:buNone/>
+              <a:defRPr sz="1125">
+                <a:solidFill>
+                  <a:srgbClr val="BCEF59"/>
+                </a:solidFill>
+                <a:latin typeface="Inter Medium"/>
+                <a:ea typeface="Inter Medium"/>
+                <a:cs typeface="Inter Medium"/>
+              </a:defRPr>
+            </a:pPr>
+            <a:r>
+              <a:t>CUSTOMER CONTEXT</a:t>
+            </a:r>
+          </a:p>
+        </p:txBody>
+      </p:sp>
+      <p:sp>
+        <p:nvSpPr>
+          <p:cNvPr id="13" name="">
+            <a:extLst xmlns:a="http://schemas.openxmlformats.org/drawingml/2006/main">
+              <a:ext uri="{FF2B5EF4-FFF2-40B4-BE49-F238E27FC236}">
+                <a16:creationId xmlns:a16="http://schemas.microsoft.com/office/drawing/2014/main" id="{2F6D8674-9C79-4497-A81A-F04AC3C3898D}"/>
+              </a:ext>
+            </a:extLst>
+          </p:cNvPr>
+          <p:cNvSpPr>
+            <a:spLocks xmlns:a="http://schemas.openxmlformats.org/drawingml/2006/main" noGrp="1"/>
+          </p:cNvSpPr>
+          <p:nvPr/>
+        </p:nvSpPr>
+        <p:spPr>
+          <a:xfrm xmlns:a="http://schemas.openxmlformats.org/drawingml/2006/main">
+            <a:off x="5810250" y="4572000"/>
+            <a:ext cx="4857750" cy="1238250"/>
+          </a:xfrm>
+          <a:prstGeom xmlns:a="http://schemas.openxmlformats.org/drawingml/2006/main" prst="rect">
+            <a:avLst/>
+          </a:prstGeom>
+          <a:noFill xmlns:a="http://schemas.openxmlformats.org/drawingml/2006/main"/>
+          <a:ln xmlns:a="http://schemas.openxmlformats.org/drawingml/2006/main" w="0">
+            <a:noFill/>
+          </a:ln>
+        </p:spPr>
+        <p:txBody>
+          <a:bodyPr xmlns:a="http://schemas.openxmlformats.org/drawingml/2006/main" lIns="0" tIns="0" rIns="0" bIns="0" anchor="t">
+            <a:normAutofit fontScale="91926"/>
+          </a:bodyPr>
+          <a:lstStyle xmlns:a="http://schemas.openxmlformats.org/drawingml/2006/main"/>
+          <a:p xmlns:a="http://schemas.openxmlformats.org/drawingml/2006/main">
+            <a:pPr marL="0" indent="0" algn="l">
+              <a:spcBef>
+                <a:spcPts val="0"/>
+              </a:spcBef>
+              <a:spcAft>
+                <a:spcPts val="0"/>
+              </a:spcAft>
+              <a:buNone/>
+              <a:defRPr sz="1575">
+                <a:solidFill>
+                  <a:srgbClr val="FFFFFF"/>
+                </a:solidFill>
+                <a:latin typeface="Inter"/>
+                <a:ea typeface="Inter"/>
+                <a:cs typeface="Inter"/>
+              </a:defRPr>
+            </a:pPr>
+            <a:r>
+              <a:t>Maintain a single security view across six venues and monthly executive reporting. [S1, S2]</a:t>
+            </a:r>
+          </a:p>
+          <a:p xmlns:a="http://schemas.openxmlformats.org/drawingml/2006/main">
+            <a:pPr marL="0" indent="0" algn="l">
+              <a:spcBef>
+                <a:spcPts val="0"/>
+              </a:spcBef>
+              <a:spcAft>
+                <a:spcPts val="0"/>
+              </a:spcAft>
+              <a:buNone/>
+              <a:defRPr sz="1575">
+                <a:solidFill>
+                  <a:srgbClr val="FFFFFF"/>
+                </a:solidFill>
+                <a:latin typeface="Inter"/>
+                <a:ea typeface="Inter"/>
+                <a:cs typeface="Inter"/>
+              </a:defRPr>
+            </a:pPr>
+            <a:r>
+              <a:t/>
+            </a:r>
+          </a:p>
+          <a:p xmlns:a="http://schemas.openxmlformats.org/drawingml/2006/main">
+            <a:pPr marL="0" indent="0" algn="l">
+              <a:spcBef>
+                <a:spcPts val="0"/>
+              </a:spcBef>
+              <a:spcAft>
+                <a:spcPts val="0"/>
+              </a:spcAft>
+              <a:buNone/>
+              <a:defRPr sz="1575">
+                <a:solidFill>
+                  <a:srgbClr val="FFFFFF"/>
+                </a:solidFill>
+                <a:latin typeface="Inter"/>
+                <a:ea typeface="Inter"/>
+                <a:cs typeface="Inter"/>
+              </a:defRPr>
+            </a:pPr>
+            <a:r>
+              <a:t>Althea Cassidy owns Customer Success. Scarlet remains sponsor; Casey remains the customer technical owner. [S1]</a:t>
             </a:r>
           </a:p>
         </p:txBody>
@@ -4695,10 +4293,10 @@
       </p:grpSpPr>
       <p:sp>
         <p:nvSpPr>
-          <p:cNvPr id="16" name="">
-            <a:extLst xmlns:a="http://schemas.openxmlformats.org/drawingml/2006/main">
-              <a:ext uri="{FF2B5EF4-FFF2-40B4-BE49-F238E27FC236}">
-                <a16:creationId xmlns:a16="http://schemas.microsoft.com/office/drawing/2014/main" id="{F7108147-99D3-4DDE-A0AE-2C0366185165}"/>
+          <p:cNvPr id="14" name="">
+            <a:extLst xmlns:a="http://schemas.openxmlformats.org/drawingml/2006/main">
+              <a:ext uri="{FF2B5EF4-FFF2-40B4-BE49-F238E27FC236}">
+                <a16:creationId xmlns:a16="http://schemas.microsoft.com/office/drawing/2014/main" id="{728B79FF-7489-4FE1-81C4-155D7D97C66A}"/>
               </a:ext>
             </a:extLst>
           </p:cNvPr>
@@ -4744,7 +4342,7 @@
               </a:defRPr>
             </a:pPr>
             <a:r>
-              <a:t>WHAT THE NEXT TEAM NEEDS</a:t>
+              <a:t>WORK THAT STILL NEEDS AN OWNER OR DATE</a:t>
             </a:r>
           </a:p>
         </p:txBody>
@@ -4754,7 +4352,7 @@
           <p:cNvPr id="2" name="">
             <a:extLst xmlns:a="http://schemas.openxmlformats.org/drawingml/2006/main">
               <a:ext uri="{FF2B5EF4-FFF2-40B4-BE49-F238E27FC236}">
-                <a16:creationId xmlns:a16="http://schemas.microsoft.com/office/drawing/2014/main" id="{39B17E59-C792-4813-BE13-B91ADC25E407}"/>
+                <a16:creationId xmlns:a16="http://schemas.microsoft.com/office/drawing/2014/main" id="{5745B60E-F8BF-4573-949C-E904C10FC64A}"/>
               </a:ext>
             </a:extLst>
           </p:cNvPr>
@@ -4800,7 +4398,7 @@
               </a:defRPr>
             </a:pPr>
             <a:r>
-              <a:t>Current context and unresolved work</a:t>
+              <a:t>Open action items</a:t>
             </a:r>
           </a:p>
         </p:txBody>
@@ -4810,7 +4408,7 @@
           <p:cNvPr id="3" name="">
             <a:extLst xmlns:a="http://schemas.openxmlformats.org/drawingml/2006/main">
               <a:ext uri="{FF2B5EF4-FFF2-40B4-BE49-F238E27FC236}">
-                <a16:creationId xmlns:a16="http://schemas.microsoft.com/office/drawing/2014/main" id="{D501230B-D03F-4797-9E4F-166A878C4CEA}"/>
+                <a16:creationId xmlns:a16="http://schemas.microsoft.com/office/drawing/2014/main" id="{FA9DAD2B-42AE-4933-8D5A-7DD02F1645B0}"/>
               </a:ext>
             </a:extLst>
           </p:cNvPr>
@@ -4866,7 +4464,7 @@
           <p:cNvPr id="4" name="">
             <a:extLst xmlns:a="http://schemas.openxmlformats.org/drawingml/2006/main">
               <a:ext uri="{FF2B5EF4-FFF2-40B4-BE49-F238E27FC236}">
-                <a16:creationId xmlns:a16="http://schemas.microsoft.com/office/drawing/2014/main" id="{129638A8-3876-4531-9CAE-66ACB7D3A0AD}"/>
+                <a16:creationId xmlns:a16="http://schemas.microsoft.com/office/drawing/2014/main" id="{EA913B38-65FF-454F-93C2-20BDCF127CAA}"/>
               </a:ext>
             </a:extLst>
           </p:cNvPr>
@@ -4922,7 +4520,7 @@
           <p:cNvPr id="5" name="">
             <a:extLst xmlns:a="http://schemas.openxmlformats.org/drawingml/2006/main">
               <a:ext uri="{FF2B5EF4-FFF2-40B4-BE49-F238E27FC236}">
-                <a16:creationId xmlns:a16="http://schemas.microsoft.com/office/drawing/2014/main" id="{B6FA2077-9945-4FA3-AE58-529BCB20F3D3}"/>
+                <a16:creationId xmlns:a16="http://schemas.microsoft.com/office/drawing/2014/main" id="{D6157B69-0561-487D-815C-7DB9AFF6EC9F}"/>
               </a:ext>
             </a:extLst>
           </p:cNvPr>
@@ -4933,8 +4531,8 @@
         </p:nvSpPr>
         <p:spPr>
           <a:xfrm xmlns:a="http://schemas.openxmlformats.org/drawingml/2006/main">
-            <a:off x="666750" y="2381250"/>
-            <a:ext cx="4476750" cy="247650"/>
+            <a:off x="666750" y="2190750"/>
+            <a:ext cx="400050" cy="400050"/>
           </a:xfrm>
           <a:prstGeom xmlns:a="http://schemas.openxmlformats.org/drawingml/2006/main" prst="rect">
             <a:avLst/>
@@ -4958,7 +4556,7 @@
                 <a:spcPts val="0"/>
               </a:spcAft>
               <a:buNone/>
-              <a:defRPr sz="1125">
+              <a:defRPr sz="2100">
                 <a:solidFill>
                   <a:srgbClr val="4A7A1D"/>
                 </a:solidFill>
@@ -4968,7 +4566,7 @@
               </a:defRPr>
             </a:pPr>
             <a:r>
-              <a:t>CUSTOMER GOAL</a:t>
+              <a:t>1</a:t>
             </a:r>
           </a:p>
         </p:txBody>
@@ -4978,7 +4576,7 @@
           <p:cNvPr id="6" name="">
             <a:extLst xmlns:a="http://schemas.openxmlformats.org/drawingml/2006/main">
               <a:ext uri="{FF2B5EF4-FFF2-40B4-BE49-F238E27FC236}">
-                <a16:creationId xmlns:a16="http://schemas.microsoft.com/office/drawing/2014/main" id="{66806EBB-9E36-4619-BF66-F9D2001DEFD2}"/>
+                <a16:creationId xmlns:a16="http://schemas.microsoft.com/office/drawing/2014/main" id="{D7E53566-B01A-4B82-8F86-3E2A261D3734}"/>
               </a:ext>
             </a:extLst>
           </p:cNvPr>
@@ -4989,8 +4587,8 @@
         </p:nvSpPr>
         <p:spPr>
           <a:xfrm xmlns:a="http://schemas.openxmlformats.org/drawingml/2006/main">
-            <a:off x="666750" y="2714625"/>
-            <a:ext cx="4476750" cy="1476375"/>
+            <a:off x="1285875" y="2190750"/>
+            <a:ext cx="6191250" cy="666750"/>
           </a:xfrm>
           <a:prstGeom xmlns:a="http://schemas.openxmlformats.org/drawingml/2006/main" prst="rect">
             <a:avLst/>
@@ -5014,7 +4612,63 @@
                 <a:spcPts val="0"/>
               </a:spcAft>
               <a:buNone/>
-              <a:defRPr sz="1575">
+              <a:defRPr sz="1650">
+                <a:solidFill>
+                  <a:srgbClr val="0A2D22"/>
+                </a:solidFill>
+                <a:latin typeface="Inter Medium"/>
+                <a:ea typeface="Inter Medium"/>
+                <a:cs typeface="Inter Medium"/>
+              </a:defRPr>
+            </a:pPr>
+            <a:r>
+              <a:t>Verify mean investigation time ≤42 minutes against the agreed 60-minute baseline. [S1, S2]</a:t>
+            </a:r>
+          </a:p>
+        </p:txBody>
+      </p:sp>
+      <p:sp>
+        <p:nvSpPr>
+          <p:cNvPr id="7" name="">
+            <a:extLst xmlns:a="http://schemas.openxmlformats.org/drawingml/2006/main">
+              <a:ext uri="{FF2B5EF4-FFF2-40B4-BE49-F238E27FC236}">
+                <a16:creationId xmlns:a16="http://schemas.microsoft.com/office/drawing/2014/main" id="{D1A62A52-F939-4EA2-BAA8-DA70A6E7A715}"/>
+              </a:ext>
+            </a:extLst>
+          </p:cNvPr>
+          <p:cNvSpPr>
+            <a:spLocks xmlns:a="http://schemas.openxmlformats.org/drawingml/2006/main" noGrp="1"/>
+          </p:cNvSpPr>
+          <p:nvPr/>
+        </p:nvSpPr>
+        <p:spPr>
+          <a:xfrm xmlns:a="http://schemas.openxmlformats.org/drawingml/2006/main">
+            <a:off x="7905750" y="2209800"/>
+            <a:ext cx="2762250" cy="590550"/>
+          </a:xfrm>
+          <a:prstGeom xmlns:a="http://schemas.openxmlformats.org/drawingml/2006/main" prst="rect">
+            <a:avLst/>
+          </a:prstGeom>
+          <a:noFill xmlns:a="http://schemas.openxmlformats.org/drawingml/2006/main"/>
+          <a:ln xmlns:a="http://schemas.openxmlformats.org/drawingml/2006/main" w="0">
+            <a:noFill/>
+          </a:ln>
+        </p:spPr>
+        <p:txBody>
+          <a:bodyPr xmlns:a="http://schemas.openxmlformats.org/drawingml/2006/main" lIns="0" tIns="0" rIns="0" bIns="0" anchor="t">
+            <a:normAutofit fontScale="100000"/>
+          </a:bodyPr>
+          <a:lstStyle xmlns:a="http://schemas.openxmlformats.org/drawingml/2006/main"/>
+          <a:p xmlns:a="http://schemas.openxmlformats.org/drawingml/2006/main">
+            <a:pPr marL="0" indent="0" algn="l">
+              <a:spcBef>
+                <a:spcPts val="0"/>
+              </a:spcBef>
+              <a:spcAft>
+                <a:spcPts val="0"/>
+              </a:spcAft>
+              <a:buNone/>
+              <a:defRPr sz="1350">
                 <a:solidFill>
                   <a:srgbClr val="0A2D22"/>
                 </a:solidFill>
@@ -5024,17 +4678,39 @@
               </a:defRPr>
             </a:pPr>
             <a:r>
-              <a:t>Maintain a single security view across six venues and monthly executive reporting. [S1, S2]</a:t>
-            </a:r>
-          </a:p>
-        </p:txBody>
-      </p:sp>
-      <p:sp>
-        <p:nvSpPr>
-          <p:cNvPr id="7" name="">
-            <a:extLst xmlns:a="http://schemas.openxmlformats.org/drawingml/2006/main">
-              <a:ext uri="{FF2B5EF4-FFF2-40B4-BE49-F238E27FC236}">
-                <a16:creationId xmlns:a16="http://schemas.microsoft.com/office/drawing/2014/main" id="{0824169C-5CAD-4000-B92F-8DB41E19F885}"/>
+              <a:t>Ruben Cherise (Implementation)</a:t>
+            </a:r>
+          </a:p>
+          <a:p xmlns:a="http://schemas.openxmlformats.org/drawingml/2006/main">
+            <a:pPr marL="0" indent="0" algn="l">
+              <a:spcBef>
+                <a:spcPts val="0"/>
+              </a:spcBef>
+              <a:spcAft>
+                <a:spcPts val="0"/>
+              </a:spcAft>
+              <a:buNone/>
+              <a:defRPr sz="1350">
+                <a:solidFill>
+                  <a:srgbClr val="0A2D22"/>
+                </a:solidFill>
+                <a:latin typeface="Inter"/>
+                <a:ea typeface="Inter"/>
+                <a:cs typeface="Inter"/>
+              </a:defRPr>
+            </a:pPr>
+            <a:r>
+              <a:t>Due: 2026-12-18</a:t>
+            </a:r>
+          </a:p>
+        </p:txBody>
+      </p:sp>
+      <p:sp>
+        <p:nvSpPr>
+          <p:cNvPr id="8" name="">
+            <a:extLst xmlns:a="http://schemas.openxmlformats.org/drawingml/2006/main">
+              <a:ext uri="{FF2B5EF4-FFF2-40B4-BE49-F238E27FC236}">
+                <a16:creationId xmlns:a16="http://schemas.microsoft.com/office/drawing/2014/main" id="{590F48F6-F124-4CBB-A851-8955C0C92566}"/>
               </a:ext>
             </a:extLst>
           </p:cNvPr>
@@ -5045,8 +4721,8 @@
         </p:nvSpPr>
         <p:spPr>
           <a:xfrm xmlns:a="http://schemas.openxmlformats.org/drawingml/2006/main">
-            <a:off x="5953125" y="2381250"/>
-            <a:ext cx="4667250" cy="247650"/>
+            <a:off x="666750" y="3476625"/>
+            <a:ext cx="400050" cy="400050"/>
           </a:xfrm>
           <a:prstGeom xmlns:a="http://schemas.openxmlformats.org/drawingml/2006/main" prst="rect">
             <a:avLst/>
@@ -5070,7 +4746,7 @@
                 <a:spcPts val="0"/>
               </a:spcAft>
               <a:buNone/>
-              <a:defRPr sz="1125">
+              <a:defRPr sz="2100">
                 <a:solidFill>
                   <a:srgbClr val="4A7A1D"/>
                 </a:solidFill>
@@ -5080,17 +4756,17 @@
               </a:defRPr>
             </a:pPr>
             <a:r>
-              <a:t>CUSTOMER STAKEHOLDERS</a:t>
-            </a:r>
-          </a:p>
-        </p:txBody>
-      </p:sp>
-      <p:sp>
-        <p:nvSpPr>
-          <p:cNvPr id="8" name="">
-            <a:extLst xmlns:a="http://schemas.openxmlformats.org/drawingml/2006/main">
-              <a:ext uri="{FF2B5EF4-FFF2-40B4-BE49-F238E27FC236}">
-                <a16:creationId xmlns:a16="http://schemas.microsoft.com/office/drawing/2014/main" id="{1CB4AF9C-4AA4-47DD-9A77-5461AF6D047D}"/>
+              <a:t>2</a:t>
+            </a:r>
+          </a:p>
+        </p:txBody>
+      </p:sp>
+      <p:sp>
+        <p:nvSpPr>
+          <p:cNvPr id="9" name="">
+            <a:extLst xmlns:a="http://schemas.openxmlformats.org/drawingml/2006/main">
+              <a:ext uri="{FF2B5EF4-FFF2-40B4-BE49-F238E27FC236}">
+                <a16:creationId xmlns:a16="http://schemas.microsoft.com/office/drawing/2014/main" id="{968C870D-5CAB-497B-B00C-2E50B0A29217}"/>
               </a:ext>
             </a:extLst>
           </p:cNvPr>
@@ -5101,8 +4777,8 @@
         </p:nvSpPr>
         <p:spPr>
           <a:xfrm xmlns:a="http://schemas.openxmlformats.org/drawingml/2006/main">
-            <a:off x="5953125" y="2714625"/>
-            <a:ext cx="4667250" cy="1476375"/>
+            <a:off x="1285875" y="3476625"/>
+            <a:ext cx="6191250" cy="666750"/>
           </a:xfrm>
           <a:prstGeom xmlns:a="http://schemas.openxmlformats.org/drawingml/2006/main" prst="rect">
             <a:avLst/>
@@ -5126,7 +4802,63 @@
                 <a:spcPts val="0"/>
               </a:spcAft>
               <a:buNone/>
-              <a:defRPr sz="1575">
+              <a:defRPr sz="1650">
+                <a:solidFill>
+                  <a:srgbClr val="0A2D22"/>
+                </a:solidFill>
+                <a:latin typeface="Inter Medium"/>
+                <a:ea typeface="Inter Medium"/>
+                <a:cs typeface="Inter Medium"/>
+              </a:defRPr>
+            </a:pPr>
+            <a:r>
+              <a:t>Confirm the customer training session and record the agreed date. [S3]</a:t>
+            </a:r>
+          </a:p>
+        </p:txBody>
+      </p:sp>
+      <p:sp>
+        <p:nvSpPr>
+          <p:cNvPr id="10" name="">
+            <a:extLst xmlns:a="http://schemas.openxmlformats.org/drawingml/2006/main">
+              <a:ext uri="{FF2B5EF4-FFF2-40B4-BE49-F238E27FC236}">
+                <a16:creationId xmlns:a16="http://schemas.microsoft.com/office/drawing/2014/main" id="{BFB44FC8-2845-4D76-8A2F-E9B8CF841582}"/>
+              </a:ext>
+            </a:extLst>
+          </p:cNvPr>
+          <p:cNvSpPr>
+            <a:spLocks xmlns:a="http://schemas.openxmlformats.org/drawingml/2006/main" noGrp="1"/>
+          </p:cNvSpPr>
+          <p:nvPr/>
+        </p:nvSpPr>
+        <p:spPr>
+          <a:xfrm xmlns:a="http://schemas.openxmlformats.org/drawingml/2006/main">
+            <a:off x="7905750" y="3495675"/>
+            <a:ext cx="2762250" cy="590550"/>
+          </a:xfrm>
+          <a:prstGeom xmlns:a="http://schemas.openxmlformats.org/drawingml/2006/main" prst="rect">
+            <a:avLst/>
+          </a:prstGeom>
+          <a:noFill xmlns:a="http://schemas.openxmlformats.org/drawingml/2006/main"/>
+          <a:ln xmlns:a="http://schemas.openxmlformats.org/drawingml/2006/main" w="0">
+            <a:noFill/>
+          </a:ln>
+        </p:spPr>
+        <p:txBody>
+          <a:bodyPr xmlns:a="http://schemas.openxmlformats.org/drawingml/2006/main" lIns="0" tIns="0" rIns="0" bIns="0" anchor="t">
+            <a:normAutofit fontScale="100000"/>
+          </a:bodyPr>
+          <a:lstStyle xmlns:a="http://schemas.openxmlformats.org/drawingml/2006/main"/>
+          <a:p xmlns:a="http://schemas.openxmlformats.org/drawingml/2006/main">
+            <a:pPr marL="0" indent="0" algn="l">
+              <a:spcBef>
+                <a:spcPts val="0"/>
+              </a:spcBef>
+              <a:spcAft>
+                <a:spcPts val="0"/>
+              </a:spcAft>
+              <a:buNone/>
+              <a:defRPr sz="1350">
                 <a:solidFill>
                   <a:srgbClr val="0A2D22"/>
                 </a:solidFill>
@@ -5136,17 +4868,39 @@
               </a:defRPr>
             </a:pPr>
             <a:r>
-              <a:t>Althea Cassidy owns Customer Success. Scarlet remains sponsor; Casey remains the customer technical owner. [S1]</a:t>
-            </a:r>
-          </a:p>
-        </p:txBody>
-      </p:sp>
-      <p:sp>
-        <p:nvSpPr>
-          <p:cNvPr id="9" name="">
-            <a:extLst xmlns:a="http://schemas.openxmlformats.org/drawingml/2006/main">
-              <a:ext uri="{FF2B5EF4-FFF2-40B4-BE49-F238E27FC236}">
-                <a16:creationId xmlns:a16="http://schemas.microsoft.com/office/drawing/2014/main" id="{3211D7BB-ED29-4226-8112-2DBDCDB09853}"/>
+              <a:t>Althea Cassidy (Customer Success)</a:t>
+            </a:r>
+          </a:p>
+          <a:p xmlns:a="http://schemas.openxmlformats.org/drawingml/2006/main">
+            <a:pPr marL="0" indent="0" algn="l">
+              <a:spcBef>
+                <a:spcPts val="0"/>
+              </a:spcBef>
+              <a:spcAft>
+                <a:spcPts val="0"/>
+              </a:spcAft>
+              <a:buNone/>
+              <a:defRPr sz="1350">
+                <a:solidFill>
+                  <a:srgbClr val="0A2D22"/>
+                </a:solidFill>
+                <a:latin typeface="Inter"/>
+                <a:ea typeface="Inter"/>
+                <a:cs typeface="Inter"/>
+              </a:defRPr>
+            </a:pPr>
+            <a:r>
+              <a:t>Due: Not Confirmed</a:t>
+            </a:r>
+          </a:p>
+        </p:txBody>
+      </p:sp>
+      <p:sp>
+        <p:nvSpPr>
+          <p:cNvPr id="11" name="">
+            <a:extLst xmlns:a="http://schemas.openxmlformats.org/drawingml/2006/main">
+              <a:ext uri="{FF2B5EF4-FFF2-40B4-BE49-F238E27FC236}">
+                <a16:creationId xmlns:a16="http://schemas.microsoft.com/office/drawing/2014/main" id="{2B0C7FF5-F785-4059-BA98-89E99CB922EF}"/>
               </a:ext>
             </a:extLst>
           </p:cNvPr>
@@ -5158,7 +4912,7 @@
         <p:spPr>
           <a:xfrm xmlns:a="http://schemas.openxmlformats.org/drawingml/2006/main">
             <a:off x="666750" y="4762500"/>
-            <a:ext cx="9953625" cy="247650"/>
+            <a:ext cx="400050" cy="400050"/>
           </a:xfrm>
           <a:prstGeom xmlns:a="http://schemas.openxmlformats.org/drawingml/2006/main" prst="rect">
             <a:avLst/>
@@ -5182,7 +4936,7 @@
                 <a:spcPts val="0"/>
               </a:spcAft>
               <a:buNone/>
-              <a:defRPr sz="1125">
+              <a:defRPr sz="2100">
                 <a:solidFill>
                   <a:srgbClr val="4A7A1D"/>
                 </a:solidFill>
@@ -5192,17 +4946,17 @@
               </a:defRPr>
             </a:pPr>
             <a:r>
-              <a:t>OPEN ACTIONS</a:t>
-            </a:r>
-          </a:p>
-        </p:txBody>
-      </p:sp>
-      <p:sp>
-        <p:nvSpPr>
-          <p:cNvPr id="10" name="">
-            <a:extLst xmlns:a="http://schemas.openxmlformats.org/drawingml/2006/main">
-              <a:ext uri="{FF2B5EF4-FFF2-40B4-BE49-F238E27FC236}">
-                <a16:creationId xmlns:a16="http://schemas.microsoft.com/office/drawing/2014/main" id="{3C61A503-5DFA-4AB6-9400-512F3DC8D968}"/>
+              <a:t>3</a:t>
+            </a:r>
+          </a:p>
+        </p:txBody>
+      </p:sp>
+      <p:sp>
+        <p:nvSpPr>
+          <p:cNvPr id="12" name="">
+            <a:extLst xmlns:a="http://schemas.openxmlformats.org/drawingml/2006/main">
+              <a:ext uri="{FF2B5EF4-FFF2-40B4-BE49-F238E27FC236}">
+                <a16:creationId xmlns:a16="http://schemas.microsoft.com/office/drawing/2014/main" id="{FBDF9F80-8A76-4080-ADD6-95E551D4A2E2}"/>
               </a:ext>
             </a:extLst>
           </p:cNvPr>
@@ -5213,8 +4967,8 @@
         </p:nvSpPr>
         <p:spPr>
           <a:xfrm xmlns:a="http://schemas.openxmlformats.org/drawingml/2006/main">
-            <a:off x="666750" y="5143500"/>
-            <a:ext cx="3095625" cy="266700"/>
+            <a:off x="1285875" y="4762500"/>
+            <a:ext cx="6191250" cy="666750"/>
           </a:xfrm>
           <a:prstGeom xmlns:a="http://schemas.openxmlformats.org/drawingml/2006/main" prst="rect">
             <a:avLst/>
@@ -5238,7 +4992,7 @@
                 <a:spcPts val="0"/>
               </a:spcAft>
               <a:buNone/>
-              <a:defRPr sz="1575">
+              <a:defRPr sz="1650">
                 <a:solidFill>
                   <a:srgbClr val="0A2D22"/>
                 </a:solidFill>
@@ -5248,17 +5002,17 @@
               </a:defRPr>
             </a:pPr>
             <a:r>
-              <a:t>Investigation target</a:t>
-            </a:r>
-          </a:p>
-        </p:txBody>
-      </p:sp>
-      <p:sp>
-        <p:nvSpPr>
-          <p:cNvPr id="11" name="">
-            <a:extLst xmlns:a="http://schemas.openxmlformats.org/drawingml/2006/main">
-              <a:ext uri="{FF2B5EF4-FFF2-40B4-BE49-F238E27FC236}">
-                <a16:creationId xmlns:a16="http://schemas.microsoft.com/office/drawing/2014/main" id="{98313B5D-8A89-4A62-B3C1-1FCBFAA1287E}"/>
+              <a:t>Confirm the first QBR date with the customer. [S3]</a:t>
+            </a:r>
+          </a:p>
+        </p:txBody>
+      </p:sp>
+      <p:sp>
+        <p:nvSpPr>
+          <p:cNvPr id="13" name="">
+            <a:extLst xmlns:a="http://schemas.openxmlformats.org/drawingml/2006/main">
+              <a:ext uri="{FF2B5EF4-FFF2-40B4-BE49-F238E27FC236}">
+                <a16:creationId xmlns:a16="http://schemas.microsoft.com/office/drawing/2014/main" id="{5994DB51-DFBD-451E-8BA4-D6EA10C75F6F}"/>
               </a:ext>
             </a:extLst>
           </p:cNvPr>
@@ -5269,8 +5023,8 @@
         </p:nvSpPr>
         <p:spPr>
           <a:xfrm xmlns:a="http://schemas.openxmlformats.org/drawingml/2006/main">
-            <a:off x="666750" y="5476875"/>
-            <a:ext cx="3095625" cy="523875"/>
+            <a:off x="7905750" y="4781550"/>
+            <a:ext cx="2762250" cy="590550"/>
           </a:xfrm>
           <a:prstGeom xmlns:a="http://schemas.openxmlformats.org/drawingml/2006/main" prst="rect">
             <a:avLst/>
@@ -5294,7 +5048,7 @@
                 <a:spcPts val="0"/>
               </a:spcAft>
               <a:buNone/>
-              <a:defRPr sz="1275">
+              <a:defRPr sz="1350">
                 <a:solidFill>
                   <a:srgbClr val="0A2D22"/>
                 </a:solidFill>
@@ -5304,7 +5058,7 @@
               </a:defRPr>
             </a:pPr>
             <a:r>
-              <a:t>Ruben Cherise (Implementation)</a:t>
+              <a:t>Althea Cassidy (Customer Success)</a:t>
             </a:r>
           </a:p>
           <a:p xmlns:a="http://schemas.openxmlformats.org/drawingml/2006/main">
@@ -5316,7 +5070,7 @@
                 <a:spcPts val="0"/>
               </a:spcAft>
               <a:buNone/>
-              <a:defRPr sz="1275">
+              <a:defRPr sz="1350">
                 <a:solidFill>
                   <a:srgbClr val="0A2D22"/>
                 </a:solidFill>
@@ -5326,275 +5080,7 @@
               </a:defRPr>
             </a:pPr>
             <a:r>
-              <a:t>Due: 2026-12-18 [S1, S2]</a:t>
-            </a:r>
-          </a:p>
-        </p:txBody>
-      </p:sp>
-      <p:sp>
-        <p:nvSpPr>
-          <p:cNvPr id="12" name="">
-            <a:extLst xmlns:a="http://schemas.openxmlformats.org/drawingml/2006/main">
-              <a:ext uri="{FF2B5EF4-FFF2-40B4-BE49-F238E27FC236}">
-                <a16:creationId xmlns:a16="http://schemas.microsoft.com/office/drawing/2014/main" id="{8DBC9A6F-16DE-423E-884F-2CECC00B6790}"/>
-              </a:ext>
-            </a:extLst>
-          </p:cNvPr>
-          <p:cNvSpPr>
-            <a:spLocks xmlns:a="http://schemas.openxmlformats.org/drawingml/2006/main" noGrp="1"/>
-          </p:cNvSpPr>
-          <p:nvPr/>
-        </p:nvSpPr>
-        <p:spPr>
-          <a:xfrm xmlns:a="http://schemas.openxmlformats.org/drawingml/2006/main">
-            <a:off x="4048125" y="5143500"/>
-            <a:ext cx="3095625" cy="266700"/>
-          </a:xfrm>
-          <a:prstGeom xmlns:a="http://schemas.openxmlformats.org/drawingml/2006/main" prst="rect">
-            <a:avLst/>
-          </a:prstGeom>
-          <a:noFill xmlns:a="http://schemas.openxmlformats.org/drawingml/2006/main"/>
-          <a:ln xmlns:a="http://schemas.openxmlformats.org/drawingml/2006/main" w="0">
-            <a:noFill/>
-          </a:ln>
-        </p:spPr>
-        <p:txBody>
-          <a:bodyPr xmlns:a="http://schemas.openxmlformats.org/drawingml/2006/main" lIns="0" tIns="0" rIns="0" bIns="0" anchor="t">
-            <a:normAutofit fontScale="100000"/>
-          </a:bodyPr>
-          <a:lstStyle xmlns:a="http://schemas.openxmlformats.org/drawingml/2006/main"/>
-          <a:p xmlns:a="http://schemas.openxmlformats.org/drawingml/2006/main">
-            <a:pPr marL="0" indent="0" algn="l">
-              <a:spcBef>
-                <a:spcPts val="0"/>
-              </a:spcBef>
-              <a:spcAft>
-                <a:spcPts val="0"/>
-              </a:spcAft>
-              <a:buNone/>
-              <a:defRPr sz="1575">
-                <a:solidFill>
-                  <a:srgbClr val="0A2D22"/>
-                </a:solidFill>
-                <a:latin typeface="Inter Medium"/>
-                <a:ea typeface="Inter Medium"/>
-                <a:cs typeface="Inter Medium"/>
-              </a:defRPr>
-            </a:pPr>
-            <a:r>
-              <a:t>Training</a:t>
-            </a:r>
-          </a:p>
-        </p:txBody>
-      </p:sp>
-      <p:sp>
-        <p:nvSpPr>
-          <p:cNvPr id="13" name="">
-            <a:extLst xmlns:a="http://schemas.openxmlformats.org/drawingml/2006/main">
-              <a:ext uri="{FF2B5EF4-FFF2-40B4-BE49-F238E27FC236}">
-                <a16:creationId xmlns:a16="http://schemas.microsoft.com/office/drawing/2014/main" id="{91B0A487-B812-4883-8EFC-F2BAEC80F0F7}"/>
-              </a:ext>
-            </a:extLst>
-          </p:cNvPr>
-          <p:cNvSpPr>
-            <a:spLocks xmlns:a="http://schemas.openxmlformats.org/drawingml/2006/main" noGrp="1"/>
-          </p:cNvSpPr>
-          <p:nvPr/>
-        </p:nvSpPr>
-        <p:spPr>
-          <a:xfrm xmlns:a="http://schemas.openxmlformats.org/drawingml/2006/main">
-            <a:off x="4048125" y="5476875"/>
-            <a:ext cx="3095625" cy="523875"/>
-          </a:xfrm>
-          <a:prstGeom xmlns:a="http://schemas.openxmlformats.org/drawingml/2006/main" prst="rect">
-            <a:avLst/>
-          </a:prstGeom>
-          <a:noFill xmlns:a="http://schemas.openxmlformats.org/drawingml/2006/main"/>
-          <a:ln xmlns:a="http://schemas.openxmlformats.org/drawingml/2006/main" w="0">
-            <a:noFill/>
-          </a:ln>
-        </p:spPr>
-        <p:txBody>
-          <a:bodyPr xmlns:a="http://schemas.openxmlformats.org/drawingml/2006/main" lIns="0" tIns="0" rIns="0" bIns="0" anchor="t">
-            <a:normAutofit fontScale="100000"/>
-          </a:bodyPr>
-          <a:lstStyle xmlns:a="http://schemas.openxmlformats.org/drawingml/2006/main"/>
-          <a:p xmlns:a="http://schemas.openxmlformats.org/drawingml/2006/main">
-            <a:pPr marL="0" indent="0" algn="l">
-              <a:spcBef>
-                <a:spcPts val="0"/>
-              </a:spcBef>
-              <a:spcAft>
-                <a:spcPts val="0"/>
-              </a:spcAft>
-              <a:buNone/>
-              <a:defRPr sz="1275">
-                <a:solidFill>
-                  <a:srgbClr val="0A2D22"/>
-                </a:solidFill>
-                <a:latin typeface="Inter"/>
-                <a:ea typeface="Inter"/>
-                <a:cs typeface="Inter"/>
-              </a:defRPr>
-            </a:pPr>
-            <a:r>
-              <a:t>Althea Cassidy (Customer Success)</a:t>
-            </a:r>
-          </a:p>
-          <a:p xmlns:a="http://schemas.openxmlformats.org/drawingml/2006/main">
-            <a:pPr marL="0" indent="0" algn="l">
-              <a:spcBef>
-                <a:spcPts val="0"/>
-              </a:spcBef>
-              <a:spcAft>
-                <a:spcPts val="0"/>
-              </a:spcAft>
-              <a:buNone/>
-              <a:defRPr sz="1275">
-                <a:solidFill>
-                  <a:srgbClr val="0A2D22"/>
-                </a:solidFill>
-                <a:latin typeface="Inter"/>
-                <a:ea typeface="Inter"/>
-                <a:cs typeface="Inter"/>
-              </a:defRPr>
-            </a:pPr>
-            <a:r>
-              <a:t>Due: Not confirmed [S3]</a:t>
-            </a:r>
-          </a:p>
-        </p:txBody>
-      </p:sp>
-      <p:sp>
-        <p:nvSpPr>
-          <p:cNvPr id="14" name="">
-            <a:extLst xmlns:a="http://schemas.openxmlformats.org/drawingml/2006/main">
-              <a:ext uri="{FF2B5EF4-FFF2-40B4-BE49-F238E27FC236}">
-                <a16:creationId xmlns:a16="http://schemas.microsoft.com/office/drawing/2014/main" id="{7824FB04-0FA1-440E-8E32-DDAF095FC1A6}"/>
-              </a:ext>
-            </a:extLst>
-          </p:cNvPr>
-          <p:cNvSpPr>
-            <a:spLocks xmlns:a="http://schemas.openxmlformats.org/drawingml/2006/main" noGrp="1"/>
-          </p:cNvSpPr>
-          <p:nvPr/>
-        </p:nvSpPr>
-        <p:spPr>
-          <a:xfrm xmlns:a="http://schemas.openxmlformats.org/drawingml/2006/main">
-            <a:off x="7429500" y="5143500"/>
-            <a:ext cx="3095625" cy="266700"/>
-          </a:xfrm>
-          <a:prstGeom xmlns:a="http://schemas.openxmlformats.org/drawingml/2006/main" prst="rect">
-            <a:avLst/>
-          </a:prstGeom>
-          <a:noFill xmlns:a="http://schemas.openxmlformats.org/drawingml/2006/main"/>
-          <a:ln xmlns:a="http://schemas.openxmlformats.org/drawingml/2006/main" w="0">
-            <a:noFill/>
-          </a:ln>
-        </p:spPr>
-        <p:txBody>
-          <a:bodyPr xmlns:a="http://schemas.openxmlformats.org/drawingml/2006/main" lIns="0" tIns="0" rIns="0" bIns="0" anchor="t">
-            <a:normAutofit fontScale="100000"/>
-          </a:bodyPr>
-          <a:lstStyle xmlns:a="http://schemas.openxmlformats.org/drawingml/2006/main"/>
-          <a:p xmlns:a="http://schemas.openxmlformats.org/drawingml/2006/main">
-            <a:pPr marL="0" indent="0" algn="l">
-              <a:spcBef>
-                <a:spcPts val="0"/>
-              </a:spcBef>
-              <a:spcAft>
-                <a:spcPts val="0"/>
-              </a:spcAft>
-              <a:buNone/>
-              <a:defRPr sz="1575">
-                <a:solidFill>
-                  <a:srgbClr val="0A2D22"/>
-                </a:solidFill>
-                <a:latin typeface="Inter Medium"/>
-                <a:ea typeface="Inter Medium"/>
-                <a:cs typeface="Inter Medium"/>
-              </a:defRPr>
-            </a:pPr>
-            <a:r>
-              <a:t>QBR</a:t>
-            </a:r>
-          </a:p>
-        </p:txBody>
-      </p:sp>
-      <p:sp>
-        <p:nvSpPr>
-          <p:cNvPr id="15" name="">
-            <a:extLst xmlns:a="http://schemas.openxmlformats.org/drawingml/2006/main">
-              <a:ext uri="{FF2B5EF4-FFF2-40B4-BE49-F238E27FC236}">
-                <a16:creationId xmlns:a16="http://schemas.microsoft.com/office/drawing/2014/main" id="{9FD69097-4C6E-446F-BD2C-2993BA014CC4}"/>
-              </a:ext>
-            </a:extLst>
-          </p:cNvPr>
-          <p:cNvSpPr>
-            <a:spLocks xmlns:a="http://schemas.openxmlformats.org/drawingml/2006/main" noGrp="1"/>
-          </p:cNvSpPr>
-          <p:nvPr/>
-        </p:nvSpPr>
-        <p:spPr>
-          <a:xfrm xmlns:a="http://schemas.openxmlformats.org/drawingml/2006/main">
-            <a:off x="7429500" y="5476875"/>
-            <a:ext cx="3095625" cy="523875"/>
-          </a:xfrm>
-          <a:prstGeom xmlns:a="http://schemas.openxmlformats.org/drawingml/2006/main" prst="rect">
-            <a:avLst/>
-          </a:prstGeom>
-          <a:noFill xmlns:a="http://schemas.openxmlformats.org/drawingml/2006/main"/>
-          <a:ln xmlns:a="http://schemas.openxmlformats.org/drawingml/2006/main" w="0">
-            <a:noFill/>
-          </a:ln>
-        </p:spPr>
-        <p:txBody>
-          <a:bodyPr xmlns:a="http://schemas.openxmlformats.org/drawingml/2006/main" lIns="0" tIns="0" rIns="0" bIns="0" anchor="t">
-            <a:normAutofit fontScale="100000"/>
-          </a:bodyPr>
-          <a:lstStyle xmlns:a="http://schemas.openxmlformats.org/drawingml/2006/main"/>
-          <a:p xmlns:a="http://schemas.openxmlformats.org/drawingml/2006/main">
-            <a:pPr marL="0" indent="0" algn="l">
-              <a:spcBef>
-                <a:spcPts val="0"/>
-              </a:spcBef>
-              <a:spcAft>
-                <a:spcPts val="0"/>
-              </a:spcAft>
-              <a:buNone/>
-              <a:defRPr sz="1275">
-                <a:solidFill>
-                  <a:srgbClr val="0A2D22"/>
-                </a:solidFill>
-                <a:latin typeface="Inter"/>
-                <a:ea typeface="Inter"/>
-                <a:cs typeface="Inter"/>
-              </a:defRPr>
-            </a:pPr>
-            <a:r>
-              <a:t>Althea Cassidy (Customer Success)</a:t>
-            </a:r>
-          </a:p>
-          <a:p xmlns:a="http://schemas.openxmlformats.org/drawingml/2006/main">
-            <a:pPr marL="0" indent="0" algn="l">
-              <a:spcBef>
-                <a:spcPts val="0"/>
-              </a:spcBef>
-              <a:spcAft>
-                <a:spcPts val="0"/>
-              </a:spcAft>
-              <a:buNone/>
-              <a:defRPr sz="1275">
-                <a:solidFill>
-                  <a:srgbClr val="0A2D22"/>
-                </a:solidFill>
-                <a:latin typeface="Inter"/>
-                <a:ea typeface="Inter"/>
-                <a:cs typeface="Inter"/>
-              </a:defRPr>
-            </a:pPr>
-            <a:r>
-              <a:t>Due: Not confirmed [S3]</a:t>
+              <a:t>Due: Not Confirmed</a:t>
             </a:r>
           </a:p>
         </p:txBody>
@@ -5633,7 +5119,7 @@
           <p:cNvPr id="13" name="">
             <a:extLst xmlns:a="http://schemas.openxmlformats.org/drawingml/2006/main">
               <a:ext uri="{FF2B5EF4-FFF2-40B4-BE49-F238E27FC236}">
-                <a16:creationId xmlns:a16="http://schemas.microsoft.com/office/drawing/2014/main" id="{64A02778-D709-45E3-82B3-AF3AC7DB8F7D}"/>
+                <a16:creationId xmlns:a16="http://schemas.microsoft.com/office/drawing/2014/main" id="{C39E55FA-F7BB-4698-8308-B4D5BE955188}"/>
               </a:ext>
             </a:extLst>
           </p:cNvPr>
@@ -5679,7 +5165,7 @@
               </a:defRPr>
             </a:pPr>
             <a:r>
-              <a:t>THE ACCOUNT KEEPS ITS PRIOR CONTEXT</a:t>
+              <a:t>RECORDED MILESTONES</a:t>
             </a:r>
           </a:p>
         </p:txBody>
@@ -5689,7 +5175,7 @@
           <p:cNvPr id="2" name="">
             <a:extLst xmlns:a="http://schemas.openxmlformats.org/drawingml/2006/main">
               <a:ext uri="{FF2B5EF4-FFF2-40B4-BE49-F238E27FC236}">
-                <a16:creationId xmlns:a16="http://schemas.microsoft.com/office/drawing/2014/main" id="{36CD3ADA-869B-426B-8C38-6FCD76128824}"/>
+                <a16:creationId xmlns:a16="http://schemas.microsoft.com/office/drawing/2014/main" id="{DD386140-B344-4241-B152-8DF20223B75B}"/>
               </a:ext>
             </a:extLst>
           </p:cNvPr>
@@ -5735,7 +5221,7 @@
               </a:defRPr>
             </a:pPr>
             <a:r>
-              <a:t>Recorded handoff history</a:t>
+              <a:t>Dates and handoff data</a:t>
             </a:r>
           </a:p>
         </p:txBody>
@@ -5745,7 +5231,7 @@
           <p:cNvPr id="3" name="">
             <a:extLst xmlns:a="http://schemas.openxmlformats.org/drawingml/2006/main">
               <a:ext uri="{FF2B5EF4-FFF2-40B4-BE49-F238E27FC236}">
-                <a16:creationId xmlns:a16="http://schemas.microsoft.com/office/drawing/2014/main" id="{5609CCE8-8F0E-4945-A15A-28AAD710A942}"/>
+                <a16:creationId xmlns:a16="http://schemas.microsoft.com/office/drawing/2014/main" id="{9EBB5965-C2F0-4301-8098-56D8B6FF6CCB}"/>
               </a:ext>
             </a:extLst>
           </p:cNvPr>
@@ -5801,7 +5287,7 @@
           <p:cNvPr id="4" name="">
             <a:extLst xmlns:a="http://schemas.openxmlformats.org/drawingml/2006/main">
               <a:ext uri="{FF2B5EF4-FFF2-40B4-BE49-F238E27FC236}">
-                <a16:creationId xmlns:a16="http://schemas.microsoft.com/office/drawing/2014/main" id="{CDD103F4-CC09-420D-975E-01C53607D9C9}"/>
+                <a16:creationId xmlns:a16="http://schemas.microsoft.com/office/drawing/2014/main" id="{B589D615-B9EB-4469-A89F-761A5BCB2AA3}"/>
               </a:ext>
             </a:extLst>
           </p:cNvPr>
@@ -5857,7 +5343,7 @@
           <p:cNvPr id="5" name="">
             <a:extLst xmlns:a="http://schemas.openxmlformats.org/drawingml/2006/main">
               <a:ext uri="{FF2B5EF4-FFF2-40B4-BE49-F238E27FC236}">
-                <a16:creationId xmlns:a16="http://schemas.microsoft.com/office/drawing/2014/main" id="{506540A1-7683-4A7E-A15D-A1ABE0C38EFE}"/>
+                <a16:creationId xmlns:a16="http://schemas.microsoft.com/office/drawing/2014/main" id="{7E5FD9ED-5F1B-452F-8D89-10E368199227}"/>
               </a:ext>
             </a:extLst>
           </p:cNvPr>
@@ -5868,7 +5354,7 @@
         </p:nvSpPr>
         <p:spPr>
           <a:xfrm xmlns:a="http://schemas.openxmlformats.org/drawingml/2006/main">
-            <a:off x="666750" y="2476500"/>
+            <a:off x="666750" y="2333625"/>
             <a:ext cx="1809750" cy="304800"/>
           </a:xfrm>
           <a:prstGeom xmlns:a="http://schemas.openxmlformats.org/drawingml/2006/main" prst="rect">
@@ -5913,7 +5399,7 @@
           <p:cNvPr id="6" name="">
             <a:extLst xmlns:a="http://schemas.openxmlformats.org/drawingml/2006/main">
               <a:ext uri="{FF2B5EF4-FFF2-40B4-BE49-F238E27FC236}">
-                <a16:creationId xmlns:a16="http://schemas.microsoft.com/office/drawing/2014/main" id="{C3AA5BBE-E1FE-419E-824B-46C9DA20AEA1}"/>
+                <a16:creationId xmlns:a16="http://schemas.microsoft.com/office/drawing/2014/main" id="{B2715C44-3EE6-43E1-B5CA-4E8FB90AC710}"/>
               </a:ext>
             </a:extLst>
           </p:cNvPr>
@@ -5924,7 +5410,7 @@
         </p:nvSpPr>
         <p:spPr>
           <a:xfrm xmlns:a="http://schemas.openxmlformats.org/drawingml/2006/main">
-            <a:off x="2667000" y="2476500"/>
+            <a:off x="2667000" y="2333625"/>
             <a:ext cx="4191000" cy="304800"/>
           </a:xfrm>
           <a:prstGeom xmlns:a="http://schemas.openxmlformats.org/drawingml/2006/main" prst="rect">
@@ -5969,7 +5455,7 @@
           <p:cNvPr id="7" name="">
             <a:extLst xmlns:a="http://schemas.openxmlformats.org/drawingml/2006/main">
               <a:ext uri="{FF2B5EF4-FFF2-40B4-BE49-F238E27FC236}">
-                <a16:creationId xmlns:a16="http://schemas.microsoft.com/office/drawing/2014/main" id="{2C5F39A7-CC50-4363-B5B6-1E7A8F12D399}"/>
+                <a16:creationId xmlns:a16="http://schemas.microsoft.com/office/drawing/2014/main" id="{69C364A9-3434-4237-B7A9-810972098B1B}"/>
               </a:ext>
             </a:extLst>
           </p:cNvPr>
@@ -5980,7 +5466,7 @@
         </p:nvSpPr>
         <p:spPr>
           <a:xfrm xmlns:a="http://schemas.openxmlformats.org/drawingml/2006/main">
-            <a:off x="8572500" y="2476500"/>
+            <a:off x="8572500" y="2333625"/>
             <a:ext cx="2095500" cy="304800"/>
           </a:xfrm>
           <a:prstGeom xmlns:a="http://schemas.openxmlformats.org/drawingml/2006/main" prst="rect">
@@ -6025,7 +5511,7 @@
           <p:cNvPr id="8" name="">
             <a:extLst xmlns:a="http://schemas.openxmlformats.org/drawingml/2006/main">
               <a:ext uri="{FF2B5EF4-FFF2-40B4-BE49-F238E27FC236}">
-                <a16:creationId xmlns:a16="http://schemas.microsoft.com/office/drawing/2014/main" id="{CD8EE8E8-BAB9-4518-B562-79E4E6B2F303}"/>
+                <a16:creationId xmlns:a16="http://schemas.microsoft.com/office/drawing/2014/main" id="{A6CB9235-AB2A-4532-88EF-3DA6B8485B00}"/>
               </a:ext>
             </a:extLst>
           </p:cNvPr>
@@ -6036,8 +5522,8 @@
         </p:nvSpPr>
         <p:spPr>
           <a:xfrm xmlns:a="http://schemas.openxmlformats.org/drawingml/2006/main">
-            <a:off x="2667000" y="2971800"/>
-            <a:ext cx="7905750" cy="904875"/>
+            <a:off x="2667000" y="2790825"/>
+            <a:ext cx="7905750" cy="781050"/>
           </a:xfrm>
           <a:prstGeom xmlns:a="http://schemas.openxmlformats.org/drawingml/2006/main" prst="rect">
             <a:avLst/>
@@ -6061,7 +5547,7 @@
                 <a:spcPts val="0"/>
               </a:spcAft>
               <a:buNone/>
-              <a:defRPr sz="1575">
+              <a:defRPr sz="1500">
                 <a:solidFill>
                   <a:srgbClr val="FFFFFF"/>
                 </a:solidFill>
@@ -6081,7 +5567,7 @@
           <p:cNvPr id="9" name="">
             <a:extLst xmlns:a="http://schemas.openxmlformats.org/drawingml/2006/main">
               <a:ext uri="{FF2B5EF4-FFF2-40B4-BE49-F238E27FC236}">
-                <a16:creationId xmlns:a16="http://schemas.microsoft.com/office/drawing/2014/main" id="{524B5A93-B5E5-4499-B24A-0BF05C071A3A}"/>
+                <a16:creationId xmlns:a16="http://schemas.microsoft.com/office/drawing/2014/main" id="{6C205D0E-5423-4B38-ADD6-D74376256FD3}"/>
               </a:ext>
             </a:extLst>
           </p:cNvPr>
@@ -6092,7 +5578,7 @@
         </p:nvSpPr>
         <p:spPr>
           <a:xfrm xmlns:a="http://schemas.openxmlformats.org/drawingml/2006/main">
-            <a:off x="666750" y="4238625"/>
+            <a:off x="666750" y="3952875"/>
             <a:ext cx="1809750" cy="304800"/>
           </a:xfrm>
           <a:prstGeom xmlns:a="http://schemas.openxmlformats.org/drawingml/2006/main" prst="rect">
@@ -6137,7 +5623,7 @@
           <p:cNvPr id="10" name="">
             <a:extLst xmlns:a="http://schemas.openxmlformats.org/drawingml/2006/main">
               <a:ext uri="{FF2B5EF4-FFF2-40B4-BE49-F238E27FC236}">
-                <a16:creationId xmlns:a16="http://schemas.microsoft.com/office/drawing/2014/main" id="{02274432-81FD-4D78-BACF-74B7828732CE}"/>
+                <a16:creationId xmlns:a16="http://schemas.microsoft.com/office/drawing/2014/main" id="{C126F0CC-A469-44B1-8BE7-3101D9097158}"/>
               </a:ext>
             </a:extLst>
           </p:cNvPr>
@@ -6148,7 +5634,7 @@
         </p:nvSpPr>
         <p:spPr>
           <a:xfrm xmlns:a="http://schemas.openxmlformats.org/drawingml/2006/main">
-            <a:off x="2667000" y="4238625"/>
+            <a:off x="2667000" y="3952875"/>
             <a:ext cx="4191000" cy="304800"/>
           </a:xfrm>
           <a:prstGeom xmlns:a="http://schemas.openxmlformats.org/drawingml/2006/main" prst="rect">
@@ -6193,7 +5679,7 @@
           <p:cNvPr id="11" name="">
             <a:extLst xmlns:a="http://schemas.openxmlformats.org/drawingml/2006/main">
               <a:ext uri="{FF2B5EF4-FFF2-40B4-BE49-F238E27FC236}">
-                <a16:creationId xmlns:a16="http://schemas.microsoft.com/office/drawing/2014/main" id="{DED401EC-66A5-49AD-8606-516EC3E3E79B}"/>
+                <a16:creationId xmlns:a16="http://schemas.microsoft.com/office/drawing/2014/main" id="{A58713B0-490C-4883-94B5-EF2E2EB041B7}"/>
               </a:ext>
             </a:extLst>
           </p:cNvPr>
@@ -6204,7 +5690,7 @@
         </p:nvSpPr>
         <p:spPr>
           <a:xfrm xmlns:a="http://schemas.openxmlformats.org/drawingml/2006/main">
-            <a:off x="8572500" y="4238625"/>
+            <a:off x="8572500" y="3952875"/>
             <a:ext cx="2095500" cy="304800"/>
           </a:xfrm>
           <a:prstGeom xmlns:a="http://schemas.openxmlformats.org/drawingml/2006/main" prst="rect">
@@ -6249,7 +5735,7 @@
           <p:cNvPr id="12" name="">
             <a:extLst xmlns:a="http://schemas.openxmlformats.org/drawingml/2006/main">
               <a:ext uri="{FF2B5EF4-FFF2-40B4-BE49-F238E27FC236}">
-                <a16:creationId xmlns:a16="http://schemas.microsoft.com/office/drawing/2014/main" id="{DC2B5DCC-C90A-469F-8544-A03B0204CD8A}"/>
+                <a16:creationId xmlns:a16="http://schemas.microsoft.com/office/drawing/2014/main" id="{132E7D19-DB13-46BC-AAF7-711F288B6980}"/>
               </a:ext>
             </a:extLst>
           </p:cNvPr>
@@ -6260,8 +5746,8 @@
         </p:nvSpPr>
         <p:spPr>
           <a:xfrm xmlns:a="http://schemas.openxmlformats.org/drawingml/2006/main">
-            <a:off x="2667000" y="4733925"/>
-            <a:ext cx="7905750" cy="904875"/>
+            <a:off x="2667000" y="4410075"/>
+            <a:ext cx="7905750" cy="781050"/>
           </a:xfrm>
           <a:prstGeom xmlns:a="http://schemas.openxmlformats.org/drawingml/2006/main" prst="rect">
             <a:avLst/>
@@ -6285,7 +5771,7 @@
                 <a:spcPts val="0"/>
               </a:spcAft>
               <a:buNone/>
-              <a:defRPr sz="1575">
+              <a:defRPr sz="1500">
                 <a:solidFill>
                   <a:srgbClr val="FFFFFF"/>
                 </a:solidFill>
@@ -6296,1608 +5782,6 @@
             </a:pPr>
             <a:r>
               <a:t>Ruben Cherise hands the account to Althea Cassidy. Six venues are reporting and 96% of priority alerts arrive within 15 minutes. Training and QBR dates remain unconfirmed; the Dec 18 goal remains open. [S1, S3]</a:t>
-            </a:r>
-          </a:p>
-        </p:txBody>
-      </p:sp>
-    </p:spTree>
-    <p:extLst>
-      <p:ext uri="{BB962C8B-B14F-4D97-AF65-F5344CB8AC3E}">
-        <p14:creationId xmlns:p14="http://schemas.microsoft.com/office/powerpoint/2010/main" val="360145486"/>
-      </p:ext>
-    </p:extLst>
-  </p:cSld>
-</p:sld>
-</file>
-
-<file path=ppt/slides/slide4.xml><?xml version="1.0" encoding="utf-8"?>
-<p:sld xmlns:p="http://schemas.openxmlformats.org/presentationml/2006/main">
-  <p:cSld>
-    <p:bg>
-      <p:bgPr>
-        <a:solidFill xmlns:a="http://schemas.openxmlformats.org/drawingml/2006/main">
-          <a:srgbClr val="F7F4ED"/>
-        </a:solidFill>
-      </p:bgPr>
-    </p:bg>
-    <p:spTree>
-      <p:nvGrpSpPr>
-        <p:cNvPr id="1" name=""/>
-        <p:cNvGrpSpPr/>
-        <p:nvPr/>
-      </p:nvGrpSpPr>
-      <p:grpSpPr>
-        <a:xfrm xmlns:a="http://schemas.openxmlformats.org/drawingml/2006/main"/>
-      </p:grpSpPr>
-      <p:sp>
-        <p:nvSpPr>
-          <p:cNvPr id="14" name="">
-            <a:extLst xmlns:a="http://schemas.openxmlformats.org/drawingml/2006/main">
-              <a:ext uri="{FF2B5EF4-FFF2-40B4-BE49-F238E27FC236}">
-                <a16:creationId xmlns:a16="http://schemas.microsoft.com/office/drawing/2014/main" id="{21F8E653-B4A0-4DD7-859F-A411B2C61FD5}"/>
-              </a:ext>
-            </a:extLst>
-          </p:cNvPr>
-          <p:cNvSpPr>
-            <a:spLocks xmlns:a="http://schemas.openxmlformats.org/drawingml/2006/main" noGrp="1"/>
-          </p:cNvSpPr>
-          <p:nvPr/>
-        </p:nvSpPr>
-        <p:spPr>
-          <a:xfrm xmlns:a="http://schemas.openxmlformats.org/drawingml/2006/main">
-            <a:off x="666750" y="476250"/>
-            <a:ext cx="10477500" cy="247650"/>
-          </a:xfrm>
-          <a:prstGeom xmlns:a="http://schemas.openxmlformats.org/drawingml/2006/main" prst="rect">
-            <a:avLst/>
-          </a:prstGeom>
-          <a:noFill xmlns:a="http://schemas.openxmlformats.org/drawingml/2006/main"/>
-          <a:ln xmlns:a="http://schemas.openxmlformats.org/drawingml/2006/main" w="0">
-            <a:noFill/>
-          </a:ln>
-        </p:spPr>
-        <p:txBody>
-          <a:bodyPr xmlns:a="http://schemas.openxmlformats.org/drawingml/2006/main" lIns="0" tIns="0" rIns="0" bIns="0" anchor="t">
-            <a:normAutofit fontScale="100000"/>
-          </a:bodyPr>
-          <a:lstStyle xmlns:a="http://schemas.openxmlformats.org/drawingml/2006/main"/>
-          <a:p xmlns:a="http://schemas.openxmlformats.org/drawingml/2006/main">
-            <a:pPr marL="0" indent="0" algn="l">
-              <a:spcBef>
-                <a:spcPts val="0"/>
-              </a:spcBef>
-              <a:spcAft>
-                <a:spcPts val="0"/>
-              </a:spcAft>
-              <a:buNone/>
-              <a:defRPr sz="1125">
-                <a:solidFill>
-                  <a:srgbClr val="4A7A1D"/>
-                </a:solidFill>
-                <a:latin typeface="Inter Medium"/>
-                <a:ea typeface="Inter Medium"/>
-                <a:cs typeface="Inter Medium"/>
-              </a:defRPr>
-            </a:pPr>
-            <a:r>
-              <a:t>HISTORICAL HANDOFF RECORD</a:t>
-            </a:r>
-          </a:p>
-        </p:txBody>
-      </p:sp>
-      <p:sp>
-        <p:nvSpPr>
-          <p:cNvPr id="2" name="">
-            <a:extLst xmlns:a="http://schemas.openxmlformats.org/drawingml/2006/main">
-              <a:ext uri="{FF2B5EF4-FFF2-40B4-BE49-F238E27FC236}">
-                <a16:creationId xmlns:a16="http://schemas.microsoft.com/office/drawing/2014/main" id="{846D1BD7-A650-4136-B15B-EA14174E7AED}"/>
-              </a:ext>
-            </a:extLst>
-          </p:cNvPr>
-          <p:cNvSpPr>
-            <a:spLocks xmlns:a="http://schemas.openxmlformats.org/drawingml/2006/main" noGrp="1"/>
-          </p:cNvSpPr>
-          <p:nvPr/>
-        </p:nvSpPr>
-        <p:spPr>
-          <a:xfrm xmlns:a="http://schemas.openxmlformats.org/drawingml/2006/main">
-            <a:off x="666750" y="876300"/>
-            <a:ext cx="10668000" cy="971550"/>
-          </a:xfrm>
-          <a:prstGeom xmlns:a="http://schemas.openxmlformats.org/drawingml/2006/main" prst="rect">
-            <a:avLst/>
-          </a:prstGeom>
-          <a:noFill xmlns:a="http://schemas.openxmlformats.org/drawingml/2006/main"/>
-          <a:ln xmlns:a="http://schemas.openxmlformats.org/drawingml/2006/main" w="0">
-            <a:noFill/>
-          </a:ln>
-        </p:spPr>
-        <p:txBody>
-          <a:bodyPr xmlns:a="http://schemas.openxmlformats.org/drawingml/2006/main" lIns="0" tIns="0" rIns="0" bIns="0" anchor="t">
-            <a:normAutofit fontScale="100000"/>
-          </a:bodyPr>
-          <a:lstStyle xmlns:a="http://schemas.openxmlformats.org/drawingml/2006/main"/>
-          <a:p xmlns:a="http://schemas.openxmlformats.org/drawingml/2006/main">
-            <a:pPr marL="0" indent="0" algn="l">
-              <a:spcBef>
-                <a:spcPts val="0"/>
-              </a:spcBef>
-              <a:spcAft>
-                <a:spcPts val="0"/>
-              </a:spcAft>
-              <a:buNone/>
-              <a:defRPr sz="3225">
-                <a:solidFill>
-                  <a:srgbClr val="0A2D22"/>
-                </a:solidFill>
-                <a:latin typeface="Inter Medium"/>
-                <a:ea typeface="Inter Medium"/>
-                <a:cs typeface="Inter Medium"/>
-              </a:defRPr>
-            </a:pPr>
-            <a:r>
-              <a:t>2026-09-16: Sales to Implementation</a:t>
-            </a:r>
-          </a:p>
-        </p:txBody>
-      </p:sp>
-      <p:sp>
-        <p:nvSpPr>
-          <p:cNvPr id="3" name="">
-            <a:extLst xmlns:a="http://schemas.openxmlformats.org/drawingml/2006/main">
-              <a:ext uri="{FF2B5EF4-FFF2-40B4-BE49-F238E27FC236}">
-                <a16:creationId xmlns:a16="http://schemas.microsoft.com/office/drawing/2014/main" id="{A3E39FBA-B9E6-428F-BA9D-301AB2C58A8E}"/>
-              </a:ext>
-            </a:extLst>
-          </p:cNvPr>
-          <p:cNvSpPr>
-            <a:spLocks xmlns:a="http://schemas.openxmlformats.org/drawingml/2006/main" noGrp="1"/>
-          </p:cNvSpPr>
-          <p:nvPr/>
-        </p:nvSpPr>
-        <p:spPr>
-          <a:xfrm xmlns:a="http://schemas.openxmlformats.org/drawingml/2006/main">
-            <a:off x="666750" y="6477000"/>
-            <a:ext cx="2476500" cy="171450"/>
-          </a:xfrm>
-          <a:prstGeom xmlns:a="http://schemas.openxmlformats.org/drawingml/2006/main" prst="rect">
-            <a:avLst/>
-          </a:prstGeom>
-          <a:noFill xmlns:a="http://schemas.openxmlformats.org/drawingml/2006/main"/>
-          <a:ln xmlns:a="http://schemas.openxmlformats.org/drawingml/2006/main" w="0">
-            <a:noFill/>
-          </a:ln>
-        </p:spPr>
-        <p:txBody>
-          <a:bodyPr xmlns:a="http://schemas.openxmlformats.org/drawingml/2006/main" lIns="0" tIns="0" rIns="0" bIns="0" anchor="t">
-            <a:normAutofit fontScale="100000"/>
-          </a:bodyPr>
-          <a:lstStyle xmlns:a="http://schemas.openxmlformats.org/drawingml/2006/main"/>
-          <a:p xmlns:a="http://schemas.openxmlformats.org/drawingml/2006/main">
-            <a:pPr marL="0" indent="0" algn="l">
-              <a:spcBef>
-                <a:spcPts val="0"/>
-              </a:spcBef>
-              <a:spcAft>
-                <a:spcPts val="0"/>
-              </a:spcAft>
-              <a:buNone/>
-              <a:defRPr sz="900">
-                <a:solidFill>
-                  <a:srgbClr val="567268"/>
-                </a:solidFill>
-                <a:latin typeface="Inter"/>
-                <a:ea typeface="Inter"/>
-                <a:cs typeface="Inter"/>
-              </a:defRPr>
-            </a:pPr>
-            <a:r>
-              <a:t>BATON   4</a:t>
-            </a:r>
-          </a:p>
-        </p:txBody>
-      </p:sp>
-      <p:sp>
-        <p:nvSpPr>
-          <p:cNvPr id="4" name="">
-            <a:extLst xmlns:a="http://schemas.openxmlformats.org/drawingml/2006/main">
-              <a:ext uri="{FF2B5EF4-FFF2-40B4-BE49-F238E27FC236}">
-                <a16:creationId xmlns:a16="http://schemas.microsoft.com/office/drawing/2014/main" id="{875FC767-C453-4985-8B1C-C74364919BB2}"/>
-              </a:ext>
-            </a:extLst>
-          </p:cNvPr>
-          <p:cNvSpPr>
-            <a:spLocks xmlns:a="http://schemas.openxmlformats.org/drawingml/2006/main" noGrp="1"/>
-          </p:cNvSpPr>
-          <p:nvPr/>
-        </p:nvSpPr>
-        <p:spPr>
-          <a:xfrm xmlns:a="http://schemas.openxmlformats.org/drawingml/2006/main">
-            <a:off x="6762750" y="6477000"/>
-            <a:ext cx="4572000" cy="171450"/>
-          </a:xfrm>
-          <a:prstGeom xmlns:a="http://schemas.openxmlformats.org/drawingml/2006/main" prst="rect">
-            <a:avLst/>
-          </a:prstGeom>
-          <a:noFill xmlns:a="http://schemas.openxmlformats.org/drawingml/2006/main"/>
-          <a:ln xmlns:a="http://schemas.openxmlformats.org/drawingml/2006/main" w="0">
-            <a:noFill/>
-          </a:ln>
-        </p:spPr>
-        <p:txBody>
-          <a:bodyPr xmlns:a="http://schemas.openxmlformats.org/drawingml/2006/main" lIns="0" tIns="0" rIns="0" bIns="0" anchor="t">
-            <a:normAutofit fontScale="100000"/>
-          </a:bodyPr>
-          <a:lstStyle xmlns:a="http://schemas.openxmlformats.org/drawingml/2006/main"/>
-          <a:p xmlns:a="http://schemas.openxmlformats.org/drawingml/2006/main">
-            <a:pPr marL="0" indent="0" algn="r">
-              <a:spcBef>
-                <a:spcPts val="0"/>
-              </a:spcBef>
-              <a:spcAft>
-                <a:spcPts val="0"/>
-              </a:spcAft>
-              <a:buNone/>
-              <a:defRPr sz="900">
-                <a:solidFill>
-                  <a:srgbClr val="567268"/>
-                </a:solidFill>
-                <a:latin typeface="Inter"/>
-                <a:ea typeface="Inter"/>
-                <a:cs typeface="Inter"/>
-              </a:defRPr>
-            </a:pPr>
-            <a:r>
-              <a:t>FICTIONAL, SIMULATED EXAMPLE   2026-12-01</a:t>
-            </a:r>
-          </a:p>
-        </p:txBody>
-      </p:sp>
-      <p:sp>
-        <p:nvSpPr>
-          <p:cNvPr id="5" name="">
-            <a:extLst xmlns:a="http://schemas.openxmlformats.org/drawingml/2006/main">
-              <a:ext uri="{FF2B5EF4-FFF2-40B4-BE49-F238E27FC236}">
-                <a16:creationId xmlns:a16="http://schemas.microsoft.com/office/drawing/2014/main" id="{AAC3D3B0-0319-4816-9266-B7394BBCE2CF}"/>
-              </a:ext>
-            </a:extLst>
-          </p:cNvPr>
-          <p:cNvSpPr>
-            <a:spLocks xmlns:a="http://schemas.openxmlformats.org/drawingml/2006/main" noGrp="1"/>
-          </p:cNvSpPr>
-          <p:nvPr/>
-        </p:nvSpPr>
-        <p:spPr>
-          <a:xfrm xmlns:a="http://schemas.openxmlformats.org/drawingml/2006/main">
-            <a:off x="666750" y="2190750"/>
-            <a:ext cx="2571750" cy="428625"/>
-          </a:xfrm>
-          <a:prstGeom xmlns:a="http://schemas.openxmlformats.org/drawingml/2006/main" prst="rect">
-            <a:avLst/>
-          </a:prstGeom>
-          <a:noFill xmlns:a="http://schemas.openxmlformats.org/drawingml/2006/main"/>
-          <a:ln xmlns:a="http://schemas.openxmlformats.org/drawingml/2006/main" w="0">
-            <a:noFill/>
-          </a:ln>
-        </p:spPr>
-        <p:txBody>
-          <a:bodyPr xmlns:a="http://schemas.openxmlformats.org/drawingml/2006/main" lIns="0" tIns="0" rIns="0" bIns="0" anchor="t">
-            <a:normAutofit fontScale="100000"/>
-          </a:bodyPr>
-          <a:lstStyle xmlns:a="http://schemas.openxmlformats.org/drawingml/2006/main"/>
-          <a:p xmlns:a="http://schemas.openxmlformats.org/drawingml/2006/main">
-            <a:pPr marL="0" indent="0" algn="l">
-              <a:spcBef>
-                <a:spcPts val="0"/>
-              </a:spcBef>
-              <a:spcAft>
-                <a:spcPts val="0"/>
-              </a:spcAft>
-              <a:buNone/>
-              <a:defRPr sz="2625">
-                <a:solidFill>
-                  <a:srgbClr val="4A7A1D"/>
-                </a:solidFill>
-                <a:latin typeface="Inter Medium"/>
-                <a:ea typeface="Inter Medium"/>
-                <a:cs typeface="Inter Medium"/>
-              </a:defRPr>
-            </a:pPr>
-            <a:r>
-              <a:t>Ready</a:t>
-            </a:r>
-          </a:p>
-        </p:txBody>
-      </p:sp>
-      <p:sp>
-        <p:nvSpPr>
-          <p:cNvPr id="6" name="">
-            <a:extLst xmlns:a="http://schemas.openxmlformats.org/drawingml/2006/main">
-              <a:ext uri="{FF2B5EF4-FFF2-40B4-BE49-F238E27FC236}">
-                <a16:creationId xmlns:a16="http://schemas.microsoft.com/office/drawing/2014/main" id="{B8340A3D-6D85-401A-A261-11CDFB322958}"/>
-              </a:ext>
-            </a:extLst>
-          </p:cNvPr>
-          <p:cNvSpPr>
-            <a:spLocks xmlns:a="http://schemas.openxmlformats.org/drawingml/2006/main" noGrp="1"/>
-          </p:cNvSpPr>
-          <p:nvPr/>
-        </p:nvSpPr>
-        <p:spPr>
-          <a:xfrm xmlns:a="http://schemas.openxmlformats.org/drawingml/2006/main">
-            <a:off x="666750" y="2762250"/>
-            <a:ext cx="4476750" cy="1143000"/>
-          </a:xfrm>
-          <a:prstGeom xmlns:a="http://schemas.openxmlformats.org/drawingml/2006/main" prst="rect">
-            <a:avLst/>
-          </a:prstGeom>
-          <a:noFill xmlns:a="http://schemas.openxmlformats.org/drawingml/2006/main"/>
-          <a:ln xmlns:a="http://schemas.openxmlformats.org/drawingml/2006/main" w="0">
-            <a:noFill/>
-          </a:ln>
-        </p:spPr>
-        <p:txBody>
-          <a:bodyPr xmlns:a="http://schemas.openxmlformats.org/drawingml/2006/main" lIns="0" tIns="0" rIns="0" bIns="0" anchor="t">
-            <a:normAutofit fontScale="100000"/>
-          </a:bodyPr>
-          <a:lstStyle xmlns:a="http://schemas.openxmlformats.org/drawingml/2006/main"/>
-          <a:p xmlns:a="http://schemas.openxmlformats.org/drawingml/2006/main">
-            <a:pPr marL="0" indent="0" algn="l">
-              <a:spcBef>
-                <a:spcPts val="0"/>
-              </a:spcBef>
-              <a:spcAft>
-                <a:spcPts val="0"/>
-              </a:spcAft>
-              <a:buNone/>
-              <a:defRPr sz="1650">
-                <a:solidFill>
-                  <a:srgbClr val="0A2D22"/>
-                </a:solidFill>
-                <a:latin typeface="Inter"/>
-                <a:ea typeface="Inter"/>
-                <a:cs typeface="Inter"/>
-              </a:defRPr>
-            </a:pPr>
-            <a:r>
-              <a:t>Samson Delilah to Ruben Cherise</a:t>
-            </a:r>
-          </a:p>
-          <a:p xmlns:a="http://schemas.openxmlformats.org/drawingml/2006/main">
-            <a:pPr marL="0" indent="0" algn="l">
-              <a:spcBef>
-                <a:spcPts val="0"/>
-              </a:spcBef>
-              <a:spcAft>
-                <a:spcPts val="0"/>
-              </a:spcAft>
-              <a:buNone/>
-              <a:defRPr sz="1650">
-                <a:solidFill>
-                  <a:srgbClr val="0A2D22"/>
-                </a:solidFill>
-                <a:latin typeface="Inter"/>
-                <a:ea typeface="Inter"/>
-                <a:cs typeface="Inter"/>
-              </a:defRPr>
-            </a:pPr>
-            <a:r>
-              <a:t>Closed Won purchase moves into the agreed implementation plan. [S1]</a:t>
-            </a:r>
-          </a:p>
-        </p:txBody>
-      </p:sp>
-      <p:sp>
-        <p:nvSpPr>
-          <p:cNvPr id="7" name="">
-            <a:extLst xmlns:a="http://schemas.openxmlformats.org/drawingml/2006/main">
-              <a:ext uri="{FF2B5EF4-FFF2-40B4-BE49-F238E27FC236}">
-                <a16:creationId xmlns:a16="http://schemas.microsoft.com/office/drawing/2014/main" id="{22100AAA-48B2-431B-A96A-82D2C084B849}"/>
-              </a:ext>
-            </a:extLst>
-          </p:cNvPr>
-          <p:cNvSpPr>
-            <a:spLocks xmlns:a="http://schemas.openxmlformats.org/drawingml/2006/main" noGrp="1"/>
-          </p:cNvSpPr>
-          <p:nvPr/>
-        </p:nvSpPr>
-        <p:spPr>
-          <a:xfrm xmlns:a="http://schemas.openxmlformats.org/drawingml/2006/main">
-            <a:off x="5905500" y="2190750"/>
-            <a:ext cx="4762500" cy="247650"/>
-          </a:xfrm>
-          <a:prstGeom xmlns:a="http://schemas.openxmlformats.org/drawingml/2006/main" prst="rect">
-            <a:avLst/>
-          </a:prstGeom>
-          <a:noFill xmlns:a="http://schemas.openxmlformats.org/drawingml/2006/main"/>
-          <a:ln xmlns:a="http://schemas.openxmlformats.org/drawingml/2006/main" w="0">
-            <a:noFill/>
-          </a:ln>
-        </p:spPr>
-        <p:txBody>
-          <a:bodyPr xmlns:a="http://schemas.openxmlformats.org/drawingml/2006/main" lIns="0" tIns="0" rIns="0" bIns="0" anchor="t">
-            <a:normAutofit fontScale="100000"/>
-          </a:bodyPr>
-          <a:lstStyle xmlns:a="http://schemas.openxmlformats.org/drawingml/2006/main"/>
-          <a:p xmlns:a="http://schemas.openxmlformats.org/drawingml/2006/main">
-            <a:pPr marL="0" indent="0" algn="l">
-              <a:spcBef>
-                <a:spcPts val="0"/>
-              </a:spcBef>
-              <a:spcAft>
-                <a:spcPts val="0"/>
-              </a:spcAft>
-              <a:buNone/>
-              <a:defRPr sz="1125">
-                <a:solidFill>
-                  <a:srgbClr val="4A7A1D"/>
-                </a:solidFill>
-                <a:latin typeface="Inter Medium"/>
-                <a:ea typeface="Inter Medium"/>
-                <a:cs typeface="Inter Medium"/>
-              </a:defRPr>
-            </a:pPr>
-            <a:r>
-              <a:t>ASSESSMENT</a:t>
-            </a:r>
-          </a:p>
-        </p:txBody>
-      </p:sp>
-      <p:sp>
-        <p:nvSpPr>
-          <p:cNvPr id="8" name="">
-            <a:extLst xmlns:a="http://schemas.openxmlformats.org/drawingml/2006/main">
-              <a:ext uri="{FF2B5EF4-FFF2-40B4-BE49-F238E27FC236}">
-                <a16:creationId xmlns:a16="http://schemas.microsoft.com/office/drawing/2014/main" id="{DF3FC37A-E0B2-4DB7-88DE-482BC4FB01FC}"/>
-              </a:ext>
-            </a:extLst>
-          </p:cNvPr>
-          <p:cNvSpPr>
-            <a:spLocks xmlns:a="http://schemas.openxmlformats.org/drawingml/2006/main" noGrp="1"/>
-          </p:cNvSpPr>
-          <p:nvPr/>
-        </p:nvSpPr>
-        <p:spPr>
-          <a:xfrm xmlns:a="http://schemas.openxmlformats.org/drawingml/2006/main">
-            <a:off x="5905500" y="2524125"/>
-            <a:ext cx="4762500" cy="1333500"/>
-          </a:xfrm>
-          <a:prstGeom xmlns:a="http://schemas.openxmlformats.org/drawingml/2006/main" prst="rect">
-            <a:avLst/>
-          </a:prstGeom>
-          <a:noFill xmlns:a="http://schemas.openxmlformats.org/drawingml/2006/main"/>
-          <a:ln xmlns:a="http://schemas.openxmlformats.org/drawingml/2006/main" w="0">
-            <a:noFill/>
-          </a:ln>
-        </p:spPr>
-        <p:txBody>
-          <a:bodyPr xmlns:a="http://schemas.openxmlformats.org/drawingml/2006/main" lIns="0" tIns="0" rIns="0" bIns="0" anchor="t">
-            <a:normAutofit fontScale="100000"/>
-          </a:bodyPr>
-          <a:lstStyle xmlns:a="http://schemas.openxmlformats.org/drawingml/2006/main"/>
-          <a:p xmlns:a="http://schemas.openxmlformats.org/drawingml/2006/main">
-            <a:pPr marL="0" indent="0" algn="l">
-              <a:spcBef>
-                <a:spcPts val="0"/>
-              </a:spcBef>
-              <a:spcAft>
-                <a:spcPts val="0"/>
-              </a:spcAft>
-              <a:buNone/>
-              <a:defRPr sz="1575">
-                <a:solidFill>
-                  <a:srgbClr val="0A2D22"/>
-                </a:solidFill>
-                <a:latin typeface="Inter"/>
-                <a:ea typeface="Inter"/>
-                <a:cs typeface="Inter"/>
-              </a:defRPr>
-            </a:pPr>
-            <a:r>
-              <a:t>Agreed owners, rollout dates and measures support implementation. SSO remains a rollout gate; the December investigation-time goal is still due. [S1, S4]</a:t>
-            </a:r>
-          </a:p>
-        </p:txBody>
-      </p:sp>
-      <p:sp>
-        <p:nvSpPr>
-          <p:cNvPr id="9" name="">
-            <a:extLst xmlns:a="http://schemas.openxmlformats.org/drawingml/2006/main">
-              <a:ext uri="{FF2B5EF4-FFF2-40B4-BE49-F238E27FC236}">
-                <a16:creationId xmlns:a16="http://schemas.microsoft.com/office/drawing/2014/main" id="{660C23B3-754D-4CAD-A2A4-F5024BD57F02}"/>
-              </a:ext>
-            </a:extLst>
-          </p:cNvPr>
-          <p:cNvSpPr>
-            <a:spLocks xmlns:a="http://schemas.openxmlformats.org/drawingml/2006/main" noGrp="1"/>
-          </p:cNvSpPr>
-          <p:nvPr/>
-        </p:nvSpPr>
-        <p:spPr>
-          <a:xfrm xmlns:a="http://schemas.openxmlformats.org/drawingml/2006/main">
-            <a:off x="666750" y="4429125"/>
-            <a:ext cx="4476750" cy="247650"/>
-          </a:xfrm>
-          <a:prstGeom xmlns:a="http://schemas.openxmlformats.org/drawingml/2006/main" prst="rect">
-            <a:avLst/>
-          </a:prstGeom>
-          <a:noFill xmlns:a="http://schemas.openxmlformats.org/drawingml/2006/main"/>
-          <a:ln xmlns:a="http://schemas.openxmlformats.org/drawingml/2006/main" w="0">
-            <a:noFill/>
-          </a:ln>
-        </p:spPr>
-        <p:txBody>
-          <a:bodyPr xmlns:a="http://schemas.openxmlformats.org/drawingml/2006/main" lIns="0" tIns="0" rIns="0" bIns="0" anchor="t">
-            <a:normAutofit fontScale="100000"/>
-          </a:bodyPr>
-          <a:lstStyle xmlns:a="http://schemas.openxmlformats.org/drawingml/2006/main"/>
-          <a:p xmlns:a="http://schemas.openxmlformats.org/drawingml/2006/main">
-            <a:pPr marL="0" indent="0" algn="l">
-              <a:spcBef>
-                <a:spcPts val="0"/>
-              </a:spcBef>
-              <a:spcAft>
-                <a:spcPts val="0"/>
-              </a:spcAft>
-              <a:buNone/>
-              <a:defRPr sz="1125">
-                <a:solidFill>
-                  <a:srgbClr val="4A7A1D"/>
-                </a:solidFill>
-                <a:latin typeface="Inter Medium"/>
-                <a:ea typeface="Inter Medium"/>
-                <a:cs typeface="Inter Medium"/>
-              </a:defRPr>
-            </a:pPr>
-            <a:r>
-              <a:t>COMMITMENTS</a:t>
-            </a:r>
-          </a:p>
-        </p:txBody>
-      </p:sp>
-      <p:sp>
-        <p:nvSpPr>
-          <p:cNvPr id="10" name="">
-            <a:extLst xmlns:a="http://schemas.openxmlformats.org/drawingml/2006/main">
-              <a:ext uri="{FF2B5EF4-FFF2-40B4-BE49-F238E27FC236}">
-                <a16:creationId xmlns:a16="http://schemas.microsoft.com/office/drawing/2014/main" id="{7237DACB-B6D5-4B13-B12E-F1748BD217DA}"/>
-              </a:ext>
-            </a:extLst>
-          </p:cNvPr>
-          <p:cNvSpPr>
-            <a:spLocks xmlns:a="http://schemas.openxmlformats.org/drawingml/2006/main" noGrp="1"/>
-          </p:cNvSpPr>
-          <p:nvPr/>
-        </p:nvSpPr>
-        <p:spPr>
-          <a:xfrm xmlns:a="http://schemas.openxmlformats.org/drawingml/2006/main">
-            <a:off x="666750" y="4762500"/>
-            <a:ext cx="4476750" cy="1238250"/>
-          </a:xfrm>
-          <a:prstGeom xmlns:a="http://schemas.openxmlformats.org/drawingml/2006/main" prst="rect">
-            <a:avLst/>
-          </a:prstGeom>
-          <a:noFill xmlns:a="http://schemas.openxmlformats.org/drawingml/2006/main"/>
-          <a:ln xmlns:a="http://schemas.openxmlformats.org/drawingml/2006/main" w="0">
-            <a:noFill/>
-          </a:ln>
-        </p:spPr>
-        <p:txBody>
-          <a:bodyPr xmlns:a="http://schemas.openxmlformats.org/drawingml/2006/main" lIns="0" tIns="0" rIns="0" bIns="0" anchor="t">
-            <a:normAutofit fontScale="100000"/>
-          </a:bodyPr>
-          <a:lstStyle xmlns:a="http://schemas.openxmlformats.org/drawingml/2006/main"/>
-          <a:p xmlns:a="http://schemas.openxmlformats.org/drawingml/2006/main">
-            <a:pPr marL="0" indent="0" algn="l">
-              <a:spcBef>
-                <a:spcPts val="0"/>
-              </a:spcBef>
-              <a:spcAft>
-                <a:spcPts val="0"/>
-              </a:spcAft>
-              <a:buNone/>
-              <a:defRPr sz="1575">
-                <a:solidFill>
-                  <a:srgbClr val="0A2D22"/>
-                </a:solidFill>
-                <a:latin typeface="Inter"/>
-                <a:ea typeface="Inter"/>
-                <a:cs typeface="Inter"/>
-              </a:defRPr>
-            </a:pPr>
-            <a:r>
-              <a:t>SSO Oct 2; corporate pilot Oct 5; venues Nov 2–30. By Dec 18, mean investigation time ≤42 minutes from a 60-minute baseline. [S4]</a:t>
-            </a:r>
-          </a:p>
-        </p:txBody>
-      </p:sp>
-      <p:sp>
-        <p:nvSpPr>
-          <p:cNvPr id="11" name="">
-            <a:extLst xmlns:a="http://schemas.openxmlformats.org/drawingml/2006/main">
-              <a:ext uri="{FF2B5EF4-FFF2-40B4-BE49-F238E27FC236}">
-                <a16:creationId xmlns:a16="http://schemas.microsoft.com/office/drawing/2014/main" id="{AEB12819-764A-486A-80BC-3EB3671C1232}"/>
-              </a:ext>
-            </a:extLst>
-          </p:cNvPr>
-          <p:cNvSpPr>
-            <a:spLocks xmlns:a="http://schemas.openxmlformats.org/drawingml/2006/main" noGrp="1"/>
-          </p:cNvSpPr>
-          <p:nvPr/>
-        </p:nvSpPr>
-        <p:spPr>
-          <a:xfrm xmlns:a="http://schemas.openxmlformats.org/drawingml/2006/main">
-            <a:off x="5905500" y="4429125"/>
-            <a:ext cx="4762500" cy="247650"/>
-          </a:xfrm>
-          <a:prstGeom xmlns:a="http://schemas.openxmlformats.org/drawingml/2006/main" prst="rect">
-            <a:avLst/>
-          </a:prstGeom>
-          <a:noFill xmlns:a="http://schemas.openxmlformats.org/drawingml/2006/main"/>
-          <a:ln xmlns:a="http://schemas.openxmlformats.org/drawingml/2006/main" w="0">
-            <a:noFill/>
-          </a:ln>
-        </p:spPr>
-        <p:txBody>
-          <a:bodyPr xmlns:a="http://schemas.openxmlformats.org/drawingml/2006/main" lIns="0" tIns="0" rIns="0" bIns="0" anchor="t">
-            <a:normAutofit fontScale="100000"/>
-          </a:bodyPr>
-          <a:lstStyle xmlns:a="http://schemas.openxmlformats.org/drawingml/2006/main"/>
-          <a:p xmlns:a="http://schemas.openxmlformats.org/drawingml/2006/main">
-            <a:pPr marL="0" indent="0" algn="l">
-              <a:spcBef>
-                <a:spcPts val="0"/>
-              </a:spcBef>
-              <a:spcAft>
-                <a:spcPts val="0"/>
-              </a:spcAft>
-              <a:buNone/>
-              <a:defRPr sz="1125">
-                <a:solidFill>
-                  <a:srgbClr val="4A7A1D"/>
-                </a:solidFill>
-                <a:latin typeface="Inter Medium"/>
-                <a:ea typeface="Inter Medium"/>
-                <a:cs typeface="Inter Medium"/>
-              </a:defRPr>
-            </a:pPr>
-            <a:r>
-              <a:t>OPEN QUESTIONS AND RISKS</a:t>
-            </a:r>
-          </a:p>
-        </p:txBody>
-      </p:sp>
-      <p:sp>
-        <p:nvSpPr>
-          <p:cNvPr id="12" name="">
-            <a:extLst xmlns:a="http://schemas.openxmlformats.org/drawingml/2006/main">
-              <a:ext uri="{FF2B5EF4-FFF2-40B4-BE49-F238E27FC236}">
-                <a16:creationId xmlns:a16="http://schemas.microsoft.com/office/drawing/2014/main" id="{CDCCEB2E-9D4A-4BB1-A6E4-C9BBD5955513}"/>
-              </a:ext>
-            </a:extLst>
-          </p:cNvPr>
-          <p:cNvSpPr>
-            <a:spLocks xmlns:a="http://schemas.openxmlformats.org/drawingml/2006/main" noGrp="1"/>
-          </p:cNvSpPr>
-          <p:nvPr/>
-        </p:nvSpPr>
-        <p:spPr>
-          <a:xfrm xmlns:a="http://schemas.openxmlformats.org/drawingml/2006/main">
-            <a:off x="5905500" y="4762500"/>
-            <a:ext cx="4762500" cy="1238250"/>
-          </a:xfrm>
-          <a:prstGeom xmlns:a="http://schemas.openxmlformats.org/drawingml/2006/main" prst="rect">
-            <a:avLst/>
-          </a:prstGeom>
-          <a:noFill xmlns:a="http://schemas.openxmlformats.org/drawingml/2006/main"/>
-          <a:ln xmlns:a="http://schemas.openxmlformats.org/drawingml/2006/main" w="0">
-            <a:noFill/>
-          </a:ln>
-        </p:spPr>
-        <p:txBody>
-          <a:bodyPr xmlns:a="http://schemas.openxmlformats.org/drawingml/2006/main" lIns="0" tIns="0" rIns="0" bIns="0" anchor="t">
-            <a:normAutofit fontScale="100000"/>
-          </a:bodyPr>
-          <a:lstStyle xmlns:a="http://schemas.openxmlformats.org/drawingml/2006/main"/>
-          <a:p xmlns:a="http://schemas.openxmlformats.org/drawingml/2006/main">
-            <a:pPr marL="0" indent="0" algn="l">
-              <a:spcBef>
-                <a:spcPts val="0"/>
-              </a:spcBef>
-              <a:spcAft>
-                <a:spcPts val="0"/>
-              </a:spcAft>
-              <a:buNone/>
-              <a:defRPr sz="1575">
-                <a:solidFill>
-                  <a:srgbClr val="0A2D22"/>
-                </a:solidFill>
-                <a:latin typeface="Inter"/>
-                <a:ea typeface="Inter"/>
-                <a:cs typeface="Inter"/>
-              </a:defRPr>
-            </a:pPr>
-            <a:r>
-              <a:t>SSO must pass before broad rollout; identity work needs two weeks’ notice. [S4]</a:t>
-            </a:r>
-          </a:p>
-        </p:txBody>
-      </p:sp>
-      <p:sp>
-        <p:nvSpPr>
-          <p:cNvPr id="13" name="">
-            <a:extLst xmlns:a="http://schemas.openxmlformats.org/drawingml/2006/main">
-              <a:ext uri="{FF2B5EF4-FFF2-40B4-BE49-F238E27FC236}">
-                <a16:creationId xmlns:a16="http://schemas.microsoft.com/office/drawing/2014/main" id="{8641ADC4-69E5-4EF5-8BE6-C878D77469E6}"/>
-              </a:ext>
-            </a:extLst>
-          </p:cNvPr>
-          <p:cNvSpPr>
-            <a:spLocks xmlns:a="http://schemas.openxmlformats.org/drawingml/2006/main" noGrp="1"/>
-          </p:cNvSpPr>
-          <p:nvPr/>
-        </p:nvSpPr>
-        <p:spPr>
-          <a:xfrm xmlns:a="http://schemas.openxmlformats.org/drawingml/2006/main">
-            <a:off x="666750" y="6191250"/>
-            <a:ext cx="5715000" cy="190500"/>
-          </a:xfrm>
-          <a:prstGeom xmlns:a="http://schemas.openxmlformats.org/drawingml/2006/main" prst="rect">
-            <a:avLst/>
-          </a:prstGeom>
-          <a:noFill xmlns:a="http://schemas.openxmlformats.org/drawingml/2006/main"/>
-          <a:ln xmlns:a="http://schemas.openxmlformats.org/drawingml/2006/main" w="0">
-            <a:noFill/>
-          </a:ln>
-        </p:spPr>
-        <p:txBody>
-          <a:bodyPr xmlns:a="http://schemas.openxmlformats.org/drawingml/2006/main" lIns="0" tIns="0" rIns="0" bIns="0" anchor="t">
-            <a:normAutofit fontScale="100000"/>
-          </a:bodyPr>
-          <a:lstStyle xmlns:a="http://schemas.openxmlformats.org/drawingml/2006/main"/>
-          <a:p xmlns:a="http://schemas.openxmlformats.org/drawingml/2006/main">
-            <a:pPr marL="0" indent="0" algn="l">
-              <a:spcBef>
-                <a:spcPts val="0"/>
-              </a:spcBef>
-              <a:spcAft>
-                <a:spcPts val="0"/>
-              </a:spcAft>
-              <a:buNone/>
-              <a:defRPr sz="975">
-                <a:solidFill>
-                  <a:srgbClr val="567268"/>
-                </a:solidFill>
-                <a:latin typeface="Inter"/>
-                <a:ea typeface="Inter"/>
-                <a:cs typeface="Inter"/>
-              </a:defRPr>
-            </a:pPr>
-            <a:r>
-              <a:t>Sales handoff policy / Historical snapshot</a:t>
-            </a:r>
-          </a:p>
-        </p:txBody>
-      </p:sp>
-    </p:spTree>
-    <p:extLst>
-      <p:ext uri="{BB962C8B-B14F-4D97-AF65-F5344CB8AC3E}">
-        <p14:creationId xmlns:p14="http://schemas.microsoft.com/office/powerpoint/2010/main" val="360145486"/>
-      </p:ext>
-    </p:extLst>
-  </p:cSld>
-</p:sld>
-</file>
-
-<file path=ppt/slides/slide5.xml><?xml version="1.0" encoding="utf-8"?>
-<p:sld xmlns:p="http://schemas.openxmlformats.org/presentationml/2006/main">
-  <p:cSld>
-    <p:bg>
-      <p:bgPr>
-        <a:solidFill xmlns:a="http://schemas.openxmlformats.org/drawingml/2006/main">
-          <a:srgbClr val="F7F4ED"/>
-        </a:solidFill>
-      </p:bgPr>
-    </p:bg>
-    <p:spTree>
-      <p:nvGrpSpPr>
-        <p:cNvPr id="1" name=""/>
-        <p:cNvGrpSpPr/>
-        <p:nvPr/>
-      </p:nvGrpSpPr>
-      <p:grpSpPr>
-        <a:xfrm xmlns:a="http://schemas.openxmlformats.org/drawingml/2006/main"/>
-      </p:grpSpPr>
-      <p:sp>
-        <p:nvSpPr>
-          <p:cNvPr id="14" name="">
-            <a:extLst xmlns:a="http://schemas.openxmlformats.org/drawingml/2006/main">
-              <a:ext uri="{FF2B5EF4-FFF2-40B4-BE49-F238E27FC236}">
-                <a16:creationId xmlns:a16="http://schemas.microsoft.com/office/drawing/2014/main" id="{837E6E7B-7ED2-496E-8B98-9F8CA79FD663}"/>
-              </a:ext>
-            </a:extLst>
-          </p:cNvPr>
-          <p:cNvSpPr>
-            <a:spLocks xmlns:a="http://schemas.openxmlformats.org/drawingml/2006/main" noGrp="1"/>
-          </p:cNvSpPr>
-          <p:nvPr/>
-        </p:nvSpPr>
-        <p:spPr>
-          <a:xfrm xmlns:a="http://schemas.openxmlformats.org/drawingml/2006/main">
-            <a:off x="666750" y="476250"/>
-            <a:ext cx="10477500" cy="247650"/>
-          </a:xfrm>
-          <a:prstGeom xmlns:a="http://schemas.openxmlformats.org/drawingml/2006/main" prst="rect">
-            <a:avLst/>
-          </a:prstGeom>
-          <a:noFill xmlns:a="http://schemas.openxmlformats.org/drawingml/2006/main"/>
-          <a:ln xmlns:a="http://schemas.openxmlformats.org/drawingml/2006/main" w="0">
-            <a:noFill/>
-          </a:ln>
-        </p:spPr>
-        <p:txBody>
-          <a:bodyPr xmlns:a="http://schemas.openxmlformats.org/drawingml/2006/main" lIns="0" tIns="0" rIns="0" bIns="0" anchor="t">
-            <a:normAutofit fontScale="100000"/>
-          </a:bodyPr>
-          <a:lstStyle xmlns:a="http://schemas.openxmlformats.org/drawingml/2006/main"/>
-          <a:p xmlns:a="http://schemas.openxmlformats.org/drawingml/2006/main">
-            <a:pPr marL="0" indent="0" algn="l">
-              <a:spcBef>
-                <a:spcPts val="0"/>
-              </a:spcBef>
-              <a:spcAft>
-                <a:spcPts val="0"/>
-              </a:spcAft>
-              <a:buNone/>
-              <a:defRPr sz="1125">
-                <a:solidFill>
-                  <a:srgbClr val="4A7A1D"/>
-                </a:solidFill>
-                <a:latin typeface="Inter Medium"/>
-                <a:ea typeface="Inter Medium"/>
-                <a:cs typeface="Inter Medium"/>
-              </a:defRPr>
-            </a:pPr>
-            <a:r>
-              <a:t>HISTORICAL HANDOFF RECORD</a:t>
-            </a:r>
-          </a:p>
-        </p:txBody>
-      </p:sp>
-      <p:sp>
-        <p:nvSpPr>
-          <p:cNvPr id="2" name="">
-            <a:extLst xmlns:a="http://schemas.openxmlformats.org/drawingml/2006/main">
-              <a:ext uri="{FF2B5EF4-FFF2-40B4-BE49-F238E27FC236}">
-                <a16:creationId xmlns:a16="http://schemas.microsoft.com/office/drawing/2014/main" id="{CB942C02-A0EE-4D95-A3F8-FF38A44E8FDA}"/>
-              </a:ext>
-            </a:extLst>
-          </p:cNvPr>
-          <p:cNvSpPr>
-            <a:spLocks xmlns:a="http://schemas.openxmlformats.org/drawingml/2006/main" noGrp="1"/>
-          </p:cNvSpPr>
-          <p:nvPr/>
-        </p:nvSpPr>
-        <p:spPr>
-          <a:xfrm xmlns:a="http://schemas.openxmlformats.org/drawingml/2006/main">
-            <a:off x="666750" y="876300"/>
-            <a:ext cx="10668000" cy="971550"/>
-          </a:xfrm>
-          <a:prstGeom xmlns:a="http://schemas.openxmlformats.org/drawingml/2006/main" prst="rect">
-            <a:avLst/>
-          </a:prstGeom>
-          <a:noFill xmlns:a="http://schemas.openxmlformats.org/drawingml/2006/main"/>
-          <a:ln xmlns:a="http://schemas.openxmlformats.org/drawingml/2006/main" w="0">
-            <a:noFill/>
-          </a:ln>
-        </p:spPr>
-        <p:txBody>
-          <a:bodyPr xmlns:a="http://schemas.openxmlformats.org/drawingml/2006/main" lIns="0" tIns="0" rIns="0" bIns="0" anchor="t">
-            <a:normAutofit fontScale="100000"/>
-          </a:bodyPr>
-          <a:lstStyle xmlns:a="http://schemas.openxmlformats.org/drawingml/2006/main"/>
-          <a:p xmlns:a="http://schemas.openxmlformats.org/drawingml/2006/main">
-            <a:pPr marL="0" indent="0" algn="l">
-              <a:spcBef>
-                <a:spcPts val="0"/>
-              </a:spcBef>
-              <a:spcAft>
-                <a:spcPts val="0"/>
-              </a:spcAft>
-              <a:buNone/>
-              <a:defRPr sz="3225">
-                <a:solidFill>
-                  <a:srgbClr val="0A2D22"/>
-                </a:solidFill>
-                <a:latin typeface="Inter Medium"/>
-                <a:ea typeface="Inter Medium"/>
-                <a:cs typeface="Inter Medium"/>
-              </a:defRPr>
-            </a:pPr>
-            <a:r>
-              <a:t>2026-12-01: Implementation to Customer Success</a:t>
-            </a:r>
-          </a:p>
-        </p:txBody>
-      </p:sp>
-      <p:sp>
-        <p:nvSpPr>
-          <p:cNvPr id="3" name="">
-            <a:extLst xmlns:a="http://schemas.openxmlformats.org/drawingml/2006/main">
-              <a:ext uri="{FF2B5EF4-FFF2-40B4-BE49-F238E27FC236}">
-                <a16:creationId xmlns:a16="http://schemas.microsoft.com/office/drawing/2014/main" id="{2226C16A-2FAD-402B-A743-159D0C224E28}"/>
-              </a:ext>
-            </a:extLst>
-          </p:cNvPr>
-          <p:cNvSpPr>
-            <a:spLocks xmlns:a="http://schemas.openxmlformats.org/drawingml/2006/main" noGrp="1"/>
-          </p:cNvSpPr>
-          <p:nvPr/>
-        </p:nvSpPr>
-        <p:spPr>
-          <a:xfrm xmlns:a="http://schemas.openxmlformats.org/drawingml/2006/main">
-            <a:off x="666750" y="6477000"/>
-            <a:ext cx="2476500" cy="171450"/>
-          </a:xfrm>
-          <a:prstGeom xmlns:a="http://schemas.openxmlformats.org/drawingml/2006/main" prst="rect">
-            <a:avLst/>
-          </a:prstGeom>
-          <a:noFill xmlns:a="http://schemas.openxmlformats.org/drawingml/2006/main"/>
-          <a:ln xmlns:a="http://schemas.openxmlformats.org/drawingml/2006/main" w="0">
-            <a:noFill/>
-          </a:ln>
-        </p:spPr>
-        <p:txBody>
-          <a:bodyPr xmlns:a="http://schemas.openxmlformats.org/drawingml/2006/main" lIns="0" tIns="0" rIns="0" bIns="0" anchor="t">
-            <a:normAutofit fontScale="100000"/>
-          </a:bodyPr>
-          <a:lstStyle xmlns:a="http://schemas.openxmlformats.org/drawingml/2006/main"/>
-          <a:p xmlns:a="http://schemas.openxmlformats.org/drawingml/2006/main">
-            <a:pPr marL="0" indent="0" algn="l">
-              <a:spcBef>
-                <a:spcPts val="0"/>
-              </a:spcBef>
-              <a:spcAft>
-                <a:spcPts val="0"/>
-              </a:spcAft>
-              <a:buNone/>
-              <a:defRPr sz="900">
-                <a:solidFill>
-                  <a:srgbClr val="567268"/>
-                </a:solidFill>
-                <a:latin typeface="Inter"/>
-                <a:ea typeface="Inter"/>
-                <a:cs typeface="Inter"/>
-              </a:defRPr>
-            </a:pPr>
-            <a:r>
-              <a:t>BATON   5</a:t>
-            </a:r>
-          </a:p>
-        </p:txBody>
-      </p:sp>
-      <p:sp>
-        <p:nvSpPr>
-          <p:cNvPr id="4" name="">
-            <a:extLst xmlns:a="http://schemas.openxmlformats.org/drawingml/2006/main">
-              <a:ext uri="{FF2B5EF4-FFF2-40B4-BE49-F238E27FC236}">
-                <a16:creationId xmlns:a16="http://schemas.microsoft.com/office/drawing/2014/main" id="{958B6841-4700-441C-9205-A6B43A5C2F19}"/>
-              </a:ext>
-            </a:extLst>
-          </p:cNvPr>
-          <p:cNvSpPr>
-            <a:spLocks xmlns:a="http://schemas.openxmlformats.org/drawingml/2006/main" noGrp="1"/>
-          </p:cNvSpPr>
-          <p:nvPr/>
-        </p:nvSpPr>
-        <p:spPr>
-          <a:xfrm xmlns:a="http://schemas.openxmlformats.org/drawingml/2006/main">
-            <a:off x="6762750" y="6477000"/>
-            <a:ext cx="4572000" cy="171450"/>
-          </a:xfrm>
-          <a:prstGeom xmlns:a="http://schemas.openxmlformats.org/drawingml/2006/main" prst="rect">
-            <a:avLst/>
-          </a:prstGeom>
-          <a:noFill xmlns:a="http://schemas.openxmlformats.org/drawingml/2006/main"/>
-          <a:ln xmlns:a="http://schemas.openxmlformats.org/drawingml/2006/main" w="0">
-            <a:noFill/>
-          </a:ln>
-        </p:spPr>
-        <p:txBody>
-          <a:bodyPr xmlns:a="http://schemas.openxmlformats.org/drawingml/2006/main" lIns="0" tIns="0" rIns="0" bIns="0" anchor="t">
-            <a:normAutofit fontScale="100000"/>
-          </a:bodyPr>
-          <a:lstStyle xmlns:a="http://schemas.openxmlformats.org/drawingml/2006/main"/>
-          <a:p xmlns:a="http://schemas.openxmlformats.org/drawingml/2006/main">
-            <a:pPr marL="0" indent="0" algn="r">
-              <a:spcBef>
-                <a:spcPts val="0"/>
-              </a:spcBef>
-              <a:spcAft>
-                <a:spcPts val="0"/>
-              </a:spcAft>
-              <a:buNone/>
-              <a:defRPr sz="900">
-                <a:solidFill>
-                  <a:srgbClr val="567268"/>
-                </a:solidFill>
-                <a:latin typeface="Inter"/>
-                <a:ea typeface="Inter"/>
-                <a:cs typeface="Inter"/>
-              </a:defRPr>
-            </a:pPr>
-            <a:r>
-              <a:t>FICTIONAL, SIMULATED EXAMPLE   2026-12-01</a:t>
-            </a:r>
-          </a:p>
-        </p:txBody>
-      </p:sp>
-      <p:sp>
-        <p:nvSpPr>
-          <p:cNvPr id="5" name="">
-            <a:extLst xmlns:a="http://schemas.openxmlformats.org/drawingml/2006/main">
-              <a:ext uri="{FF2B5EF4-FFF2-40B4-BE49-F238E27FC236}">
-                <a16:creationId xmlns:a16="http://schemas.microsoft.com/office/drawing/2014/main" id="{26367CD5-C23B-4FFD-ACC5-6241D9ED200C}"/>
-              </a:ext>
-            </a:extLst>
-          </p:cNvPr>
-          <p:cNvSpPr>
-            <a:spLocks xmlns:a="http://schemas.openxmlformats.org/drawingml/2006/main" noGrp="1"/>
-          </p:cNvSpPr>
-          <p:nvPr/>
-        </p:nvSpPr>
-        <p:spPr>
-          <a:xfrm xmlns:a="http://schemas.openxmlformats.org/drawingml/2006/main">
-            <a:off x="666750" y="2190750"/>
-            <a:ext cx="2571750" cy="428625"/>
-          </a:xfrm>
-          <a:prstGeom xmlns:a="http://schemas.openxmlformats.org/drawingml/2006/main" prst="rect">
-            <a:avLst/>
-          </a:prstGeom>
-          <a:noFill xmlns:a="http://schemas.openxmlformats.org/drawingml/2006/main"/>
-          <a:ln xmlns:a="http://schemas.openxmlformats.org/drawingml/2006/main" w="0">
-            <a:noFill/>
-          </a:ln>
-        </p:spPr>
-        <p:txBody>
-          <a:bodyPr xmlns:a="http://schemas.openxmlformats.org/drawingml/2006/main" lIns="0" tIns="0" rIns="0" bIns="0" anchor="t">
-            <a:normAutofit fontScale="100000"/>
-          </a:bodyPr>
-          <a:lstStyle xmlns:a="http://schemas.openxmlformats.org/drawingml/2006/main"/>
-          <a:p xmlns:a="http://schemas.openxmlformats.org/drawingml/2006/main">
-            <a:pPr marL="0" indent="0" algn="l">
-              <a:spcBef>
-                <a:spcPts val="0"/>
-              </a:spcBef>
-              <a:spcAft>
-                <a:spcPts val="0"/>
-              </a:spcAft>
-              <a:buNone/>
-              <a:defRPr sz="2625">
-                <a:solidFill>
-                  <a:srgbClr val="B06B10"/>
-                </a:solidFill>
-                <a:latin typeface="Inter Medium"/>
-                <a:ea typeface="Inter Medium"/>
-                <a:cs typeface="Inter Medium"/>
-              </a:defRPr>
-            </a:pPr>
-            <a:r>
-              <a:t>Needs Review</a:t>
-            </a:r>
-          </a:p>
-        </p:txBody>
-      </p:sp>
-      <p:sp>
-        <p:nvSpPr>
-          <p:cNvPr id="6" name="">
-            <a:extLst xmlns:a="http://schemas.openxmlformats.org/drawingml/2006/main">
-              <a:ext uri="{FF2B5EF4-FFF2-40B4-BE49-F238E27FC236}">
-                <a16:creationId xmlns:a16="http://schemas.microsoft.com/office/drawing/2014/main" id="{7D9ABD52-A6B8-499A-87B5-385249DFD4ED}"/>
-              </a:ext>
-            </a:extLst>
-          </p:cNvPr>
-          <p:cNvSpPr>
-            <a:spLocks xmlns:a="http://schemas.openxmlformats.org/drawingml/2006/main" noGrp="1"/>
-          </p:cNvSpPr>
-          <p:nvPr/>
-        </p:nvSpPr>
-        <p:spPr>
-          <a:xfrm xmlns:a="http://schemas.openxmlformats.org/drawingml/2006/main">
-            <a:off x="666750" y="2762250"/>
-            <a:ext cx="4476750" cy="1143000"/>
-          </a:xfrm>
-          <a:prstGeom xmlns:a="http://schemas.openxmlformats.org/drawingml/2006/main" prst="rect">
-            <a:avLst/>
-          </a:prstGeom>
-          <a:noFill xmlns:a="http://schemas.openxmlformats.org/drawingml/2006/main"/>
-          <a:ln xmlns:a="http://schemas.openxmlformats.org/drawingml/2006/main" w="0">
-            <a:noFill/>
-          </a:ln>
-        </p:spPr>
-        <p:txBody>
-          <a:bodyPr xmlns:a="http://schemas.openxmlformats.org/drawingml/2006/main" lIns="0" tIns="0" rIns="0" bIns="0" anchor="t">
-            <a:normAutofit fontScale="100000"/>
-          </a:bodyPr>
-          <a:lstStyle xmlns:a="http://schemas.openxmlformats.org/drawingml/2006/main"/>
-          <a:p xmlns:a="http://schemas.openxmlformats.org/drawingml/2006/main">
-            <a:pPr marL="0" indent="0" algn="l">
-              <a:spcBef>
-                <a:spcPts val="0"/>
-              </a:spcBef>
-              <a:spcAft>
-                <a:spcPts val="0"/>
-              </a:spcAft>
-              <a:buNone/>
-              <a:defRPr sz="1650">
-                <a:solidFill>
-                  <a:srgbClr val="0A2D22"/>
-                </a:solidFill>
-                <a:latin typeface="Inter"/>
-                <a:ea typeface="Inter"/>
-                <a:cs typeface="Inter"/>
-              </a:defRPr>
-            </a:pPr>
-            <a:r>
-              <a:t>Ruben Cherise to Althea Cassidy</a:t>
-            </a:r>
-          </a:p>
-          <a:p xmlns:a="http://schemas.openxmlformats.org/drawingml/2006/main">
-            <a:pPr marL="0" indent="0" algn="l">
-              <a:spcBef>
-                <a:spcPts val="0"/>
-              </a:spcBef>
-              <a:spcAft>
-                <a:spcPts val="0"/>
-              </a:spcAft>
-              <a:buNone/>
-              <a:defRPr sz="1650">
-                <a:solidFill>
-                  <a:srgbClr val="0A2D22"/>
-                </a:solidFill>
-                <a:latin typeface="Inter"/>
-                <a:ea typeface="Inter"/>
-                <a:cs typeface="Inter"/>
-              </a:defRPr>
-            </a:pPr>
-            <a:r>
-              <a:t>Implementation milestone review transfers ongoing customer ownership to Customer Success. [S1]</a:t>
-            </a:r>
-          </a:p>
-        </p:txBody>
-      </p:sp>
-      <p:sp>
-        <p:nvSpPr>
-          <p:cNvPr id="7" name="">
-            <a:extLst xmlns:a="http://schemas.openxmlformats.org/drawingml/2006/main">
-              <a:ext uri="{FF2B5EF4-FFF2-40B4-BE49-F238E27FC236}">
-                <a16:creationId xmlns:a16="http://schemas.microsoft.com/office/drawing/2014/main" id="{1474D981-3191-4854-B9D6-5C1036517C4E}"/>
-              </a:ext>
-            </a:extLst>
-          </p:cNvPr>
-          <p:cNvSpPr>
-            <a:spLocks xmlns:a="http://schemas.openxmlformats.org/drawingml/2006/main" noGrp="1"/>
-          </p:cNvSpPr>
-          <p:nvPr/>
-        </p:nvSpPr>
-        <p:spPr>
-          <a:xfrm xmlns:a="http://schemas.openxmlformats.org/drawingml/2006/main">
-            <a:off x="5905500" y="2190750"/>
-            <a:ext cx="4762500" cy="247650"/>
-          </a:xfrm>
-          <a:prstGeom xmlns:a="http://schemas.openxmlformats.org/drawingml/2006/main" prst="rect">
-            <a:avLst/>
-          </a:prstGeom>
-          <a:noFill xmlns:a="http://schemas.openxmlformats.org/drawingml/2006/main"/>
-          <a:ln xmlns:a="http://schemas.openxmlformats.org/drawingml/2006/main" w="0">
-            <a:noFill/>
-          </a:ln>
-        </p:spPr>
-        <p:txBody>
-          <a:bodyPr xmlns:a="http://schemas.openxmlformats.org/drawingml/2006/main" lIns="0" tIns="0" rIns="0" bIns="0" anchor="t">
-            <a:normAutofit fontScale="100000"/>
-          </a:bodyPr>
-          <a:lstStyle xmlns:a="http://schemas.openxmlformats.org/drawingml/2006/main"/>
-          <a:p xmlns:a="http://schemas.openxmlformats.org/drawingml/2006/main">
-            <a:pPr marL="0" indent="0" algn="l">
-              <a:spcBef>
-                <a:spcPts val="0"/>
-              </a:spcBef>
-              <a:spcAft>
-                <a:spcPts val="0"/>
-              </a:spcAft>
-              <a:buNone/>
-              <a:defRPr sz="1125">
-                <a:solidFill>
-                  <a:srgbClr val="4A7A1D"/>
-                </a:solidFill>
-                <a:latin typeface="Inter Medium"/>
-                <a:ea typeface="Inter Medium"/>
-                <a:cs typeface="Inter Medium"/>
-              </a:defRPr>
-            </a:pPr>
-            <a:r>
-              <a:t>ASSESSMENT</a:t>
-            </a:r>
-          </a:p>
-        </p:txBody>
-      </p:sp>
-      <p:sp>
-        <p:nvSpPr>
-          <p:cNvPr id="8" name="">
-            <a:extLst xmlns:a="http://schemas.openxmlformats.org/drawingml/2006/main">
-              <a:ext uri="{FF2B5EF4-FFF2-40B4-BE49-F238E27FC236}">
-                <a16:creationId xmlns:a16="http://schemas.microsoft.com/office/drawing/2014/main" id="{3975C687-3A93-4834-8072-7A7EC84E0A6D}"/>
-              </a:ext>
-            </a:extLst>
-          </p:cNvPr>
-          <p:cNvSpPr>
-            <a:spLocks xmlns:a="http://schemas.openxmlformats.org/drawingml/2006/main" noGrp="1"/>
-          </p:cNvSpPr>
-          <p:nvPr/>
-        </p:nvSpPr>
-        <p:spPr>
-          <a:xfrm xmlns:a="http://schemas.openxmlformats.org/drawingml/2006/main">
-            <a:off x="5905500" y="2524125"/>
-            <a:ext cx="4762500" cy="1333500"/>
-          </a:xfrm>
-          <a:prstGeom xmlns:a="http://schemas.openxmlformats.org/drawingml/2006/main" prst="rect">
-            <a:avLst/>
-          </a:prstGeom>
-          <a:noFill xmlns:a="http://schemas.openxmlformats.org/drawingml/2006/main"/>
-          <a:ln xmlns:a="http://schemas.openxmlformats.org/drawingml/2006/main" w="0">
-            <a:noFill/>
-          </a:ln>
-        </p:spPr>
-        <p:txBody>
-          <a:bodyPr xmlns:a="http://schemas.openxmlformats.org/drawingml/2006/main" lIns="0" tIns="0" rIns="0" bIns="0" anchor="t">
-            <a:normAutofit fontScale="100000"/>
-          </a:bodyPr>
-          <a:lstStyle xmlns:a="http://schemas.openxmlformats.org/drawingml/2006/main"/>
-          <a:p xmlns:a="http://schemas.openxmlformats.org/drawingml/2006/main">
-            <a:pPr marL="0" indent="0" algn="l">
-              <a:spcBef>
-                <a:spcPts val="0"/>
-              </a:spcBef>
-              <a:spcAft>
-                <a:spcPts val="0"/>
-              </a:spcAft>
-              <a:buNone/>
-              <a:defRPr sz="1575">
-                <a:solidFill>
-                  <a:srgbClr val="0A2D22"/>
-                </a:solidFill>
-                <a:latin typeface="Inter"/>
-                <a:ea typeface="Inter"/>
-                <a:cs typeface="Inter"/>
-              </a:defRPr>
-            </a:pPr>
-            <a:r>
-              <a:t>Six venues are reporting and 96% of priority alerts arrive within 15 minutes. Training and QBR dates remain unconfirmed; the Dec 18 goal remains open. [S1, S3]</a:t>
-            </a:r>
-          </a:p>
-        </p:txBody>
-      </p:sp>
-      <p:sp>
-        <p:nvSpPr>
-          <p:cNvPr id="9" name="">
-            <a:extLst xmlns:a="http://schemas.openxmlformats.org/drawingml/2006/main">
-              <a:ext uri="{FF2B5EF4-FFF2-40B4-BE49-F238E27FC236}">
-                <a16:creationId xmlns:a16="http://schemas.microsoft.com/office/drawing/2014/main" id="{61D9E136-6A4C-4842-9C2B-AAB7740FA1F5}"/>
-              </a:ext>
-            </a:extLst>
-          </p:cNvPr>
-          <p:cNvSpPr>
-            <a:spLocks xmlns:a="http://schemas.openxmlformats.org/drawingml/2006/main" noGrp="1"/>
-          </p:cNvSpPr>
-          <p:nvPr/>
-        </p:nvSpPr>
-        <p:spPr>
-          <a:xfrm xmlns:a="http://schemas.openxmlformats.org/drawingml/2006/main">
-            <a:off x="666750" y="4429125"/>
-            <a:ext cx="4476750" cy="247650"/>
-          </a:xfrm>
-          <a:prstGeom xmlns:a="http://schemas.openxmlformats.org/drawingml/2006/main" prst="rect">
-            <a:avLst/>
-          </a:prstGeom>
-          <a:noFill xmlns:a="http://schemas.openxmlformats.org/drawingml/2006/main"/>
-          <a:ln xmlns:a="http://schemas.openxmlformats.org/drawingml/2006/main" w="0">
-            <a:noFill/>
-          </a:ln>
-        </p:spPr>
-        <p:txBody>
-          <a:bodyPr xmlns:a="http://schemas.openxmlformats.org/drawingml/2006/main" lIns="0" tIns="0" rIns="0" bIns="0" anchor="t">
-            <a:normAutofit fontScale="100000"/>
-          </a:bodyPr>
-          <a:lstStyle xmlns:a="http://schemas.openxmlformats.org/drawingml/2006/main"/>
-          <a:p xmlns:a="http://schemas.openxmlformats.org/drawingml/2006/main">
-            <a:pPr marL="0" indent="0" algn="l">
-              <a:spcBef>
-                <a:spcPts val="0"/>
-              </a:spcBef>
-              <a:spcAft>
-                <a:spcPts val="0"/>
-              </a:spcAft>
-              <a:buNone/>
-              <a:defRPr sz="1125">
-                <a:solidFill>
-                  <a:srgbClr val="4A7A1D"/>
-                </a:solidFill>
-                <a:latin typeface="Inter Medium"/>
-                <a:ea typeface="Inter Medium"/>
-                <a:cs typeface="Inter Medium"/>
-              </a:defRPr>
-            </a:pPr>
-            <a:r>
-              <a:t>COMMITMENTS</a:t>
-            </a:r>
-          </a:p>
-        </p:txBody>
-      </p:sp>
-      <p:sp>
-        <p:nvSpPr>
-          <p:cNvPr id="10" name="">
-            <a:extLst xmlns:a="http://schemas.openxmlformats.org/drawingml/2006/main">
-              <a:ext uri="{FF2B5EF4-FFF2-40B4-BE49-F238E27FC236}">
-                <a16:creationId xmlns:a16="http://schemas.microsoft.com/office/drawing/2014/main" id="{BFF283F9-F319-4974-BD6B-9B872DFBF67F}"/>
-              </a:ext>
-            </a:extLst>
-          </p:cNvPr>
-          <p:cNvSpPr>
-            <a:spLocks xmlns:a="http://schemas.openxmlformats.org/drawingml/2006/main" noGrp="1"/>
-          </p:cNvSpPr>
-          <p:nvPr/>
-        </p:nvSpPr>
-        <p:spPr>
-          <a:xfrm xmlns:a="http://schemas.openxmlformats.org/drawingml/2006/main">
-            <a:off x="666750" y="4762500"/>
-            <a:ext cx="4476750" cy="1238250"/>
-          </a:xfrm>
-          <a:prstGeom xmlns:a="http://schemas.openxmlformats.org/drawingml/2006/main" prst="rect">
-            <a:avLst/>
-          </a:prstGeom>
-          <a:noFill xmlns:a="http://schemas.openxmlformats.org/drawingml/2006/main"/>
-          <a:ln xmlns:a="http://schemas.openxmlformats.org/drawingml/2006/main" w="0">
-            <a:noFill/>
-          </a:ln>
-        </p:spPr>
-        <p:txBody>
-          <a:bodyPr xmlns:a="http://schemas.openxmlformats.org/drawingml/2006/main" lIns="0" tIns="0" rIns="0" bIns="0" anchor="t">
-            <a:normAutofit fontScale="100000"/>
-          </a:bodyPr>
-          <a:lstStyle xmlns:a="http://schemas.openxmlformats.org/drawingml/2006/main"/>
-          <a:p xmlns:a="http://schemas.openxmlformats.org/drawingml/2006/main">
-            <a:pPr marL="0" indent="0" algn="l">
-              <a:spcBef>
-                <a:spcPts val="0"/>
-              </a:spcBef>
-              <a:spcAft>
-                <a:spcPts val="0"/>
-              </a:spcAft>
-              <a:buNone/>
-              <a:defRPr sz="1575">
-                <a:solidFill>
-                  <a:srgbClr val="0A2D22"/>
-                </a:solidFill>
-                <a:latin typeface="Inter"/>
-                <a:ea typeface="Inter"/>
-                <a:cs typeface="Inter"/>
-              </a:defRPr>
-            </a:pPr>
-            <a:r>
-              <a:t>All six venues report; 96% of priority alerts arrive within 15 minutes. The ≤42-minute investigation target remains due Dec 18. [S1, S3]</a:t>
-            </a:r>
-          </a:p>
-        </p:txBody>
-      </p:sp>
-      <p:sp>
-        <p:nvSpPr>
-          <p:cNvPr id="11" name="">
-            <a:extLst xmlns:a="http://schemas.openxmlformats.org/drawingml/2006/main">
-              <a:ext uri="{FF2B5EF4-FFF2-40B4-BE49-F238E27FC236}">
-                <a16:creationId xmlns:a16="http://schemas.microsoft.com/office/drawing/2014/main" id="{454B2E0A-DD49-41BC-9F82-F08829907F43}"/>
-              </a:ext>
-            </a:extLst>
-          </p:cNvPr>
-          <p:cNvSpPr>
-            <a:spLocks xmlns:a="http://schemas.openxmlformats.org/drawingml/2006/main" noGrp="1"/>
-          </p:cNvSpPr>
-          <p:nvPr/>
-        </p:nvSpPr>
-        <p:spPr>
-          <a:xfrm xmlns:a="http://schemas.openxmlformats.org/drawingml/2006/main">
-            <a:off x="5905500" y="4429125"/>
-            <a:ext cx="4762500" cy="247650"/>
-          </a:xfrm>
-          <a:prstGeom xmlns:a="http://schemas.openxmlformats.org/drawingml/2006/main" prst="rect">
-            <a:avLst/>
-          </a:prstGeom>
-          <a:noFill xmlns:a="http://schemas.openxmlformats.org/drawingml/2006/main"/>
-          <a:ln xmlns:a="http://schemas.openxmlformats.org/drawingml/2006/main" w="0">
-            <a:noFill/>
-          </a:ln>
-        </p:spPr>
-        <p:txBody>
-          <a:bodyPr xmlns:a="http://schemas.openxmlformats.org/drawingml/2006/main" lIns="0" tIns="0" rIns="0" bIns="0" anchor="t">
-            <a:normAutofit fontScale="100000"/>
-          </a:bodyPr>
-          <a:lstStyle xmlns:a="http://schemas.openxmlformats.org/drawingml/2006/main"/>
-          <a:p xmlns:a="http://schemas.openxmlformats.org/drawingml/2006/main">
-            <a:pPr marL="0" indent="0" algn="l">
-              <a:spcBef>
-                <a:spcPts val="0"/>
-              </a:spcBef>
-              <a:spcAft>
-                <a:spcPts val="0"/>
-              </a:spcAft>
-              <a:buNone/>
-              <a:defRPr sz="1125">
-                <a:solidFill>
-                  <a:srgbClr val="4A7A1D"/>
-                </a:solidFill>
-                <a:latin typeface="Inter Medium"/>
-                <a:ea typeface="Inter Medium"/>
-                <a:cs typeface="Inter Medium"/>
-              </a:defRPr>
-            </a:pPr>
-            <a:r>
-              <a:t>OPEN QUESTIONS AND RISKS</a:t>
-            </a:r>
-          </a:p>
-        </p:txBody>
-      </p:sp>
-      <p:sp>
-        <p:nvSpPr>
-          <p:cNvPr id="12" name="">
-            <a:extLst xmlns:a="http://schemas.openxmlformats.org/drawingml/2006/main">
-              <a:ext uri="{FF2B5EF4-FFF2-40B4-BE49-F238E27FC236}">
-                <a16:creationId xmlns:a16="http://schemas.microsoft.com/office/drawing/2014/main" id="{833796F6-0960-4CAC-8270-201BED191E41}"/>
-              </a:ext>
-            </a:extLst>
-          </p:cNvPr>
-          <p:cNvSpPr>
-            <a:spLocks xmlns:a="http://schemas.openxmlformats.org/drawingml/2006/main" noGrp="1"/>
-          </p:cNvSpPr>
-          <p:nvPr/>
-        </p:nvSpPr>
-        <p:spPr>
-          <a:xfrm xmlns:a="http://schemas.openxmlformats.org/drawingml/2006/main">
-            <a:off x="5905500" y="4762500"/>
-            <a:ext cx="4762500" cy="1238250"/>
-          </a:xfrm>
-          <a:prstGeom xmlns:a="http://schemas.openxmlformats.org/drawingml/2006/main" prst="rect">
-            <a:avLst/>
-          </a:prstGeom>
-          <a:noFill xmlns:a="http://schemas.openxmlformats.org/drawingml/2006/main"/>
-          <a:ln xmlns:a="http://schemas.openxmlformats.org/drawingml/2006/main" w="0">
-            <a:noFill/>
-          </a:ln>
-        </p:spPr>
-        <p:txBody>
-          <a:bodyPr xmlns:a="http://schemas.openxmlformats.org/drawingml/2006/main" lIns="0" tIns="0" rIns="0" bIns="0" anchor="t">
-            <a:normAutofit fontScale="87959"/>
-          </a:bodyPr>
-          <a:lstStyle xmlns:a="http://schemas.openxmlformats.org/drawingml/2006/main"/>
-          <a:p xmlns:a="http://schemas.openxmlformats.org/drawingml/2006/main">
-            <a:pPr marL="0" indent="0" algn="l">
-              <a:spcBef>
-                <a:spcPts val="0"/>
-              </a:spcBef>
-              <a:spcAft>
-                <a:spcPts val="0"/>
-              </a:spcAft>
-              <a:buNone/>
-              <a:defRPr sz="1575">
-                <a:solidFill>
-                  <a:srgbClr val="0A2D22"/>
-                </a:solidFill>
-                <a:latin typeface="Inter"/>
-                <a:ea typeface="Inter"/>
-                <a:cs typeface="Inter"/>
-              </a:defRPr>
-            </a:pPr>
-            <a:r>
-              <a:t>Customer training session and first QBR date: Not Confirmed. [S1]</a:t>
-            </a:r>
-          </a:p>
-          <a:p xmlns:a="http://schemas.openxmlformats.org/drawingml/2006/main">
-            <a:pPr marL="0" indent="0" algn="l">
-              <a:spcBef>
-                <a:spcPts val="0"/>
-              </a:spcBef>
-              <a:spcAft>
-                <a:spcPts val="0"/>
-              </a:spcAft>
-              <a:buNone/>
-              <a:defRPr sz="1575">
-                <a:solidFill>
-                  <a:srgbClr val="0A2D22"/>
-                </a:solidFill>
-                <a:latin typeface="Inter"/>
-                <a:ea typeface="Inter"/>
-                <a:cs typeface="Inter"/>
-              </a:defRPr>
-            </a:pPr>
-            <a:r>
-              <a:t/>
-            </a:r>
-          </a:p>
-          <a:p xmlns:a="http://schemas.openxmlformats.org/drawingml/2006/main">
-            <a:pPr marL="0" indent="0" algn="l">
-              <a:spcBef>
-                <a:spcPts val="0"/>
-              </a:spcBef>
-              <a:spcAft>
-                <a:spcPts val="0"/>
-              </a:spcAft>
-              <a:buNone/>
-              <a:defRPr sz="1575">
-                <a:solidFill>
-                  <a:srgbClr val="0A2D22"/>
-                </a:solidFill>
-                <a:latin typeface="Inter"/>
-                <a:ea typeface="Inter"/>
-                <a:cs typeface="Inter"/>
-              </a:defRPr>
-            </a:pPr>
-            <a:r>
-              <a:t>Do not treat rollout metrics as proof of the investigation-time goal; its final measurement is still outstanding. [S1]</a:t>
-            </a:r>
-          </a:p>
-        </p:txBody>
-      </p:sp>
-      <p:sp>
-        <p:nvSpPr>
-          <p:cNvPr id="13" name="">
-            <a:extLst xmlns:a="http://schemas.openxmlformats.org/drawingml/2006/main">
-              <a:ext uri="{FF2B5EF4-FFF2-40B4-BE49-F238E27FC236}">
-                <a16:creationId xmlns:a16="http://schemas.microsoft.com/office/drawing/2014/main" id="{FAC2C951-50AB-441D-8701-9238B6A85F64}"/>
-              </a:ext>
-            </a:extLst>
-          </p:cNvPr>
-          <p:cNvSpPr>
-            <a:spLocks xmlns:a="http://schemas.openxmlformats.org/drawingml/2006/main" noGrp="1"/>
-          </p:cNvSpPr>
-          <p:nvPr/>
-        </p:nvSpPr>
-        <p:spPr>
-          <a:xfrm xmlns:a="http://schemas.openxmlformats.org/drawingml/2006/main">
-            <a:off x="666750" y="6191250"/>
-            <a:ext cx="5715000" cy="190500"/>
-          </a:xfrm>
-          <a:prstGeom xmlns:a="http://schemas.openxmlformats.org/drawingml/2006/main" prst="rect">
-            <a:avLst/>
-          </a:prstGeom>
-          <a:noFill xmlns:a="http://schemas.openxmlformats.org/drawingml/2006/main"/>
-          <a:ln xmlns:a="http://schemas.openxmlformats.org/drawingml/2006/main" w="0">
-            <a:noFill/>
-          </a:ln>
-        </p:spPr>
-        <p:txBody>
-          <a:bodyPr xmlns:a="http://schemas.openxmlformats.org/drawingml/2006/main" lIns="0" tIns="0" rIns="0" bIns="0" anchor="t">
-            <a:normAutofit fontScale="100000"/>
-          </a:bodyPr>
-          <a:lstStyle xmlns:a="http://schemas.openxmlformats.org/drawingml/2006/main"/>
-          <a:p xmlns:a="http://schemas.openxmlformats.org/drawingml/2006/main">
-            <a:pPr marL="0" indent="0" algn="l">
-              <a:spcBef>
-                <a:spcPts val="0"/>
-              </a:spcBef>
-              <a:spcAft>
-                <a:spcPts val="0"/>
-              </a:spcAft>
-              <a:buNone/>
-              <a:defRPr sz="975">
-                <a:solidFill>
-                  <a:srgbClr val="567268"/>
-                </a:solidFill>
-                <a:latin typeface="Inter"/>
-                <a:ea typeface="Inter"/>
-                <a:cs typeface="Inter"/>
-              </a:defRPr>
-            </a:pPr>
-            <a:r>
-              <a:t>Internal transfer policy / Historical snapshot</a:t>
             </a:r>
           </a:p>
         </p:txBody>

</xml_diff>

<commit_message>
Focus the account deck on clear next steps
</commit_message>
<xml_diff>
--- a/examples/terrapin-account-deck.pptx
+++ b/examples/terrapin-account-deck.pptx
@@ -2,39 +2,38 @@
 <file path=ppt/presentation.xml><?xml version="1.0" encoding="utf-8"?>
 <p:presentation xmlns:p="http://schemas.openxmlformats.org/presentationml/2006/main" embedTrueTypeFonts="1" saveSubsetFonts="0">
   <p:sldMasterIdLst>
-    <p:sldMasterId xmlns:r="http://schemas.openxmlformats.org/officeDocument/2006/relationships" id="2147483648" r:id="Reff342ed1c384f13"/>
+    <p:sldMasterId xmlns:r="http://schemas.openxmlformats.org/officeDocument/2006/relationships" id="2147483648" r:id="R7924141128be4321"/>
   </p:sldMasterIdLst>
   <p:notesMasterIdLst>
-    <p:notesMasterId xmlns:r="http://schemas.openxmlformats.org/officeDocument/2006/relationships" r:id="Rc6ac4cd241074af1"/>
+    <p:notesMasterId xmlns:r="http://schemas.openxmlformats.org/officeDocument/2006/relationships" r:id="R5c1bfeb7a1504aa9"/>
   </p:notesMasterIdLst>
   <p:sldIdLst>
-    <p:sldId xmlns:r="http://schemas.openxmlformats.org/officeDocument/2006/relationships" id="256" r:id="R114d313ea81642be"/>
-    <p:sldId xmlns:r="http://schemas.openxmlformats.org/officeDocument/2006/relationships" id="257" r:id="R2ecd76d24f8543c2"/>
-    <p:sldId xmlns:r="http://schemas.openxmlformats.org/officeDocument/2006/relationships" id="258" r:id="Rd9f66bb8311b443a"/>
+    <p:sldId xmlns:r="http://schemas.openxmlformats.org/officeDocument/2006/relationships" id="256" r:id="Rc4b40781b2014c83"/>
+    <p:sldId xmlns:r="http://schemas.openxmlformats.org/officeDocument/2006/relationships" id="257" r:id="R87f1829cf99b463b"/>
   </p:sldIdLst>
   <p:sldSz cx="12192000" cy="6858000"/>
   <p:notesSz cx="6858000" cy="9144000"/>
   <p:embeddedFontLst>
     <p:embeddedFont>
       <p:font typeface="Inter"/>
-      <p:regular xmlns:r="http://schemas.openxmlformats.org/officeDocument/2006/relationships" r:id="Ree231feb1c7e4178"/>
-      <p:bold xmlns:r="http://schemas.openxmlformats.org/officeDocument/2006/relationships" r:id="Rebe415936e70417f"/>
+      <p:regular xmlns:r="http://schemas.openxmlformats.org/officeDocument/2006/relationships" r:id="R03d433f1c66e447c"/>
+      <p:bold xmlns:r="http://schemas.openxmlformats.org/officeDocument/2006/relationships" r:id="R38ee1a603b77422b"/>
     </p:embeddedFont>
     <p:embeddedFont>
       <p:font typeface="Inter Medium"/>
-      <p:regular xmlns:r="http://schemas.openxmlformats.org/officeDocument/2006/relationships" r:id="R1864f48476bb4541"/>
+      <p:regular xmlns:r="http://schemas.openxmlformats.org/officeDocument/2006/relationships" r:id="R2fa89fc4fcb649a4"/>
     </p:embeddedFont>
     <p:embeddedFont>
       <p:font typeface="Inter SemiBold"/>
-      <p:regular xmlns:r="http://schemas.openxmlformats.org/officeDocument/2006/relationships" r:id="R0c07254420bd4750"/>
-      <p:bold xmlns:r="http://schemas.openxmlformats.org/officeDocument/2006/relationships" r:id="Rf622ae5d220c48f3"/>
+      <p:regular xmlns:r="http://schemas.openxmlformats.org/officeDocument/2006/relationships" r:id="R8552157f1c3d4203"/>
+      <p:bold xmlns:r="http://schemas.openxmlformats.org/officeDocument/2006/relationships" r:id="Rb10071a9681a4a30"/>
     </p:embeddedFont>
     <p:embeddedFont>
       <p:font typeface="OpenAI Sans"/>
-      <p:regular xmlns:r="http://schemas.openxmlformats.org/officeDocument/2006/relationships" r:id="R14e7ced036f942ff"/>
-      <p:bold xmlns:r="http://schemas.openxmlformats.org/officeDocument/2006/relationships" r:id="R935507ed41044aaa"/>
-      <p:italic xmlns:r="http://schemas.openxmlformats.org/officeDocument/2006/relationships" r:id="R2e45bd2d0eaa473a"/>
-      <p:boldItalic xmlns:r="http://schemas.openxmlformats.org/officeDocument/2006/relationships" r:id="Ree196c46679747df"/>
+      <p:regular xmlns:r="http://schemas.openxmlformats.org/officeDocument/2006/relationships" r:id="Ra555a798fc764060"/>
+      <p:bold xmlns:r="http://schemas.openxmlformats.org/officeDocument/2006/relationships" r:id="R1ec25e48c354436c"/>
+      <p:italic xmlns:r="http://schemas.openxmlformats.org/officeDocument/2006/relationships" r:id="R1d5afcc765f348bc"/>
+      <p:boldItalic xmlns:r="http://schemas.openxmlformats.org/officeDocument/2006/relationships" r:id="R90115c7edbfa499f"/>
     </p:embeddedFont>
   </p:embeddedFontLst>
 </p:presentation>
@@ -838,126 +837,6 @@
 </p:notes>
 </file>
 
-<file path=ppt/notesSlides/notesSlide3.xml><?xml version="1.0" encoding="utf-8"?>
-<p:notes xmlns:p="http://schemas.openxmlformats.org/presentationml/2006/main">
-  <p:cSld>
-    <p:spTree>
-      <p:nvGrpSpPr>
-        <p:cNvPr id="1" name=""/>
-        <p:cNvGrpSpPr/>
-        <p:nvPr/>
-      </p:nvGrpSpPr>
-      <p:grpSpPr>
-        <a:xfrm xmlns:a="http://schemas.openxmlformats.org/drawingml/2006/main"/>
-      </p:grpSpPr>
-      <p:sp>
-        <p:nvSpPr>
-          <p:cNvPr id="2" name="Slide Image Placeholder 1"/>
-          <p:cNvSpPr>
-            <a:spLocks xmlns:a="http://schemas.openxmlformats.org/drawingml/2006/main" noGrp="1"/>
-          </p:cNvSpPr>
-          <p:nvPr>
-            <p:ph type="sldImg" idx="0"/>
-          </p:nvPr>
-        </p:nvSpPr>
-        <p:spPr/>
-      </p:sp>
-      <p:sp>
-        <p:nvSpPr>
-          <p:cNvPr id="3" name="Notes Placeholder 2"/>
-          <p:cNvSpPr>
-            <a:spLocks xmlns:a="http://schemas.openxmlformats.org/drawingml/2006/main" noGrp="1"/>
-          </p:cNvSpPr>
-          <p:nvPr>
-            <p:ph type="body" idx="1"/>
-          </p:nvPr>
-        </p:nvSpPr>
-        <p:spPr/>
-        <p:txBody>
-          <a:bodyPr xmlns:a="http://schemas.openxmlformats.org/drawingml/2006/main"/>
-          <a:lstStyle xmlns:a="http://schemas.openxmlformats.org/drawingml/2006/main"/>
-          <a:p xmlns:a="http://schemas.openxmlformats.org/drawingml/2006/main">
-            <a:r>
-              <a:t>Handoff timeline from validated stored history. Each row is a dated immutable event.</a:t>
-            </a:r>
-          </a:p>
-          <a:p xmlns:a="http://schemas.openxmlformats.org/drawingml/2006/main">
-            <a:r>
-              <a:t/>
-            </a:r>
-          </a:p>
-          <a:p xmlns:a="http://schemas.openxmlformats.org/drawingml/2006/main">
-            <a:r>
-              <a:t>terrapin-2026-09-16-sales-implementation</a:t>
-            </a:r>
-          </a:p>
-          <a:p xmlns:a="http://schemas.openxmlformats.org/drawingml/2006/main">
-            <a:r>
-              <a:t>2026-09-16T09:00:00-05:00</a:t>
-            </a:r>
-          </a:p>
-          <a:p xmlns:a="http://schemas.openxmlformats.org/drawingml/2006/main">
-            <a:r>
-              <a:t>Samson Delilah (Sales) to Ruben Cherise (Implementation)</a:t>
-            </a:r>
-          </a:p>
-          <a:p xmlns:a="http://schemas.openxmlformats.org/drawingml/2006/main">
-            <a:r>
-              <a:t>Ready</a:t>
-            </a:r>
-          </a:p>
-          <a:p xmlns:a="http://schemas.openxmlformats.org/drawingml/2006/main">
-            <a:r>
-              <a:t/>
-            </a:r>
-          </a:p>
-          <a:p xmlns:a="http://schemas.openxmlformats.org/drawingml/2006/main">
-            <a:r>
-              <a:t>terrapin-2026-12-01-implementation-cs</a:t>
-            </a:r>
-          </a:p>
-          <a:p xmlns:a="http://schemas.openxmlformats.org/drawingml/2006/main">
-            <a:r>
-              <a:t>2026-12-01T09:00:00-06:00</a:t>
-            </a:r>
-          </a:p>
-          <a:p xmlns:a="http://schemas.openxmlformats.org/drawingml/2006/main">
-            <a:r>
-              <a:t>Ruben Cherise (Implementation) to Althea Cassidy (Customer Success)</a:t>
-            </a:r>
-          </a:p>
-          <a:p xmlns:a="http://schemas.openxmlformats.org/drawingml/2006/main">
-            <a:r>
-              <a:t>Needs Review</a:t>
-            </a:r>
-          </a:p>
-        </p:txBody>
-      </p:sp>
-      <p:sp>
-        <p:nvSpPr>
-          <p:cNvPr id="4" name="Slide Number Placeholder 3"/>
-          <p:cNvSpPr>
-            <a:spLocks xmlns:a="http://schemas.openxmlformats.org/drawingml/2006/main" noGrp="1"/>
-          </p:cNvSpPr>
-          <p:nvPr>
-            <p:ph type="sldNum" idx="5"/>
-          </p:nvPr>
-        </p:nvSpPr>
-        <p:spPr/>
-        <p:txBody>
-          <a:bodyPr xmlns:a="http://schemas.openxmlformats.org/drawingml/2006/main"/>
-          <a:lstStyle xmlns:a="http://schemas.openxmlformats.org/drawingml/2006/main"/>
-          <a:p xmlns:a="http://schemas.openxmlformats.org/drawingml/2006/main"/>
-        </p:txBody>
-      </p:sp>
-    </p:spTree>
-  </p:cSld>
-  <p:clrMapOvr>
-    <a:masterClrMapping xmlns:a="http://schemas.openxmlformats.org/drawingml/2006/main"/>
-  </p:clrMapOvr>
-</p:notes>
-</file>
-
 <file path=ppt/slideLayouts/slideLayout1.xml><?xml version="1.0" encoding="utf-8"?>
 <p:sldLayout xmlns:p="http://schemas.openxmlformats.org/presentationml/2006/main" preserve="1" userDrawn="1">
   <p:cSld name="Title Slide">
@@ -2813,14 +2692,14 @@
   </p:cSld>
   <p:clrMap bg1="dk1" tx1="lt1" bg2="dk2" tx2="lt2" accent1="accent1" accent2="accent2" accent3="accent3" accent4="accent4" accent5="accent5" accent6="accent6" hlink="hlink" folHlink="folHlink"/>
   <p:sldLayoutIdLst>
-    <p:sldLayoutId xmlns:r="http://schemas.openxmlformats.org/officeDocument/2006/relationships" id="2147483649" r:id="R3c1948d917ce4d8f"/>
-    <p:sldLayoutId xmlns:r="http://schemas.openxmlformats.org/officeDocument/2006/relationships" id="2147483650" r:id="R913beff9e0ef4d43"/>
-    <p:sldLayoutId xmlns:r="http://schemas.openxmlformats.org/officeDocument/2006/relationships" id="2147483651" r:id="R177a0562702447cf"/>
-    <p:sldLayoutId xmlns:r="http://schemas.openxmlformats.org/officeDocument/2006/relationships" id="2147483652" r:id="R01dfaf79d0404a24"/>
-    <p:sldLayoutId xmlns:r="http://schemas.openxmlformats.org/officeDocument/2006/relationships" id="2147483653" r:id="R048d74bea44444a7"/>
-    <p:sldLayoutId xmlns:r="http://schemas.openxmlformats.org/officeDocument/2006/relationships" id="2147483654" r:id="R4773f2df73b84f8c"/>
-    <p:sldLayoutId xmlns:r="http://schemas.openxmlformats.org/officeDocument/2006/relationships" id="2147483655" r:id="Rff24395f4aa54f56"/>
-    <p:sldLayoutId xmlns:r="http://schemas.openxmlformats.org/officeDocument/2006/relationships" id="2147483656" r:id="Rd4ef1987da2247b6"/>
+    <p:sldLayoutId xmlns:r="http://schemas.openxmlformats.org/officeDocument/2006/relationships" id="2147483649" r:id="R32cfe96330a946d1"/>
+    <p:sldLayoutId xmlns:r="http://schemas.openxmlformats.org/officeDocument/2006/relationships" id="2147483650" r:id="Rb36bc0c6015b411e"/>
+    <p:sldLayoutId xmlns:r="http://schemas.openxmlformats.org/officeDocument/2006/relationships" id="2147483651" r:id="R9564ddb5962e447b"/>
+    <p:sldLayoutId xmlns:r="http://schemas.openxmlformats.org/officeDocument/2006/relationships" id="2147483652" r:id="Rc443f0a3e14247f8"/>
+    <p:sldLayoutId xmlns:r="http://schemas.openxmlformats.org/officeDocument/2006/relationships" id="2147483653" r:id="R55cb228c4c3a4f60"/>
+    <p:sldLayoutId xmlns:r="http://schemas.openxmlformats.org/officeDocument/2006/relationships" id="2147483654" r:id="R10fc3e41632144d4"/>
+    <p:sldLayoutId xmlns:r="http://schemas.openxmlformats.org/officeDocument/2006/relationships" id="2147483655" r:id="Rb2e2a315c7b645c3"/>
+    <p:sldLayoutId xmlns:r="http://schemas.openxmlformats.org/officeDocument/2006/relationships" id="2147483656" r:id="R2e7a7df2a04c47e0"/>
   </p:sldLayoutIdLst>
   <p:hf hdr="0" dt="0"/>
   <p:txStyles>
@@ -3473,7 +3352,7 @@
           <p:cNvPr id="14" name="">
             <a:extLst xmlns:a="http://schemas.openxmlformats.org/drawingml/2006/main">
               <a:ext uri="{FF2B5EF4-FFF2-40B4-BE49-F238E27FC236}">
-                <a16:creationId xmlns:a16="http://schemas.microsoft.com/office/drawing/2014/main" id="{613F8D2E-D035-4810-92EF-179EA3A91FC5}"/>
+                <a16:creationId xmlns:a16="http://schemas.microsoft.com/office/drawing/2014/main" id="{45FB5150-221F-470B-8A15-AFD130390146}"/>
               </a:ext>
             </a:extLst>
           </p:cNvPr>
@@ -3519,7 +3398,7 @@
               </a:defRPr>
             </a:pPr>
             <a:r>
-              <a:t>ACCOUNT HANDOFF SUMMARY</a:t>
+              <a:t>ACCOUNT HANDOFF BRIEF</a:t>
             </a:r>
           </a:p>
         </p:txBody>
@@ -3529,7 +3408,7 @@
           <p:cNvPr id="2" name="">
             <a:extLst xmlns:a="http://schemas.openxmlformats.org/drawingml/2006/main">
               <a:ext uri="{FF2B5EF4-FFF2-40B4-BE49-F238E27FC236}">
-                <a16:creationId xmlns:a16="http://schemas.microsoft.com/office/drawing/2014/main" id="{95C2AC2E-C931-4DE3-ACF3-2EC4452B0574}"/>
+                <a16:creationId xmlns:a16="http://schemas.microsoft.com/office/drawing/2014/main" id="{E2686BBB-C050-4A78-8E14-B021F6DAC80E}"/>
               </a:ext>
             </a:extLst>
           </p:cNvPr>
@@ -3585,7 +3464,7 @@
           <p:cNvPr id="3" name="">
             <a:extLst xmlns:a="http://schemas.openxmlformats.org/drawingml/2006/main">
               <a:ext uri="{FF2B5EF4-FFF2-40B4-BE49-F238E27FC236}">
-                <a16:creationId xmlns:a16="http://schemas.microsoft.com/office/drawing/2014/main" id="{D9D4C6BB-3D77-4281-AAAF-A68402EBA7D8}"/>
+                <a16:creationId xmlns:a16="http://schemas.microsoft.com/office/drawing/2014/main" id="{9542F53B-7120-4B51-A26B-07797AAA9B5C}"/>
               </a:ext>
             </a:extLst>
           </p:cNvPr>
@@ -3641,7 +3520,7 @@
           <p:cNvPr id="4" name="">
             <a:extLst xmlns:a="http://schemas.openxmlformats.org/drawingml/2006/main">
               <a:ext uri="{FF2B5EF4-FFF2-40B4-BE49-F238E27FC236}">
-                <a16:creationId xmlns:a16="http://schemas.microsoft.com/office/drawing/2014/main" id="{F9903640-89A2-4D03-85D1-4A278B7337C9}"/>
+                <a16:creationId xmlns:a16="http://schemas.microsoft.com/office/drawing/2014/main" id="{D55A1C7D-7E26-481F-8B83-214BB019BE46}"/>
               </a:ext>
             </a:extLst>
           </p:cNvPr>
@@ -3697,7 +3576,7 @@
           <p:cNvPr id="5" name="">
             <a:extLst xmlns:a="http://schemas.openxmlformats.org/drawingml/2006/main">
               <a:ext uri="{FF2B5EF4-FFF2-40B4-BE49-F238E27FC236}">
-                <a16:creationId xmlns:a16="http://schemas.microsoft.com/office/drawing/2014/main" id="{09673A81-6F14-41A9-AEF9-73CB3B84B38D}"/>
+                <a16:creationId xmlns:a16="http://schemas.microsoft.com/office/drawing/2014/main" id="{70448934-8AD4-4B24-BC1B-F0FF221D4113}"/>
               </a:ext>
             </a:extLst>
           </p:cNvPr>
@@ -3708,7 +3587,7 @@
         </p:nvSpPr>
         <p:spPr>
           <a:xfrm xmlns:a="http://schemas.openxmlformats.org/drawingml/2006/main">
-            <a:off x="666750" y="2286000"/>
+            <a:off x="666750" y="2095500"/>
             <a:ext cx="4667250" cy="619125"/>
           </a:xfrm>
           <a:prstGeom xmlns:a="http://schemas.openxmlformats.org/drawingml/2006/main" prst="rect">
@@ -3735,7 +3614,7 @@
               <a:buNone/>
               <a:defRPr sz="3750">
                 <a:solidFill>
-                  <a:srgbClr val="BCEF59"/>
+                  <a:srgbClr val="F7C96A"/>
                 </a:solidFill>
                 <a:latin typeface="Inter Medium"/>
                 <a:ea typeface="Inter Medium"/>
@@ -3753,7 +3632,7 @@
           <p:cNvPr id="6" name="">
             <a:extLst xmlns:a="http://schemas.openxmlformats.org/drawingml/2006/main">
               <a:ext uri="{FF2B5EF4-FFF2-40B4-BE49-F238E27FC236}">
-                <a16:creationId xmlns:a16="http://schemas.microsoft.com/office/drawing/2014/main" id="{BAED2D03-E2BD-47F0-88B0-BF18242559EE}"/>
+                <a16:creationId xmlns:a16="http://schemas.microsoft.com/office/drawing/2014/main" id="{047FF59F-82C3-4390-9A71-B19205EC39E9}"/>
               </a:ext>
             </a:extLst>
           </p:cNvPr>
@@ -3764,7 +3643,7 @@
         </p:nvSpPr>
         <p:spPr>
           <a:xfrm xmlns:a="http://schemas.openxmlformats.org/drawingml/2006/main">
-            <a:off x="666750" y="3238500"/>
+            <a:off x="666750" y="3095625"/>
             <a:ext cx="4191000" cy="247650"/>
           </a:xfrm>
           <a:prstGeom xmlns:a="http://schemas.openxmlformats.org/drawingml/2006/main" prst="rect">
@@ -3809,7 +3688,7 @@
           <p:cNvPr id="7" name="">
             <a:extLst xmlns:a="http://schemas.openxmlformats.org/drawingml/2006/main">
               <a:ext uri="{FF2B5EF4-FFF2-40B4-BE49-F238E27FC236}">
-                <a16:creationId xmlns:a16="http://schemas.microsoft.com/office/drawing/2014/main" id="{27367809-FADF-466E-85EF-9EC0557FD197}"/>
+                <a16:creationId xmlns:a16="http://schemas.microsoft.com/office/drawing/2014/main" id="{FDFF2E10-7FF1-4FB7-B704-01EC1A27216E}"/>
               </a:ext>
             </a:extLst>
           </p:cNvPr>
@@ -3820,8 +3699,8 @@
         </p:nvSpPr>
         <p:spPr>
           <a:xfrm xmlns:a="http://schemas.openxmlformats.org/drawingml/2006/main">
-            <a:off x="666750" y="3571875"/>
-            <a:ext cx="4191000" cy="619125"/>
+            <a:off x="666750" y="3429000"/>
+            <a:ext cx="4191000" cy="447675"/>
           </a:xfrm>
           <a:prstGeom xmlns:a="http://schemas.openxmlformats.org/drawingml/2006/main" prst="rect">
             <a:avLst/>
@@ -3865,7 +3744,7 @@
           <p:cNvPr id="8" name="">
             <a:extLst xmlns:a="http://schemas.openxmlformats.org/drawingml/2006/main">
               <a:ext uri="{FF2B5EF4-FFF2-40B4-BE49-F238E27FC236}">
-                <a16:creationId xmlns:a16="http://schemas.microsoft.com/office/drawing/2014/main" id="{B9EC8408-CB75-4791-B1B3-DB96BBD2BBF9}"/>
+                <a16:creationId xmlns:a16="http://schemas.microsoft.com/office/drawing/2014/main" id="{5416ADFF-AC53-4E7F-9DD9-6EE97C581A5C}"/>
               </a:ext>
             </a:extLst>
           </p:cNvPr>
@@ -3876,7 +3755,7 @@
         </p:nvSpPr>
         <p:spPr>
           <a:xfrm xmlns:a="http://schemas.openxmlformats.org/drawingml/2006/main">
-            <a:off x="666750" y="4619625"/>
+            <a:off x="666750" y="4286250"/>
             <a:ext cx="4191000" cy="247650"/>
           </a:xfrm>
           <a:prstGeom xmlns:a="http://schemas.openxmlformats.org/drawingml/2006/main" prst="rect">
@@ -3911,7 +3790,7 @@
               </a:defRPr>
             </a:pPr>
             <a:r>
-              <a:t>LATEST TRANSFER</a:t>
+              <a:t>BUSINESS GOAL</a:t>
             </a:r>
           </a:p>
         </p:txBody>
@@ -3921,7 +3800,7 @@
           <p:cNvPr id="9" name="">
             <a:extLst xmlns:a="http://schemas.openxmlformats.org/drawingml/2006/main">
               <a:ext uri="{FF2B5EF4-FFF2-40B4-BE49-F238E27FC236}">
-                <a16:creationId xmlns:a16="http://schemas.microsoft.com/office/drawing/2014/main" id="{01D12358-E1CA-481B-B23B-DE6EDDCE24A2}"/>
+                <a16:creationId xmlns:a16="http://schemas.microsoft.com/office/drawing/2014/main" id="{79F037F6-2E4F-40F3-9169-551C3C1B5B68}"/>
               </a:ext>
             </a:extLst>
           </p:cNvPr>
@@ -3932,8 +3811,8 @@
         </p:nvSpPr>
         <p:spPr>
           <a:xfrm xmlns:a="http://schemas.openxmlformats.org/drawingml/2006/main">
-            <a:off x="666750" y="4953000"/>
-            <a:ext cx="4191000" cy="619125"/>
+            <a:off x="666750" y="4619625"/>
+            <a:ext cx="4191000" cy="714375"/>
           </a:xfrm>
           <a:prstGeom xmlns:a="http://schemas.openxmlformats.org/drawingml/2006/main" prst="rect">
             <a:avLst/>
@@ -3967,9 +3846,99 @@
               </a:defRPr>
             </a:pPr>
             <a:r>
-              <a:t>Implementation to Customer Success</a:t>
-            </a:r>
-          </a:p>
+              <a:t>One security view across six venues and monthly executive reporting. [S1, S2]</a:t>
+            </a:r>
+          </a:p>
+        </p:txBody>
+      </p:sp>
+      <p:sp>
+        <p:nvSpPr>
+          <p:cNvPr id="10" name="">
+            <a:extLst xmlns:a="http://schemas.openxmlformats.org/drawingml/2006/main">
+              <a:ext uri="{FF2B5EF4-FFF2-40B4-BE49-F238E27FC236}">
+                <a16:creationId xmlns:a16="http://schemas.microsoft.com/office/drawing/2014/main" id="{BA926219-B45F-4FD2-B247-7EAEDBC7ED8A}"/>
+              </a:ext>
+            </a:extLst>
+          </p:cNvPr>
+          <p:cNvSpPr>
+            <a:spLocks xmlns:a="http://schemas.openxmlformats.org/drawingml/2006/main" noGrp="1"/>
+          </p:cNvSpPr>
+          <p:nvPr/>
+        </p:nvSpPr>
+        <p:spPr>
+          <a:xfrm xmlns:a="http://schemas.openxmlformats.org/drawingml/2006/main">
+            <a:off x="5810250" y="2095500"/>
+            <a:ext cx="4857750" cy="247650"/>
+          </a:xfrm>
+          <a:prstGeom xmlns:a="http://schemas.openxmlformats.org/drawingml/2006/main" prst="rect">
+            <a:avLst/>
+          </a:prstGeom>
+          <a:noFill xmlns:a="http://schemas.openxmlformats.org/drawingml/2006/main"/>
+          <a:ln xmlns:a="http://schemas.openxmlformats.org/drawingml/2006/main" w="0">
+            <a:noFill/>
+          </a:ln>
+        </p:spPr>
+        <p:txBody>
+          <a:bodyPr xmlns:a="http://schemas.openxmlformats.org/drawingml/2006/main" lIns="0" tIns="0" rIns="0" bIns="0" anchor="t">
+            <a:normAutofit fontScale="100000"/>
+          </a:bodyPr>
+          <a:lstStyle xmlns:a="http://schemas.openxmlformats.org/drawingml/2006/main"/>
+          <a:p xmlns:a="http://schemas.openxmlformats.org/drawingml/2006/main">
+            <a:pPr marL="0" indent="0" algn="l">
+              <a:spcBef>
+                <a:spcPts val="0"/>
+              </a:spcBef>
+              <a:spcAft>
+                <a:spcPts val="0"/>
+              </a:spcAft>
+              <a:buNone/>
+              <a:defRPr sz="1125">
+                <a:solidFill>
+                  <a:srgbClr val="BCEF59"/>
+                </a:solidFill>
+                <a:latin typeface="Inter Medium"/>
+                <a:ea typeface="Inter Medium"/>
+                <a:cs typeface="Inter Medium"/>
+              </a:defRPr>
+            </a:pPr>
+            <a:r>
+              <a:t>WHAT THE DATA SAYS</a:t>
+            </a:r>
+          </a:p>
+        </p:txBody>
+      </p:sp>
+      <p:sp>
+        <p:nvSpPr>
+          <p:cNvPr id="11" name="">
+            <a:extLst xmlns:a="http://schemas.openxmlformats.org/drawingml/2006/main">
+              <a:ext uri="{FF2B5EF4-FFF2-40B4-BE49-F238E27FC236}">
+                <a16:creationId xmlns:a16="http://schemas.microsoft.com/office/drawing/2014/main" id="{D9185152-C824-4C9B-8F87-2191F5A46320}"/>
+              </a:ext>
+            </a:extLst>
+          </p:cNvPr>
+          <p:cNvSpPr>
+            <a:spLocks xmlns:a="http://schemas.openxmlformats.org/drawingml/2006/main" noGrp="1"/>
+          </p:cNvSpPr>
+          <p:nvPr/>
+        </p:nvSpPr>
+        <p:spPr>
+          <a:xfrm xmlns:a="http://schemas.openxmlformats.org/drawingml/2006/main">
+            <a:off x="5810250" y="2428875"/>
+            <a:ext cx="4857750" cy="1285875"/>
+          </a:xfrm>
+          <a:prstGeom xmlns:a="http://schemas.openxmlformats.org/drawingml/2006/main" prst="rect">
+            <a:avLst/>
+          </a:prstGeom>
+          <a:noFill xmlns:a="http://schemas.openxmlformats.org/drawingml/2006/main"/>
+          <a:ln xmlns:a="http://schemas.openxmlformats.org/drawingml/2006/main" w="0">
+            <a:noFill/>
+          </a:ln>
+        </p:spPr>
+        <p:txBody>
+          <a:bodyPr xmlns:a="http://schemas.openxmlformats.org/drawingml/2006/main" lIns="0" tIns="0" rIns="0" bIns="0" anchor="t">
+            <a:normAutofit fontScale="100000"/>
+          </a:bodyPr>
+          <a:lstStyle xmlns:a="http://schemas.openxmlformats.org/drawingml/2006/main"/>
           <a:p xmlns:a="http://schemas.openxmlformats.org/drawingml/2006/main">
             <a:pPr marL="0" indent="0" algn="l">
               <a:spcBef>
@@ -3989,17 +3958,17 @@
               </a:defRPr>
             </a:pPr>
             <a:r>
-              <a:t>2026-12-01 [S1]</a:t>
-            </a:r>
-          </a:p>
-        </p:txBody>
-      </p:sp>
-      <p:sp>
-        <p:nvSpPr>
-          <p:cNvPr id="10" name="">
-            <a:extLst xmlns:a="http://schemas.openxmlformats.org/drawingml/2006/main">
-              <a:ext uri="{FF2B5EF4-FFF2-40B4-BE49-F238E27FC236}">
-                <a16:creationId xmlns:a16="http://schemas.microsoft.com/office/drawing/2014/main" id="{C4EAFFAC-BAD4-42BD-B7B3-D2F3A56F50CD}"/>
+              <a:t>Six of six venues report to one dashboard. 96% of priority alerts arrive within 15 minutes. The 42-minute investigation target is still due Dec 18. [S1, S3]</a:t>
+            </a:r>
+          </a:p>
+        </p:txBody>
+      </p:sp>
+      <p:sp>
+        <p:nvSpPr>
+          <p:cNvPr id="12" name="">
+            <a:extLst xmlns:a="http://schemas.openxmlformats.org/drawingml/2006/main">
+              <a:ext uri="{FF2B5EF4-FFF2-40B4-BE49-F238E27FC236}">
+                <a16:creationId xmlns:a16="http://schemas.microsoft.com/office/drawing/2014/main" id="{D8886271-708F-42C7-A6FE-E2CC838B6D37}"/>
               </a:ext>
             </a:extLst>
           </p:cNvPr>
@@ -4010,7 +3979,7 @@
         </p:nvSpPr>
         <p:spPr>
           <a:xfrm xmlns:a="http://schemas.openxmlformats.org/drawingml/2006/main">
-            <a:off x="5810250" y="2286000"/>
+            <a:off x="5810250" y="4238625"/>
             <a:ext cx="4857750" cy="247650"/>
           </a:xfrm>
           <a:prstGeom xmlns:a="http://schemas.openxmlformats.org/drawingml/2006/main" prst="rect">
@@ -4045,17 +4014,17 @@
               </a:defRPr>
             </a:pPr>
             <a:r>
-              <a:t>SOURCE DATA</a:t>
-            </a:r>
-          </a:p>
-        </p:txBody>
-      </p:sp>
-      <p:sp>
-        <p:nvSpPr>
-          <p:cNvPr id="11" name="">
-            <a:extLst xmlns:a="http://schemas.openxmlformats.org/drawingml/2006/main">
-              <a:ext uri="{FF2B5EF4-FFF2-40B4-BE49-F238E27FC236}">
-                <a16:creationId xmlns:a16="http://schemas.microsoft.com/office/drawing/2014/main" id="{F4B00F97-ABA3-4212-9C04-2D87BD9BB316}"/>
+              <a:t>RECOMMENDATION</a:t>
+            </a:r>
+          </a:p>
+        </p:txBody>
+      </p:sp>
+      <p:sp>
+        <p:nvSpPr>
+          <p:cNvPr id="13" name="">
+            <a:extLst xmlns:a="http://schemas.openxmlformats.org/drawingml/2006/main">
+              <a:ext uri="{FF2B5EF4-FFF2-40B4-BE49-F238E27FC236}">
+                <a16:creationId xmlns:a16="http://schemas.microsoft.com/office/drawing/2014/main" id="{7FA9C4DD-E0FE-4CD2-9335-50851A492F3D}"/>
               </a:ext>
             </a:extLst>
           </p:cNvPr>
@@ -4066,8 +4035,8 @@
         </p:nvSpPr>
         <p:spPr>
           <a:xfrm xmlns:a="http://schemas.openxmlformats.org/drawingml/2006/main">
-            <a:off x="5810250" y="2619375"/>
-            <a:ext cx="4857750" cy="1143000"/>
+            <a:off x="5810250" y="4572000"/>
+            <a:ext cx="4857750" cy="1095375"/>
           </a:xfrm>
           <a:prstGeom xmlns:a="http://schemas.openxmlformats.org/drawingml/2006/main" prst="rect">
             <a:avLst/>
@@ -4101,163 +4070,7 @@
               </a:defRPr>
             </a:pPr>
             <a:r>
-              <a:t>Six venues are reporting and 96% of priority alerts arrive within 15 minutes. Training and QBR dates remain unconfirmed; the Dec 18 goal remains open. [S1, S3]</a:t>
-            </a:r>
-          </a:p>
-        </p:txBody>
-      </p:sp>
-      <p:sp>
-        <p:nvSpPr>
-          <p:cNvPr id="12" name="">
-            <a:extLst xmlns:a="http://schemas.openxmlformats.org/drawingml/2006/main">
-              <a:ext uri="{FF2B5EF4-FFF2-40B4-BE49-F238E27FC236}">
-                <a16:creationId xmlns:a16="http://schemas.microsoft.com/office/drawing/2014/main" id="{BA599D18-3175-43EA-84EC-94D027225BC7}"/>
-              </a:ext>
-            </a:extLst>
-          </p:cNvPr>
-          <p:cNvSpPr>
-            <a:spLocks xmlns:a="http://schemas.openxmlformats.org/drawingml/2006/main" noGrp="1"/>
-          </p:cNvSpPr>
-          <p:nvPr/>
-        </p:nvSpPr>
-        <p:spPr>
-          <a:xfrm xmlns:a="http://schemas.openxmlformats.org/drawingml/2006/main">
-            <a:off x="5810250" y="4238625"/>
-            <a:ext cx="4857750" cy="247650"/>
-          </a:xfrm>
-          <a:prstGeom xmlns:a="http://schemas.openxmlformats.org/drawingml/2006/main" prst="rect">
-            <a:avLst/>
-          </a:prstGeom>
-          <a:noFill xmlns:a="http://schemas.openxmlformats.org/drawingml/2006/main"/>
-          <a:ln xmlns:a="http://schemas.openxmlformats.org/drawingml/2006/main" w="0">
-            <a:noFill/>
-          </a:ln>
-        </p:spPr>
-        <p:txBody>
-          <a:bodyPr xmlns:a="http://schemas.openxmlformats.org/drawingml/2006/main" lIns="0" tIns="0" rIns="0" bIns="0" anchor="t">
-            <a:normAutofit fontScale="100000"/>
-          </a:bodyPr>
-          <a:lstStyle xmlns:a="http://schemas.openxmlformats.org/drawingml/2006/main"/>
-          <a:p xmlns:a="http://schemas.openxmlformats.org/drawingml/2006/main">
-            <a:pPr marL="0" indent="0" algn="l">
-              <a:spcBef>
-                <a:spcPts val="0"/>
-              </a:spcBef>
-              <a:spcAft>
-                <a:spcPts val="0"/>
-              </a:spcAft>
-              <a:buNone/>
-              <a:defRPr sz="1125">
-                <a:solidFill>
-                  <a:srgbClr val="BCEF59"/>
-                </a:solidFill>
-                <a:latin typeface="Inter Medium"/>
-                <a:ea typeface="Inter Medium"/>
-                <a:cs typeface="Inter Medium"/>
-              </a:defRPr>
-            </a:pPr>
-            <a:r>
-              <a:t>CUSTOMER CONTEXT</a:t>
-            </a:r>
-          </a:p>
-        </p:txBody>
-      </p:sp>
-      <p:sp>
-        <p:nvSpPr>
-          <p:cNvPr id="13" name="">
-            <a:extLst xmlns:a="http://schemas.openxmlformats.org/drawingml/2006/main">
-              <a:ext uri="{FF2B5EF4-FFF2-40B4-BE49-F238E27FC236}">
-                <a16:creationId xmlns:a16="http://schemas.microsoft.com/office/drawing/2014/main" id="{2F6D8674-9C79-4497-A81A-F04AC3C3898D}"/>
-              </a:ext>
-            </a:extLst>
-          </p:cNvPr>
-          <p:cNvSpPr>
-            <a:spLocks xmlns:a="http://schemas.openxmlformats.org/drawingml/2006/main" noGrp="1"/>
-          </p:cNvSpPr>
-          <p:nvPr/>
-        </p:nvSpPr>
-        <p:spPr>
-          <a:xfrm xmlns:a="http://schemas.openxmlformats.org/drawingml/2006/main">
-            <a:off x="5810250" y="4572000"/>
-            <a:ext cx="4857750" cy="1238250"/>
-          </a:xfrm>
-          <a:prstGeom xmlns:a="http://schemas.openxmlformats.org/drawingml/2006/main" prst="rect">
-            <a:avLst/>
-          </a:prstGeom>
-          <a:noFill xmlns:a="http://schemas.openxmlformats.org/drawingml/2006/main"/>
-          <a:ln xmlns:a="http://schemas.openxmlformats.org/drawingml/2006/main" w="0">
-            <a:noFill/>
-          </a:ln>
-        </p:spPr>
-        <p:txBody>
-          <a:bodyPr xmlns:a="http://schemas.openxmlformats.org/drawingml/2006/main" lIns="0" tIns="0" rIns="0" bIns="0" anchor="t">
-            <a:normAutofit fontScale="91926"/>
-          </a:bodyPr>
-          <a:lstStyle xmlns:a="http://schemas.openxmlformats.org/drawingml/2006/main"/>
-          <a:p xmlns:a="http://schemas.openxmlformats.org/drawingml/2006/main">
-            <a:pPr marL="0" indent="0" algn="l">
-              <a:spcBef>
-                <a:spcPts val="0"/>
-              </a:spcBef>
-              <a:spcAft>
-                <a:spcPts val="0"/>
-              </a:spcAft>
-              <a:buNone/>
-              <a:defRPr sz="1575">
-                <a:solidFill>
-                  <a:srgbClr val="FFFFFF"/>
-                </a:solidFill>
-                <a:latin typeface="Inter"/>
-                <a:ea typeface="Inter"/>
-                <a:cs typeface="Inter"/>
-              </a:defRPr>
-            </a:pPr>
-            <a:r>
-              <a:t>Maintain a single security view across six venues and monthly executive reporting. [S1, S2]</a:t>
-            </a:r>
-          </a:p>
-          <a:p xmlns:a="http://schemas.openxmlformats.org/drawingml/2006/main">
-            <a:pPr marL="0" indent="0" algn="l">
-              <a:spcBef>
-                <a:spcPts val="0"/>
-              </a:spcBef>
-              <a:spcAft>
-                <a:spcPts val="0"/>
-              </a:spcAft>
-              <a:buNone/>
-              <a:defRPr sz="1575">
-                <a:solidFill>
-                  <a:srgbClr val="FFFFFF"/>
-                </a:solidFill>
-                <a:latin typeface="Inter"/>
-                <a:ea typeface="Inter"/>
-                <a:cs typeface="Inter"/>
-              </a:defRPr>
-            </a:pPr>
-            <a:r>
-              <a:t/>
-            </a:r>
-          </a:p>
-          <a:p xmlns:a="http://schemas.openxmlformats.org/drawingml/2006/main">
-            <a:pPr marL="0" indent="0" algn="l">
-              <a:spcBef>
-                <a:spcPts val="0"/>
-              </a:spcBef>
-              <a:spcAft>
-                <a:spcPts val="0"/>
-              </a:spcAft>
-              <a:buNone/>
-              <a:defRPr sz="1575">
-                <a:solidFill>
-                  <a:srgbClr val="FFFFFF"/>
-                </a:solidFill>
-                <a:latin typeface="Inter"/>
-                <a:ea typeface="Inter"/>
-                <a:cs typeface="Inter"/>
-              </a:defRPr>
-            </a:pPr>
-            <a:r>
-              <a:t>Althea Cassidy owns Customer Success. Scarlet remains sponsor; Casey remains the customer technical owner. [S1]</a:t>
+              <a:t>Keep this handoff open. Althea should confirm the training and first QBR dates. Ruben should validate the 42-minute investigation target by Dec 18. [S1, S3]</a:t>
             </a:r>
           </a:p>
         </p:txBody>
@@ -4293,10 +4106,10 @@
       </p:grpSpPr>
       <p:sp>
         <p:nvSpPr>
-          <p:cNvPr id="14" name="">
-            <a:extLst xmlns:a="http://schemas.openxmlformats.org/drawingml/2006/main">
-              <a:ext uri="{FF2B5EF4-FFF2-40B4-BE49-F238E27FC236}">
-                <a16:creationId xmlns:a16="http://schemas.microsoft.com/office/drawing/2014/main" id="{728B79FF-7489-4FE1-81C4-155D7D97C66A}"/>
+          <p:cNvPr id="15" name="">
+            <a:extLst xmlns:a="http://schemas.openxmlformats.org/drawingml/2006/main">
+              <a:ext uri="{FF2B5EF4-FFF2-40B4-BE49-F238E27FC236}">
+                <a16:creationId xmlns:a16="http://schemas.microsoft.com/office/drawing/2014/main" id="{C4220142-EC42-4701-9628-3C62AE50AD23}"/>
               </a:ext>
             </a:extLst>
           </p:cNvPr>
@@ -4342,7 +4155,7 @@
               </a:defRPr>
             </a:pPr>
             <a:r>
-              <a:t>WORK THAT STILL NEEDS AN OWNER OR DATE</a:t>
+              <a:t>WHAT NEEDS TO HAPPEN NEXT</a:t>
             </a:r>
           </a:p>
         </p:txBody>
@@ -4352,7 +4165,7 @@
           <p:cNvPr id="2" name="">
             <a:extLst xmlns:a="http://schemas.openxmlformats.org/drawingml/2006/main">
               <a:ext uri="{FF2B5EF4-FFF2-40B4-BE49-F238E27FC236}">
-                <a16:creationId xmlns:a16="http://schemas.microsoft.com/office/drawing/2014/main" id="{5745B60E-F8BF-4573-949C-E904C10FC64A}"/>
+                <a16:creationId xmlns:a16="http://schemas.microsoft.com/office/drawing/2014/main" id="{A7753613-2B2F-4000-8D7A-7B20853D6231}"/>
               </a:ext>
             </a:extLst>
           </p:cNvPr>
@@ -4398,7 +4211,7 @@
               </a:defRPr>
             </a:pPr>
             <a:r>
-              <a:t>Open action items</a:t>
+              <a:t>Recommended next steps</a:t>
             </a:r>
           </a:p>
         </p:txBody>
@@ -4408,7 +4221,7 @@
           <p:cNvPr id="3" name="">
             <a:extLst xmlns:a="http://schemas.openxmlformats.org/drawingml/2006/main">
               <a:ext uri="{FF2B5EF4-FFF2-40B4-BE49-F238E27FC236}">
-                <a16:creationId xmlns:a16="http://schemas.microsoft.com/office/drawing/2014/main" id="{FA9DAD2B-42AE-4933-8D5A-7DD02F1645B0}"/>
+                <a16:creationId xmlns:a16="http://schemas.microsoft.com/office/drawing/2014/main" id="{3ED53E20-46DC-4338-BFB0-CFC4BEDB80E8}"/>
               </a:ext>
             </a:extLst>
           </p:cNvPr>
@@ -4464,7 +4277,7 @@
           <p:cNvPr id="4" name="">
             <a:extLst xmlns:a="http://schemas.openxmlformats.org/drawingml/2006/main">
               <a:ext uri="{FF2B5EF4-FFF2-40B4-BE49-F238E27FC236}">
-                <a16:creationId xmlns:a16="http://schemas.microsoft.com/office/drawing/2014/main" id="{EA913B38-65FF-454F-93C2-20BDCF127CAA}"/>
+                <a16:creationId xmlns:a16="http://schemas.microsoft.com/office/drawing/2014/main" id="{561D6FF6-5DCF-41CF-9FDA-7AC7F7B41555}"/>
               </a:ext>
             </a:extLst>
           </p:cNvPr>
@@ -4520,7 +4333,7 @@
           <p:cNvPr id="5" name="">
             <a:extLst xmlns:a="http://schemas.openxmlformats.org/drawingml/2006/main">
               <a:ext uri="{FF2B5EF4-FFF2-40B4-BE49-F238E27FC236}">
-                <a16:creationId xmlns:a16="http://schemas.microsoft.com/office/drawing/2014/main" id="{D6157B69-0561-487D-815C-7DB9AFF6EC9F}"/>
+                <a16:creationId xmlns:a16="http://schemas.microsoft.com/office/drawing/2014/main" id="{4649A774-93C9-4D67-B59B-05885AC1CE3C}"/>
               </a:ext>
             </a:extLst>
           </p:cNvPr>
@@ -4531,8 +4344,8 @@
         </p:nvSpPr>
         <p:spPr>
           <a:xfrm xmlns:a="http://schemas.openxmlformats.org/drawingml/2006/main">
-            <a:off x="666750" y="2190750"/>
-            <a:ext cx="400050" cy="400050"/>
+            <a:off x="666750" y="1809750"/>
+            <a:ext cx="9810750" cy="400050"/>
           </a:xfrm>
           <a:prstGeom xmlns:a="http://schemas.openxmlformats.org/drawingml/2006/main" prst="rect">
             <a:avLst/>
@@ -4556,7 +4369,63 @@
                 <a:spcPts val="0"/>
               </a:spcAft>
               <a:buNone/>
-              <a:defRPr sz="2100">
+              <a:defRPr sz="1575">
+                <a:solidFill>
+                  <a:srgbClr val="0A2D22"/>
+                </a:solidFill>
+                <a:latin typeface="Inter Medium"/>
+                <a:ea typeface="Inter Medium"/>
+                <a:cs typeface="Inter Medium"/>
+              </a:defRPr>
+            </a:pPr>
+            <a:r>
+              <a:t>Do not close the handoff until the two customer dates and Dec 18 measurement are recorded.</a:t>
+            </a:r>
+          </a:p>
+        </p:txBody>
+      </p:sp>
+      <p:sp>
+        <p:nvSpPr>
+          <p:cNvPr id="6" name="">
+            <a:extLst xmlns:a="http://schemas.openxmlformats.org/drawingml/2006/main">
+              <a:ext uri="{FF2B5EF4-FFF2-40B4-BE49-F238E27FC236}">
+                <a16:creationId xmlns:a16="http://schemas.microsoft.com/office/drawing/2014/main" id="{30C34525-AC36-471B-A271-95D956893716}"/>
+              </a:ext>
+            </a:extLst>
+          </p:cNvPr>
+          <p:cNvSpPr>
+            <a:spLocks xmlns:a="http://schemas.openxmlformats.org/drawingml/2006/main" noGrp="1"/>
+          </p:cNvSpPr>
+          <p:nvPr/>
+        </p:nvSpPr>
+        <p:spPr>
+          <a:xfrm xmlns:a="http://schemas.openxmlformats.org/drawingml/2006/main">
+            <a:off x="666750" y="2619375"/>
+            <a:ext cx="1333500" cy="266700"/>
+          </a:xfrm>
+          <a:prstGeom xmlns:a="http://schemas.openxmlformats.org/drawingml/2006/main" prst="rect">
+            <a:avLst/>
+          </a:prstGeom>
+          <a:noFill xmlns:a="http://schemas.openxmlformats.org/drawingml/2006/main"/>
+          <a:ln xmlns:a="http://schemas.openxmlformats.org/drawingml/2006/main" w="0">
+            <a:noFill/>
+          </a:ln>
+        </p:spPr>
+        <p:txBody>
+          <a:bodyPr xmlns:a="http://schemas.openxmlformats.org/drawingml/2006/main" lIns="0" tIns="0" rIns="0" bIns="0" anchor="t">
+            <a:normAutofit fontScale="100000"/>
+          </a:bodyPr>
+          <a:lstStyle xmlns:a="http://schemas.openxmlformats.org/drawingml/2006/main"/>
+          <a:p xmlns:a="http://schemas.openxmlformats.org/drawingml/2006/main">
+            <a:pPr marL="0" indent="0" algn="l">
+              <a:spcBef>
+                <a:spcPts val="0"/>
+              </a:spcBef>
+              <a:spcAft>
+                <a:spcPts val="0"/>
+              </a:spcAft>
+              <a:buNone/>
+              <a:defRPr sz="1125">
                 <a:solidFill>
                   <a:srgbClr val="4A7A1D"/>
                 </a:solidFill>
@@ -4566,17 +4435,17 @@
               </a:defRPr>
             </a:pPr>
             <a:r>
-              <a:t>1</a:t>
-            </a:r>
-          </a:p>
-        </p:txBody>
-      </p:sp>
-      <p:sp>
-        <p:nvSpPr>
-          <p:cNvPr id="6" name="">
-            <a:extLst xmlns:a="http://schemas.openxmlformats.org/drawingml/2006/main">
-              <a:ext uri="{FF2B5EF4-FFF2-40B4-BE49-F238E27FC236}">
-                <a16:creationId xmlns:a16="http://schemas.microsoft.com/office/drawing/2014/main" id="{D7E53566-B01A-4B82-8F86-3E2A261D3734}"/>
+              <a:t>PRIORITY 1</a:t>
+            </a:r>
+          </a:p>
+        </p:txBody>
+      </p:sp>
+      <p:sp>
+        <p:nvSpPr>
+          <p:cNvPr id="7" name="">
+            <a:extLst xmlns:a="http://schemas.openxmlformats.org/drawingml/2006/main">
+              <a:ext uri="{FF2B5EF4-FFF2-40B4-BE49-F238E27FC236}">
+                <a16:creationId xmlns:a16="http://schemas.microsoft.com/office/drawing/2014/main" id="{161AC08E-F0D0-4C32-8BE1-8E423109F5B4}"/>
               </a:ext>
             </a:extLst>
           </p:cNvPr>
@@ -4587,8 +4456,8 @@
         </p:nvSpPr>
         <p:spPr>
           <a:xfrm xmlns:a="http://schemas.openxmlformats.org/drawingml/2006/main">
-            <a:off x="1285875" y="2190750"/>
-            <a:ext cx="6191250" cy="666750"/>
+            <a:off x="666750" y="2981325"/>
+            <a:ext cx="6191250" cy="590550"/>
           </a:xfrm>
           <a:prstGeom xmlns:a="http://schemas.openxmlformats.org/drawingml/2006/main" prst="rect">
             <a:avLst/>
@@ -4612,7 +4481,7 @@
                 <a:spcPts val="0"/>
               </a:spcAft>
               <a:buNone/>
-              <a:defRPr sz="1650">
+              <a:defRPr sz="1575">
                 <a:solidFill>
                   <a:srgbClr val="0A2D22"/>
                 </a:solidFill>
@@ -4629,10 +4498,10 @@
       </p:sp>
       <p:sp>
         <p:nvSpPr>
-          <p:cNvPr id="7" name="">
-            <a:extLst xmlns:a="http://schemas.openxmlformats.org/drawingml/2006/main">
-              <a:ext uri="{FF2B5EF4-FFF2-40B4-BE49-F238E27FC236}">
-                <a16:creationId xmlns:a16="http://schemas.microsoft.com/office/drawing/2014/main" id="{D1A62A52-F939-4EA2-BAA8-DA70A6E7A715}"/>
+          <p:cNvPr id="8" name="">
+            <a:extLst xmlns:a="http://schemas.openxmlformats.org/drawingml/2006/main">
+              <a:ext uri="{FF2B5EF4-FFF2-40B4-BE49-F238E27FC236}">
+                <a16:creationId xmlns:a16="http://schemas.microsoft.com/office/drawing/2014/main" id="{47FE66B8-2060-4311-9C04-562B72B17369}"/>
               </a:ext>
             </a:extLst>
           </p:cNvPr>
@@ -4643,8 +4512,8 @@
         </p:nvSpPr>
         <p:spPr>
           <a:xfrm xmlns:a="http://schemas.openxmlformats.org/drawingml/2006/main">
-            <a:off x="7905750" y="2209800"/>
-            <a:ext cx="2762250" cy="590550"/>
+            <a:off x="7667625" y="2981325"/>
+            <a:ext cx="3000375" cy="590550"/>
           </a:xfrm>
           <a:prstGeom xmlns:a="http://schemas.openxmlformats.org/drawingml/2006/main" prst="rect">
             <a:avLst/>
@@ -4668,7 +4537,7 @@
                 <a:spcPts val="0"/>
               </a:spcAft>
               <a:buNone/>
-              <a:defRPr sz="1350">
+              <a:defRPr sz="1275">
                 <a:solidFill>
                   <a:srgbClr val="0A2D22"/>
                 </a:solidFill>
@@ -4678,7 +4547,7 @@
               </a:defRPr>
             </a:pPr>
             <a:r>
-              <a:t>Ruben Cherise (Implementation)</a:t>
+              <a:t>Owner: Ruben Cherise (Implementation)</a:t>
             </a:r>
           </a:p>
           <a:p xmlns:a="http://schemas.openxmlformats.org/drawingml/2006/main">
@@ -4690,7 +4559,7 @@
                 <a:spcPts val="0"/>
               </a:spcAft>
               <a:buNone/>
-              <a:defRPr sz="1350">
+              <a:defRPr sz="1275">
                 <a:solidFill>
                   <a:srgbClr val="0A2D22"/>
                 </a:solidFill>
@@ -4707,10 +4576,10 @@
       </p:sp>
       <p:sp>
         <p:nvSpPr>
-          <p:cNvPr id="8" name="">
-            <a:extLst xmlns:a="http://schemas.openxmlformats.org/drawingml/2006/main">
-              <a:ext uri="{FF2B5EF4-FFF2-40B4-BE49-F238E27FC236}">
-                <a16:creationId xmlns:a16="http://schemas.microsoft.com/office/drawing/2014/main" id="{590F48F6-F124-4CBB-A851-8955C0C92566}"/>
+          <p:cNvPr id="9" name="">
+            <a:extLst xmlns:a="http://schemas.openxmlformats.org/drawingml/2006/main">
+              <a:ext uri="{FF2B5EF4-FFF2-40B4-BE49-F238E27FC236}">
+                <a16:creationId xmlns:a16="http://schemas.microsoft.com/office/drawing/2014/main" id="{01C6F0FE-15DA-4500-BB0C-BF45391D199D}"/>
               </a:ext>
             </a:extLst>
           </p:cNvPr>
@@ -4721,8 +4590,8 @@
         </p:nvSpPr>
         <p:spPr>
           <a:xfrm xmlns:a="http://schemas.openxmlformats.org/drawingml/2006/main">
-            <a:off x="666750" y="3476625"/>
-            <a:ext cx="400050" cy="400050"/>
+            <a:off x="666750" y="3810000"/>
+            <a:ext cx="1333500" cy="266700"/>
           </a:xfrm>
           <a:prstGeom xmlns:a="http://schemas.openxmlformats.org/drawingml/2006/main" prst="rect">
             <a:avLst/>
@@ -4746,7 +4615,7 @@
                 <a:spcPts val="0"/>
               </a:spcAft>
               <a:buNone/>
-              <a:defRPr sz="2100">
+              <a:defRPr sz="1125">
                 <a:solidFill>
                   <a:srgbClr val="4A7A1D"/>
                 </a:solidFill>
@@ -4756,17 +4625,17 @@
               </a:defRPr>
             </a:pPr>
             <a:r>
-              <a:t>2</a:t>
-            </a:r>
-          </a:p>
-        </p:txBody>
-      </p:sp>
-      <p:sp>
-        <p:nvSpPr>
-          <p:cNvPr id="9" name="">
-            <a:extLst xmlns:a="http://schemas.openxmlformats.org/drawingml/2006/main">
-              <a:ext uri="{FF2B5EF4-FFF2-40B4-BE49-F238E27FC236}">
-                <a16:creationId xmlns:a16="http://schemas.microsoft.com/office/drawing/2014/main" id="{968C870D-5CAB-497B-B00C-2E50B0A29217}"/>
+              <a:t>PRIORITY 2</a:t>
+            </a:r>
+          </a:p>
+        </p:txBody>
+      </p:sp>
+      <p:sp>
+        <p:nvSpPr>
+          <p:cNvPr id="10" name="">
+            <a:extLst xmlns:a="http://schemas.openxmlformats.org/drawingml/2006/main">
+              <a:ext uri="{FF2B5EF4-FFF2-40B4-BE49-F238E27FC236}">
+                <a16:creationId xmlns:a16="http://schemas.microsoft.com/office/drawing/2014/main" id="{ABB39DF1-2F05-4D04-B667-4271DC2310B0}"/>
               </a:ext>
             </a:extLst>
           </p:cNvPr>
@@ -4777,8 +4646,8 @@
         </p:nvSpPr>
         <p:spPr>
           <a:xfrm xmlns:a="http://schemas.openxmlformats.org/drawingml/2006/main">
-            <a:off x="1285875" y="3476625"/>
-            <a:ext cx="6191250" cy="666750"/>
+            <a:off x="666750" y="4171950"/>
+            <a:ext cx="6191250" cy="590550"/>
           </a:xfrm>
           <a:prstGeom xmlns:a="http://schemas.openxmlformats.org/drawingml/2006/main" prst="rect">
             <a:avLst/>
@@ -4802,7 +4671,7 @@
                 <a:spcPts val="0"/>
               </a:spcAft>
               <a:buNone/>
-              <a:defRPr sz="1650">
+              <a:defRPr sz="1575">
                 <a:solidFill>
                   <a:srgbClr val="0A2D22"/>
                 </a:solidFill>
@@ -4819,10 +4688,10 @@
       </p:sp>
       <p:sp>
         <p:nvSpPr>
-          <p:cNvPr id="10" name="">
-            <a:extLst xmlns:a="http://schemas.openxmlformats.org/drawingml/2006/main">
-              <a:ext uri="{FF2B5EF4-FFF2-40B4-BE49-F238E27FC236}">
-                <a16:creationId xmlns:a16="http://schemas.microsoft.com/office/drawing/2014/main" id="{BFB44FC8-2845-4D76-8A2F-E9B8CF841582}"/>
+          <p:cNvPr id="11" name="">
+            <a:extLst xmlns:a="http://schemas.openxmlformats.org/drawingml/2006/main">
+              <a:ext uri="{FF2B5EF4-FFF2-40B4-BE49-F238E27FC236}">
+                <a16:creationId xmlns:a16="http://schemas.microsoft.com/office/drawing/2014/main" id="{34B98750-B637-4009-88C5-E6C4211CCBCA}"/>
               </a:ext>
             </a:extLst>
           </p:cNvPr>
@@ -4833,8 +4702,8 @@
         </p:nvSpPr>
         <p:spPr>
           <a:xfrm xmlns:a="http://schemas.openxmlformats.org/drawingml/2006/main">
-            <a:off x="7905750" y="3495675"/>
-            <a:ext cx="2762250" cy="590550"/>
+            <a:off x="7667625" y="4171950"/>
+            <a:ext cx="3000375" cy="590550"/>
           </a:xfrm>
           <a:prstGeom xmlns:a="http://schemas.openxmlformats.org/drawingml/2006/main" prst="rect">
             <a:avLst/>
@@ -4858,7 +4727,7 @@
                 <a:spcPts val="0"/>
               </a:spcAft>
               <a:buNone/>
-              <a:defRPr sz="1350">
+              <a:defRPr sz="1275">
                 <a:solidFill>
                   <a:srgbClr val="0A2D22"/>
                 </a:solidFill>
@@ -4868,7 +4737,7 @@
               </a:defRPr>
             </a:pPr>
             <a:r>
-              <a:t>Althea Cassidy (Customer Success)</a:t>
+              <a:t>Owner: Althea Cassidy (Customer Success)</a:t>
             </a:r>
           </a:p>
           <a:p xmlns:a="http://schemas.openxmlformats.org/drawingml/2006/main">
@@ -4880,7 +4749,7 @@
                 <a:spcPts val="0"/>
               </a:spcAft>
               <a:buNone/>
-              <a:defRPr sz="1350">
+              <a:defRPr sz="1275">
                 <a:solidFill>
                   <a:srgbClr val="0A2D22"/>
                 </a:solidFill>
@@ -4890,17 +4759,17 @@
               </a:defRPr>
             </a:pPr>
             <a:r>
-              <a:t>Due: Not Confirmed</a:t>
-            </a:r>
-          </a:p>
-        </p:txBody>
-      </p:sp>
-      <p:sp>
-        <p:nvSpPr>
-          <p:cNvPr id="11" name="">
-            <a:extLst xmlns:a="http://schemas.openxmlformats.org/drawingml/2006/main">
-              <a:ext uri="{FF2B5EF4-FFF2-40B4-BE49-F238E27FC236}">
-                <a16:creationId xmlns:a16="http://schemas.microsoft.com/office/drawing/2014/main" id="{2B0C7FF5-F785-4059-BA98-89E99CB922EF}"/>
+              <a:t>Due: Confirm date</a:t>
+            </a:r>
+          </a:p>
+        </p:txBody>
+      </p:sp>
+      <p:sp>
+        <p:nvSpPr>
+          <p:cNvPr id="12" name="">
+            <a:extLst xmlns:a="http://schemas.openxmlformats.org/drawingml/2006/main">
+              <a:ext uri="{FF2B5EF4-FFF2-40B4-BE49-F238E27FC236}">
+                <a16:creationId xmlns:a16="http://schemas.microsoft.com/office/drawing/2014/main" id="{1AA338AB-BA36-4D75-A48A-5C897285C8AE}"/>
               </a:ext>
             </a:extLst>
           </p:cNvPr>
@@ -4911,8 +4780,8 @@
         </p:nvSpPr>
         <p:spPr>
           <a:xfrm xmlns:a="http://schemas.openxmlformats.org/drawingml/2006/main">
-            <a:off x="666750" y="4762500"/>
-            <a:ext cx="400050" cy="400050"/>
+            <a:off x="666750" y="5000625"/>
+            <a:ext cx="1333500" cy="266700"/>
           </a:xfrm>
           <a:prstGeom xmlns:a="http://schemas.openxmlformats.org/drawingml/2006/main" prst="rect">
             <a:avLst/>
@@ -4936,7 +4805,7 @@
                 <a:spcPts val="0"/>
               </a:spcAft>
               <a:buNone/>
-              <a:defRPr sz="2100">
+              <a:defRPr sz="1125">
                 <a:solidFill>
                   <a:srgbClr val="4A7A1D"/>
                 </a:solidFill>
@@ -4946,17 +4815,17 @@
               </a:defRPr>
             </a:pPr>
             <a:r>
-              <a:t>3</a:t>
-            </a:r>
-          </a:p>
-        </p:txBody>
-      </p:sp>
-      <p:sp>
-        <p:nvSpPr>
-          <p:cNvPr id="12" name="">
-            <a:extLst xmlns:a="http://schemas.openxmlformats.org/drawingml/2006/main">
-              <a:ext uri="{FF2B5EF4-FFF2-40B4-BE49-F238E27FC236}">
-                <a16:creationId xmlns:a16="http://schemas.microsoft.com/office/drawing/2014/main" id="{FBDF9F80-8A76-4080-ADD6-95E551D4A2E2}"/>
+              <a:t>PRIORITY 3</a:t>
+            </a:r>
+          </a:p>
+        </p:txBody>
+      </p:sp>
+      <p:sp>
+        <p:nvSpPr>
+          <p:cNvPr id="13" name="">
+            <a:extLst xmlns:a="http://schemas.openxmlformats.org/drawingml/2006/main">
+              <a:ext uri="{FF2B5EF4-FFF2-40B4-BE49-F238E27FC236}">
+                <a16:creationId xmlns:a16="http://schemas.microsoft.com/office/drawing/2014/main" id="{9519D258-0E0D-4799-AC9C-6322B8899980}"/>
               </a:ext>
             </a:extLst>
           </p:cNvPr>
@@ -4967,8 +4836,8 @@
         </p:nvSpPr>
         <p:spPr>
           <a:xfrm xmlns:a="http://schemas.openxmlformats.org/drawingml/2006/main">
-            <a:off x="1285875" y="4762500"/>
-            <a:ext cx="6191250" cy="666750"/>
+            <a:off x="666750" y="5362575"/>
+            <a:ext cx="6191250" cy="590550"/>
           </a:xfrm>
           <a:prstGeom xmlns:a="http://schemas.openxmlformats.org/drawingml/2006/main" prst="rect">
             <a:avLst/>
@@ -4992,7 +4861,7 @@
                 <a:spcPts val="0"/>
               </a:spcAft>
               <a:buNone/>
-              <a:defRPr sz="1650">
+              <a:defRPr sz="1575">
                 <a:solidFill>
                   <a:srgbClr val="0A2D22"/>
                 </a:solidFill>
@@ -5009,10 +4878,10 @@
       </p:sp>
       <p:sp>
         <p:nvSpPr>
-          <p:cNvPr id="13" name="">
-            <a:extLst xmlns:a="http://schemas.openxmlformats.org/drawingml/2006/main">
-              <a:ext uri="{FF2B5EF4-FFF2-40B4-BE49-F238E27FC236}">
-                <a16:creationId xmlns:a16="http://schemas.microsoft.com/office/drawing/2014/main" id="{5994DB51-DFBD-451E-8BA4-D6EA10C75F6F}"/>
+          <p:cNvPr id="14" name="">
+            <a:extLst xmlns:a="http://schemas.openxmlformats.org/drawingml/2006/main">
+              <a:ext uri="{FF2B5EF4-FFF2-40B4-BE49-F238E27FC236}">
+                <a16:creationId xmlns:a16="http://schemas.microsoft.com/office/drawing/2014/main" id="{1094815B-04CF-4C80-B9C1-50A9AE55AAE5}"/>
               </a:ext>
             </a:extLst>
           </p:cNvPr>
@@ -5023,8 +4892,8 @@
         </p:nvSpPr>
         <p:spPr>
           <a:xfrm xmlns:a="http://schemas.openxmlformats.org/drawingml/2006/main">
-            <a:off x="7905750" y="4781550"/>
-            <a:ext cx="2762250" cy="590550"/>
+            <a:off x="7667625" y="5362575"/>
+            <a:ext cx="3000375" cy="590550"/>
           </a:xfrm>
           <a:prstGeom xmlns:a="http://schemas.openxmlformats.org/drawingml/2006/main" prst="rect">
             <a:avLst/>
@@ -5048,7 +4917,7 @@
                 <a:spcPts val="0"/>
               </a:spcAft>
               <a:buNone/>
-              <a:defRPr sz="1350">
+              <a:defRPr sz="1275">
                 <a:solidFill>
                   <a:srgbClr val="0A2D22"/>
                 </a:solidFill>
@@ -5058,7 +4927,7 @@
               </a:defRPr>
             </a:pPr>
             <a:r>
-              <a:t>Althea Cassidy (Customer Success)</a:t>
+              <a:t>Owner: Althea Cassidy (Customer Success)</a:t>
             </a:r>
           </a:p>
           <a:p xmlns:a="http://schemas.openxmlformats.org/drawingml/2006/main">
@@ -5070,7 +4939,7 @@
                 <a:spcPts val="0"/>
               </a:spcAft>
               <a:buNone/>
-              <a:defRPr sz="1350">
+              <a:defRPr sz="1275">
                 <a:solidFill>
                   <a:srgbClr val="0A2D22"/>
                 </a:solidFill>
@@ -5080,708 +4949,7 @@
               </a:defRPr>
             </a:pPr>
             <a:r>
-              <a:t>Due: Not Confirmed</a:t>
-            </a:r>
-          </a:p>
-        </p:txBody>
-      </p:sp>
-    </p:spTree>
-    <p:extLst>
-      <p:ext uri="{BB962C8B-B14F-4D97-AF65-F5344CB8AC3E}">
-        <p14:creationId xmlns:p14="http://schemas.microsoft.com/office/powerpoint/2010/main" val="360145486"/>
-      </p:ext>
-    </p:extLst>
-  </p:cSld>
-</p:sld>
-</file>
-
-<file path=ppt/slides/slide3.xml><?xml version="1.0" encoding="utf-8"?>
-<p:sld xmlns:p="http://schemas.openxmlformats.org/presentationml/2006/main">
-  <p:cSld>
-    <p:bg>
-      <p:bgPr>
-        <a:solidFill xmlns:a="http://schemas.openxmlformats.org/drawingml/2006/main">
-          <a:srgbClr val="0A2D22"/>
-        </a:solidFill>
-      </p:bgPr>
-    </p:bg>
-    <p:spTree>
-      <p:nvGrpSpPr>
-        <p:cNvPr id="1" name=""/>
-        <p:cNvGrpSpPr/>
-        <p:nvPr/>
-      </p:nvGrpSpPr>
-      <p:grpSpPr>
-        <a:xfrm xmlns:a="http://schemas.openxmlformats.org/drawingml/2006/main"/>
-      </p:grpSpPr>
-      <p:sp>
-        <p:nvSpPr>
-          <p:cNvPr id="13" name="">
-            <a:extLst xmlns:a="http://schemas.openxmlformats.org/drawingml/2006/main">
-              <a:ext uri="{FF2B5EF4-FFF2-40B4-BE49-F238E27FC236}">
-                <a16:creationId xmlns:a16="http://schemas.microsoft.com/office/drawing/2014/main" id="{C39E55FA-F7BB-4698-8308-B4D5BE955188}"/>
-              </a:ext>
-            </a:extLst>
-          </p:cNvPr>
-          <p:cNvSpPr>
-            <a:spLocks xmlns:a="http://schemas.openxmlformats.org/drawingml/2006/main" noGrp="1"/>
-          </p:cNvSpPr>
-          <p:nvPr/>
-        </p:nvSpPr>
-        <p:spPr>
-          <a:xfrm xmlns:a="http://schemas.openxmlformats.org/drawingml/2006/main">
-            <a:off x="666750" y="476250"/>
-            <a:ext cx="10477500" cy="247650"/>
-          </a:xfrm>
-          <a:prstGeom xmlns:a="http://schemas.openxmlformats.org/drawingml/2006/main" prst="rect">
-            <a:avLst/>
-          </a:prstGeom>
-          <a:noFill xmlns:a="http://schemas.openxmlformats.org/drawingml/2006/main"/>
-          <a:ln xmlns:a="http://schemas.openxmlformats.org/drawingml/2006/main" w="0">
-            <a:noFill/>
-          </a:ln>
-        </p:spPr>
-        <p:txBody>
-          <a:bodyPr xmlns:a="http://schemas.openxmlformats.org/drawingml/2006/main" lIns="0" tIns="0" rIns="0" bIns="0" anchor="t">
-            <a:normAutofit fontScale="100000"/>
-          </a:bodyPr>
-          <a:lstStyle xmlns:a="http://schemas.openxmlformats.org/drawingml/2006/main"/>
-          <a:p xmlns:a="http://schemas.openxmlformats.org/drawingml/2006/main">
-            <a:pPr marL="0" indent="0" algn="l">
-              <a:spcBef>
-                <a:spcPts val="0"/>
-              </a:spcBef>
-              <a:spcAft>
-                <a:spcPts val="0"/>
-              </a:spcAft>
-              <a:buNone/>
-              <a:defRPr sz="1125">
-                <a:solidFill>
-                  <a:srgbClr val="BCEF59"/>
-                </a:solidFill>
-                <a:latin typeface="Inter Medium"/>
-                <a:ea typeface="Inter Medium"/>
-                <a:cs typeface="Inter Medium"/>
-              </a:defRPr>
-            </a:pPr>
-            <a:r>
-              <a:t>RECORDED MILESTONES</a:t>
-            </a:r>
-          </a:p>
-        </p:txBody>
-      </p:sp>
-      <p:sp>
-        <p:nvSpPr>
-          <p:cNvPr id="2" name="">
-            <a:extLst xmlns:a="http://schemas.openxmlformats.org/drawingml/2006/main">
-              <a:ext uri="{FF2B5EF4-FFF2-40B4-BE49-F238E27FC236}">
-                <a16:creationId xmlns:a16="http://schemas.microsoft.com/office/drawing/2014/main" id="{DD386140-B344-4241-B152-8DF20223B75B}"/>
-              </a:ext>
-            </a:extLst>
-          </p:cNvPr>
-          <p:cNvSpPr>
-            <a:spLocks xmlns:a="http://schemas.openxmlformats.org/drawingml/2006/main" noGrp="1"/>
-          </p:cNvSpPr>
-          <p:nvPr/>
-        </p:nvSpPr>
-        <p:spPr>
-          <a:xfrm xmlns:a="http://schemas.openxmlformats.org/drawingml/2006/main">
-            <a:off x="666750" y="876300"/>
-            <a:ext cx="10668000" cy="971550"/>
-          </a:xfrm>
-          <a:prstGeom xmlns:a="http://schemas.openxmlformats.org/drawingml/2006/main" prst="rect">
-            <a:avLst/>
-          </a:prstGeom>
-          <a:noFill xmlns:a="http://schemas.openxmlformats.org/drawingml/2006/main"/>
-          <a:ln xmlns:a="http://schemas.openxmlformats.org/drawingml/2006/main" w="0">
-            <a:noFill/>
-          </a:ln>
-        </p:spPr>
-        <p:txBody>
-          <a:bodyPr xmlns:a="http://schemas.openxmlformats.org/drawingml/2006/main" lIns="0" tIns="0" rIns="0" bIns="0" anchor="t">
-            <a:normAutofit fontScale="100000"/>
-          </a:bodyPr>
-          <a:lstStyle xmlns:a="http://schemas.openxmlformats.org/drawingml/2006/main"/>
-          <a:p xmlns:a="http://schemas.openxmlformats.org/drawingml/2006/main">
-            <a:pPr marL="0" indent="0" algn="l">
-              <a:spcBef>
-                <a:spcPts val="0"/>
-              </a:spcBef>
-              <a:spcAft>
-                <a:spcPts val="0"/>
-              </a:spcAft>
-              <a:buNone/>
-              <a:defRPr sz="3225">
-                <a:solidFill>
-                  <a:srgbClr val="FFFFFF"/>
-                </a:solidFill>
-                <a:latin typeface="Inter Medium"/>
-                <a:ea typeface="Inter Medium"/>
-                <a:cs typeface="Inter Medium"/>
-              </a:defRPr>
-            </a:pPr>
-            <a:r>
-              <a:t>Dates and handoff data</a:t>
-            </a:r>
-          </a:p>
-        </p:txBody>
-      </p:sp>
-      <p:sp>
-        <p:nvSpPr>
-          <p:cNvPr id="3" name="">
-            <a:extLst xmlns:a="http://schemas.openxmlformats.org/drawingml/2006/main">
-              <a:ext uri="{FF2B5EF4-FFF2-40B4-BE49-F238E27FC236}">
-                <a16:creationId xmlns:a16="http://schemas.microsoft.com/office/drawing/2014/main" id="{9EBB5965-C2F0-4301-8098-56D8B6FF6CCB}"/>
-              </a:ext>
-            </a:extLst>
-          </p:cNvPr>
-          <p:cNvSpPr>
-            <a:spLocks xmlns:a="http://schemas.openxmlformats.org/drawingml/2006/main" noGrp="1"/>
-          </p:cNvSpPr>
-          <p:nvPr/>
-        </p:nvSpPr>
-        <p:spPr>
-          <a:xfrm xmlns:a="http://schemas.openxmlformats.org/drawingml/2006/main">
-            <a:off x="666750" y="6477000"/>
-            <a:ext cx="2476500" cy="171450"/>
-          </a:xfrm>
-          <a:prstGeom xmlns:a="http://schemas.openxmlformats.org/drawingml/2006/main" prst="rect">
-            <a:avLst/>
-          </a:prstGeom>
-          <a:noFill xmlns:a="http://schemas.openxmlformats.org/drawingml/2006/main"/>
-          <a:ln xmlns:a="http://schemas.openxmlformats.org/drawingml/2006/main" w="0">
-            <a:noFill/>
-          </a:ln>
-        </p:spPr>
-        <p:txBody>
-          <a:bodyPr xmlns:a="http://schemas.openxmlformats.org/drawingml/2006/main" lIns="0" tIns="0" rIns="0" bIns="0" anchor="t">
-            <a:normAutofit fontScale="100000"/>
-          </a:bodyPr>
-          <a:lstStyle xmlns:a="http://schemas.openxmlformats.org/drawingml/2006/main"/>
-          <a:p xmlns:a="http://schemas.openxmlformats.org/drawingml/2006/main">
-            <a:pPr marL="0" indent="0" algn="l">
-              <a:spcBef>
-                <a:spcPts val="0"/>
-              </a:spcBef>
-              <a:spcAft>
-                <a:spcPts val="0"/>
-              </a:spcAft>
-              <a:buNone/>
-              <a:defRPr sz="900">
-                <a:solidFill>
-                  <a:srgbClr val="B8C9C0"/>
-                </a:solidFill>
-                <a:latin typeface="Inter"/>
-                <a:ea typeface="Inter"/>
-                <a:cs typeface="Inter"/>
-              </a:defRPr>
-            </a:pPr>
-            <a:r>
-              <a:t>BATON   3</a:t>
-            </a:r>
-          </a:p>
-        </p:txBody>
-      </p:sp>
-      <p:sp>
-        <p:nvSpPr>
-          <p:cNvPr id="4" name="">
-            <a:extLst xmlns:a="http://schemas.openxmlformats.org/drawingml/2006/main">
-              <a:ext uri="{FF2B5EF4-FFF2-40B4-BE49-F238E27FC236}">
-                <a16:creationId xmlns:a16="http://schemas.microsoft.com/office/drawing/2014/main" id="{B589D615-B9EB-4469-A89F-761A5BCB2AA3}"/>
-              </a:ext>
-            </a:extLst>
-          </p:cNvPr>
-          <p:cNvSpPr>
-            <a:spLocks xmlns:a="http://schemas.openxmlformats.org/drawingml/2006/main" noGrp="1"/>
-          </p:cNvSpPr>
-          <p:nvPr/>
-        </p:nvSpPr>
-        <p:spPr>
-          <a:xfrm xmlns:a="http://schemas.openxmlformats.org/drawingml/2006/main">
-            <a:off x="6762750" y="6477000"/>
-            <a:ext cx="4572000" cy="171450"/>
-          </a:xfrm>
-          <a:prstGeom xmlns:a="http://schemas.openxmlformats.org/drawingml/2006/main" prst="rect">
-            <a:avLst/>
-          </a:prstGeom>
-          <a:noFill xmlns:a="http://schemas.openxmlformats.org/drawingml/2006/main"/>
-          <a:ln xmlns:a="http://schemas.openxmlformats.org/drawingml/2006/main" w="0">
-            <a:noFill/>
-          </a:ln>
-        </p:spPr>
-        <p:txBody>
-          <a:bodyPr xmlns:a="http://schemas.openxmlformats.org/drawingml/2006/main" lIns="0" tIns="0" rIns="0" bIns="0" anchor="t">
-            <a:normAutofit fontScale="100000"/>
-          </a:bodyPr>
-          <a:lstStyle xmlns:a="http://schemas.openxmlformats.org/drawingml/2006/main"/>
-          <a:p xmlns:a="http://schemas.openxmlformats.org/drawingml/2006/main">
-            <a:pPr marL="0" indent="0" algn="r">
-              <a:spcBef>
-                <a:spcPts val="0"/>
-              </a:spcBef>
-              <a:spcAft>
-                <a:spcPts val="0"/>
-              </a:spcAft>
-              <a:buNone/>
-              <a:defRPr sz="900">
-                <a:solidFill>
-                  <a:srgbClr val="B8C9C0"/>
-                </a:solidFill>
-                <a:latin typeface="Inter"/>
-                <a:ea typeface="Inter"/>
-                <a:cs typeface="Inter"/>
-              </a:defRPr>
-            </a:pPr>
-            <a:r>
-              <a:t>FICTIONAL, SIMULATED EXAMPLE   2026-12-01</a:t>
-            </a:r>
-          </a:p>
-        </p:txBody>
-      </p:sp>
-      <p:sp>
-        <p:nvSpPr>
-          <p:cNvPr id="5" name="">
-            <a:extLst xmlns:a="http://schemas.openxmlformats.org/drawingml/2006/main">
-              <a:ext uri="{FF2B5EF4-FFF2-40B4-BE49-F238E27FC236}">
-                <a16:creationId xmlns:a16="http://schemas.microsoft.com/office/drawing/2014/main" id="{7E5FD9ED-5F1B-452F-8D89-10E368199227}"/>
-              </a:ext>
-            </a:extLst>
-          </p:cNvPr>
-          <p:cNvSpPr>
-            <a:spLocks xmlns:a="http://schemas.openxmlformats.org/drawingml/2006/main" noGrp="1"/>
-          </p:cNvSpPr>
-          <p:nvPr/>
-        </p:nvSpPr>
-        <p:spPr>
-          <a:xfrm xmlns:a="http://schemas.openxmlformats.org/drawingml/2006/main">
-            <a:off x="666750" y="2333625"/>
-            <a:ext cx="1809750" cy="304800"/>
-          </a:xfrm>
-          <a:prstGeom xmlns:a="http://schemas.openxmlformats.org/drawingml/2006/main" prst="rect">
-            <a:avLst/>
-          </a:prstGeom>
-          <a:noFill xmlns:a="http://schemas.openxmlformats.org/drawingml/2006/main"/>
-          <a:ln xmlns:a="http://schemas.openxmlformats.org/drawingml/2006/main" w="0">
-            <a:noFill/>
-          </a:ln>
-        </p:spPr>
-        <p:txBody>
-          <a:bodyPr xmlns:a="http://schemas.openxmlformats.org/drawingml/2006/main" lIns="0" tIns="0" rIns="0" bIns="0" anchor="t">
-            <a:normAutofit fontScale="100000"/>
-          </a:bodyPr>
-          <a:lstStyle xmlns:a="http://schemas.openxmlformats.org/drawingml/2006/main"/>
-          <a:p xmlns:a="http://schemas.openxmlformats.org/drawingml/2006/main">
-            <a:pPr marL="0" indent="0" algn="l">
-              <a:spcBef>
-                <a:spcPts val="0"/>
-              </a:spcBef>
-              <a:spcAft>
-                <a:spcPts val="0"/>
-              </a:spcAft>
-              <a:buNone/>
-              <a:defRPr sz="1800">
-                <a:solidFill>
-                  <a:srgbClr val="BCEF59"/>
-                </a:solidFill>
-                <a:latin typeface="Inter Medium"/>
-                <a:ea typeface="Inter Medium"/>
-                <a:cs typeface="Inter Medium"/>
-              </a:defRPr>
-            </a:pPr>
-            <a:r>
-              <a:t>2026-09-16</a:t>
-            </a:r>
-          </a:p>
-        </p:txBody>
-      </p:sp>
-      <p:sp>
-        <p:nvSpPr>
-          <p:cNvPr id="6" name="">
-            <a:extLst xmlns:a="http://schemas.openxmlformats.org/drawingml/2006/main">
-              <a:ext uri="{FF2B5EF4-FFF2-40B4-BE49-F238E27FC236}">
-                <a16:creationId xmlns:a16="http://schemas.microsoft.com/office/drawing/2014/main" id="{B2715C44-3EE6-43E1-B5CA-4E8FB90AC710}"/>
-              </a:ext>
-            </a:extLst>
-          </p:cNvPr>
-          <p:cNvSpPr>
-            <a:spLocks xmlns:a="http://schemas.openxmlformats.org/drawingml/2006/main" noGrp="1"/>
-          </p:cNvSpPr>
-          <p:nvPr/>
-        </p:nvSpPr>
-        <p:spPr>
-          <a:xfrm xmlns:a="http://schemas.openxmlformats.org/drawingml/2006/main">
-            <a:off x="2667000" y="2333625"/>
-            <a:ext cx="4191000" cy="304800"/>
-          </a:xfrm>
-          <a:prstGeom xmlns:a="http://schemas.openxmlformats.org/drawingml/2006/main" prst="rect">
-            <a:avLst/>
-          </a:prstGeom>
-          <a:noFill xmlns:a="http://schemas.openxmlformats.org/drawingml/2006/main"/>
-          <a:ln xmlns:a="http://schemas.openxmlformats.org/drawingml/2006/main" w="0">
-            <a:noFill/>
-          </a:ln>
-        </p:spPr>
-        <p:txBody>
-          <a:bodyPr xmlns:a="http://schemas.openxmlformats.org/drawingml/2006/main" lIns="0" tIns="0" rIns="0" bIns="0" anchor="t">
-            <a:normAutofit fontScale="100000"/>
-          </a:bodyPr>
-          <a:lstStyle xmlns:a="http://schemas.openxmlformats.org/drawingml/2006/main"/>
-          <a:p xmlns:a="http://schemas.openxmlformats.org/drawingml/2006/main">
-            <a:pPr marL="0" indent="0" algn="l">
-              <a:spcBef>
-                <a:spcPts val="0"/>
-              </a:spcBef>
-              <a:spcAft>
-                <a:spcPts val="0"/>
-              </a:spcAft>
-              <a:buNone/>
-              <a:defRPr sz="1875">
-                <a:solidFill>
-                  <a:srgbClr val="FFFFFF"/>
-                </a:solidFill>
-                <a:latin typeface="Inter Medium"/>
-                <a:ea typeface="Inter Medium"/>
-                <a:cs typeface="Inter Medium"/>
-              </a:defRPr>
-            </a:pPr>
-            <a:r>
-              <a:t>Sales to Implementation</a:t>
-            </a:r>
-          </a:p>
-        </p:txBody>
-      </p:sp>
-      <p:sp>
-        <p:nvSpPr>
-          <p:cNvPr id="7" name="">
-            <a:extLst xmlns:a="http://schemas.openxmlformats.org/drawingml/2006/main">
-              <a:ext uri="{FF2B5EF4-FFF2-40B4-BE49-F238E27FC236}">
-                <a16:creationId xmlns:a16="http://schemas.microsoft.com/office/drawing/2014/main" id="{69C364A9-3434-4237-B7A9-810972098B1B}"/>
-              </a:ext>
-            </a:extLst>
-          </p:cNvPr>
-          <p:cNvSpPr>
-            <a:spLocks xmlns:a="http://schemas.openxmlformats.org/drawingml/2006/main" noGrp="1"/>
-          </p:cNvSpPr>
-          <p:nvPr/>
-        </p:nvSpPr>
-        <p:spPr>
-          <a:xfrm xmlns:a="http://schemas.openxmlformats.org/drawingml/2006/main">
-            <a:off x="8572500" y="2333625"/>
-            <a:ext cx="2095500" cy="304800"/>
-          </a:xfrm>
-          <a:prstGeom xmlns:a="http://schemas.openxmlformats.org/drawingml/2006/main" prst="rect">
-            <a:avLst/>
-          </a:prstGeom>
-          <a:noFill xmlns:a="http://schemas.openxmlformats.org/drawingml/2006/main"/>
-          <a:ln xmlns:a="http://schemas.openxmlformats.org/drawingml/2006/main" w="0">
-            <a:noFill/>
-          </a:ln>
-        </p:spPr>
-        <p:txBody>
-          <a:bodyPr xmlns:a="http://schemas.openxmlformats.org/drawingml/2006/main" lIns="0" tIns="0" rIns="0" bIns="0" anchor="t">
-            <a:normAutofit fontScale="100000"/>
-          </a:bodyPr>
-          <a:lstStyle xmlns:a="http://schemas.openxmlformats.org/drawingml/2006/main"/>
-          <a:p xmlns:a="http://schemas.openxmlformats.org/drawingml/2006/main">
-            <a:pPr marL="0" indent="0" algn="r">
-              <a:spcBef>
-                <a:spcPts val="0"/>
-              </a:spcBef>
-              <a:spcAft>
-                <a:spcPts val="0"/>
-              </a:spcAft>
-              <a:buNone/>
-              <a:defRPr sz="1875">
-                <a:solidFill>
-                  <a:srgbClr val="BCEF59"/>
-                </a:solidFill>
-                <a:latin typeface="Inter Medium"/>
-                <a:ea typeface="Inter Medium"/>
-                <a:cs typeface="Inter Medium"/>
-              </a:defRPr>
-            </a:pPr>
-            <a:r>
-              <a:t>Ready</a:t>
-            </a:r>
-          </a:p>
-        </p:txBody>
-      </p:sp>
-      <p:sp>
-        <p:nvSpPr>
-          <p:cNvPr id="8" name="">
-            <a:extLst xmlns:a="http://schemas.openxmlformats.org/drawingml/2006/main">
-              <a:ext uri="{FF2B5EF4-FFF2-40B4-BE49-F238E27FC236}">
-                <a16:creationId xmlns:a16="http://schemas.microsoft.com/office/drawing/2014/main" id="{A6CB9235-AB2A-4532-88EF-3DA6B8485B00}"/>
-              </a:ext>
-            </a:extLst>
-          </p:cNvPr>
-          <p:cNvSpPr>
-            <a:spLocks xmlns:a="http://schemas.openxmlformats.org/drawingml/2006/main" noGrp="1"/>
-          </p:cNvSpPr>
-          <p:nvPr/>
-        </p:nvSpPr>
-        <p:spPr>
-          <a:xfrm xmlns:a="http://schemas.openxmlformats.org/drawingml/2006/main">
-            <a:off x="2667000" y="2790825"/>
-            <a:ext cx="7905750" cy="781050"/>
-          </a:xfrm>
-          <a:prstGeom xmlns:a="http://schemas.openxmlformats.org/drawingml/2006/main" prst="rect">
-            <a:avLst/>
-          </a:prstGeom>
-          <a:noFill xmlns:a="http://schemas.openxmlformats.org/drawingml/2006/main"/>
-          <a:ln xmlns:a="http://schemas.openxmlformats.org/drawingml/2006/main" w="0">
-            <a:noFill/>
-          </a:ln>
-        </p:spPr>
-        <p:txBody>
-          <a:bodyPr xmlns:a="http://schemas.openxmlformats.org/drawingml/2006/main" lIns="0" tIns="0" rIns="0" bIns="0" anchor="t">
-            <a:normAutofit fontScale="100000"/>
-          </a:bodyPr>
-          <a:lstStyle xmlns:a="http://schemas.openxmlformats.org/drawingml/2006/main"/>
-          <a:p xmlns:a="http://schemas.openxmlformats.org/drawingml/2006/main">
-            <a:pPr marL="0" indent="0" algn="l">
-              <a:spcBef>
-                <a:spcPts val="0"/>
-              </a:spcBef>
-              <a:spcAft>
-                <a:spcPts val="0"/>
-              </a:spcAft>
-              <a:buNone/>
-              <a:defRPr sz="1500">
-                <a:solidFill>
-                  <a:srgbClr val="FFFFFF"/>
-                </a:solidFill>
-                <a:latin typeface="Inter"/>
-                <a:ea typeface="Inter"/>
-                <a:cs typeface="Inter"/>
-              </a:defRPr>
-            </a:pPr>
-            <a:r>
-              <a:t>Samson Delilah hands the account to Ruben Cherise. Agreed owners, rollout dates and measures support implementation. SSO remains a rollout gate; the December investigation-time goal is still due. [S1, S4]</a:t>
-            </a:r>
-          </a:p>
-        </p:txBody>
-      </p:sp>
-      <p:sp>
-        <p:nvSpPr>
-          <p:cNvPr id="9" name="">
-            <a:extLst xmlns:a="http://schemas.openxmlformats.org/drawingml/2006/main">
-              <a:ext uri="{FF2B5EF4-FFF2-40B4-BE49-F238E27FC236}">
-                <a16:creationId xmlns:a16="http://schemas.microsoft.com/office/drawing/2014/main" id="{6C205D0E-5423-4B38-ADD6-D74376256FD3}"/>
-              </a:ext>
-            </a:extLst>
-          </p:cNvPr>
-          <p:cNvSpPr>
-            <a:spLocks xmlns:a="http://schemas.openxmlformats.org/drawingml/2006/main" noGrp="1"/>
-          </p:cNvSpPr>
-          <p:nvPr/>
-        </p:nvSpPr>
-        <p:spPr>
-          <a:xfrm xmlns:a="http://schemas.openxmlformats.org/drawingml/2006/main">
-            <a:off x="666750" y="3952875"/>
-            <a:ext cx="1809750" cy="304800"/>
-          </a:xfrm>
-          <a:prstGeom xmlns:a="http://schemas.openxmlformats.org/drawingml/2006/main" prst="rect">
-            <a:avLst/>
-          </a:prstGeom>
-          <a:noFill xmlns:a="http://schemas.openxmlformats.org/drawingml/2006/main"/>
-          <a:ln xmlns:a="http://schemas.openxmlformats.org/drawingml/2006/main" w="0">
-            <a:noFill/>
-          </a:ln>
-        </p:spPr>
-        <p:txBody>
-          <a:bodyPr xmlns:a="http://schemas.openxmlformats.org/drawingml/2006/main" lIns="0" tIns="0" rIns="0" bIns="0" anchor="t">
-            <a:normAutofit fontScale="100000"/>
-          </a:bodyPr>
-          <a:lstStyle xmlns:a="http://schemas.openxmlformats.org/drawingml/2006/main"/>
-          <a:p xmlns:a="http://schemas.openxmlformats.org/drawingml/2006/main">
-            <a:pPr marL="0" indent="0" algn="l">
-              <a:spcBef>
-                <a:spcPts val="0"/>
-              </a:spcBef>
-              <a:spcAft>
-                <a:spcPts val="0"/>
-              </a:spcAft>
-              <a:buNone/>
-              <a:defRPr sz="1800">
-                <a:solidFill>
-                  <a:srgbClr val="BCEF59"/>
-                </a:solidFill>
-                <a:latin typeface="Inter Medium"/>
-                <a:ea typeface="Inter Medium"/>
-                <a:cs typeface="Inter Medium"/>
-              </a:defRPr>
-            </a:pPr>
-            <a:r>
-              <a:t>2026-12-01</a:t>
-            </a:r>
-          </a:p>
-        </p:txBody>
-      </p:sp>
-      <p:sp>
-        <p:nvSpPr>
-          <p:cNvPr id="10" name="">
-            <a:extLst xmlns:a="http://schemas.openxmlformats.org/drawingml/2006/main">
-              <a:ext uri="{FF2B5EF4-FFF2-40B4-BE49-F238E27FC236}">
-                <a16:creationId xmlns:a16="http://schemas.microsoft.com/office/drawing/2014/main" id="{C126F0CC-A469-44B1-8BE7-3101D9097158}"/>
-              </a:ext>
-            </a:extLst>
-          </p:cNvPr>
-          <p:cNvSpPr>
-            <a:spLocks xmlns:a="http://schemas.openxmlformats.org/drawingml/2006/main" noGrp="1"/>
-          </p:cNvSpPr>
-          <p:nvPr/>
-        </p:nvSpPr>
-        <p:spPr>
-          <a:xfrm xmlns:a="http://schemas.openxmlformats.org/drawingml/2006/main">
-            <a:off x="2667000" y="3952875"/>
-            <a:ext cx="4191000" cy="304800"/>
-          </a:xfrm>
-          <a:prstGeom xmlns:a="http://schemas.openxmlformats.org/drawingml/2006/main" prst="rect">
-            <a:avLst/>
-          </a:prstGeom>
-          <a:noFill xmlns:a="http://schemas.openxmlformats.org/drawingml/2006/main"/>
-          <a:ln xmlns:a="http://schemas.openxmlformats.org/drawingml/2006/main" w="0">
-            <a:noFill/>
-          </a:ln>
-        </p:spPr>
-        <p:txBody>
-          <a:bodyPr xmlns:a="http://schemas.openxmlformats.org/drawingml/2006/main" lIns="0" tIns="0" rIns="0" bIns="0" anchor="t">
-            <a:normAutofit fontScale="100000"/>
-          </a:bodyPr>
-          <a:lstStyle xmlns:a="http://schemas.openxmlformats.org/drawingml/2006/main"/>
-          <a:p xmlns:a="http://schemas.openxmlformats.org/drawingml/2006/main">
-            <a:pPr marL="0" indent="0" algn="l">
-              <a:spcBef>
-                <a:spcPts val="0"/>
-              </a:spcBef>
-              <a:spcAft>
-                <a:spcPts val="0"/>
-              </a:spcAft>
-              <a:buNone/>
-              <a:defRPr sz="1875">
-                <a:solidFill>
-                  <a:srgbClr val="FFFFFF"/>
-                </a:solidFill>
-                <a:latin typeface="Inter Medium"/>
-                <a:ea typeface="Inter Medium"/>
-                <a:cs typeface="Inter Medium"/>
-              </a:defRPr>
-            </a:pPr>
-            <a:r>
-              <a:t>Implementation to Customer Success</a:t>
-            </a:r>
-          </a:p>
-        </p:txBody>
-      </p:sp>
-      <p:sp>
-        <p:nvSpPr>
-          <p:cNvPr id="11" name="">
-            <a:extLst xmlns:a="http://schemas.openxmlformats.org/drawingml/2006/main">
-              <a:ext uri="{FF2B5EF4-FFF2-40B4-BE49-F238E27FC236}">
-                <a16:creationId xmlns:a16="http://schemas.microsoft.com/office/drawing/2014/main" id="{A58713B0-490C-4883-94B5-EF2E2EB041B7}"/>
-              </a:ext>
-            </a:extLst>
-          </p:cNvPr>
-          <p:cNvSpPr>
-            <a:spLocks xmlns:a="http://schemas.openxmlformats.org/drawingml/2006/main" noGrp="1"/>
-          </p:cNvSpPr>
-          <p:nvPr/>
-        </p:nvSpPr>
-        <p:spPr>
-          <a:xfrm xmlns:a="http://schemas.openxmlformats.org/drawingml/2006/main">
-            <a:off x="8572500" y="3952875"/>
-            <a:ext cx="2095500" cy="304800"/>
-          </a:xfrm>
-          <a:prstGeom xmlns:a="http://schemas.openxmlformats.org/drawingml/2006/main" prst="rect">
-            <a:avLst/>
-          </a:prstGeom>
-          <a:noFill xmlns:a="http://schemas.openxmlformats.org/drawingml/2006/main"/>
-          <a:ln xmlns:a="http://schemas.openxmlformats.org/drawingml/2006/main" w="0">
-            <a:noFill/>
-          </a:ln>
-        </p:spPr>
-        <p:txBody>
-          <a:bodyPr xmlns:a="http://schemas.openxmlformats.org/drawingml/2006/main" lIns="0" tIns="0" rIns="0" bIns="0" anchor="t">
-            <a:normAutofit fontScale="100000"/>
-          </a:bodyPr>
-          <a:lstStyle xmlns:a="http://schemas.openxmlformats.org/drawingml/2006/main"/>
-          <a:p xmlns:a="http://schemas.openxmlformats.org/drawingml/2006/main">
-            <a:pPr marL="0" indent="0" algn="r">
-              <a:spcBef>
-                <a:spcPts val="0"/>
-              </a:spcBef>
-              <a:spcAft>
-                <a:spcPts val="0"/>
-              </a:spcAft>
-              <a:buNone/>
-              <a:defRPr sz="1875">
-                <a:solidFill>
-                  <a:srgbClr val="F7C96A"/>
-                </a:solidFill>
-                <a:latin typeface="Inter Medium"/>
-                <a:ea typeface="Inter Medium"/>
-                <a:cs typeface="Inter Medium"/>
-              </a:defRPr>
-            </a:pPr>
-            <a:r>
-              <a:t>Needs Review</a:t>
-            </a:r>
-          </a:p>
-        </p:txBody>
-      </p:sp>
-      <p:sp>
-        <p:nvSpPr>
-          <p:cNvPr id="12" name="">
-            <a:extLst xmlns:a="http://schemas.openxmlformats.org/drawingml/2006/main">
-              <a:ext uri="{FF2B5EF4-FFF2-40B4-BE49-F238E27FC236}">
-                <a16:creationId xmlns:a16="http://schemas.microsoft.com/office/drawing/2014/main" id="{132E7D19-DB13-46BC-AAF7-711F288B6980}"/>
-              </a:ext>
-            </a:extLst>
-          </p:cNvPr>
-          <p:cNvSpPr>
-            <a:spLocks xmlns:a="http://schemas.openxmlformats.org/drawingml/2006/main" noGrp="1"/>
-          </p:cNvSpPr>
-          <p:nvPr/>
-        </p:nvSpPr>
-        <p:spPr>
-          <a:xfrm xmlns:a="http://schemas.openxmlformats.org/drawingml/2006/main">
-            <a:off x="2667000" y="4410075"/>
-            <a:ext cx="7905750" cy="781050"/>
-          </a:xfrm>
-          <a:prstGeom xmlns:a="http://schemas.openxmlformats.org/drawingml/2006/main" prst="rect">
-            <a:avLst/>
-          </a:prstGeom>
-          <a:noFill xmlns:a="http://schemas.openxmlformats.org/drawingml/2006/main"/>
-          <a:ln xmlns:a="http://schemas.openxmlformats.org/drawingml/2006/main" w="0">
-            <a:noFill/>
-          </a:ln>
-        </p:spPr>
-        <p:txBody>
-          <a:bodyPr xmlns:a="http://schemas.openxmlformats.org/drawingml/2006/main" lIns="0" tIns="0" rIns="0" bIns="0" anchor="t">
-            <a:normAutofit fontScale="100000"/>
-          </a:bodyPr>
-          <a:lstStyle xmlns:a="http://schemas.openxmlformats.org/drawingml/2006/main"/>
-          <a:p xmlns:a="http://schemas.openxmlformats.org/drawingml/2006/main">
-            <a:pPr marL="0" indent="0" algn="l">
-              <a:spcBef>
-                <a:spcPts val="0"/>
-              </a:spcBef>
-              <a:spcAft>
-                <a:spcPts val="0"/>
-              </a:spcAft>
-              <a:buNone/>
-              <a:defRPr sz="1500">
-                <a:solidFill>
-                  <a:srgbClr val="FFFFFF"/>
-                </a:solidFill>
-                <a:latin typeface="Inter"/>
-                <a:ea typeface="Inter"/>
-                <a:cs typeface="Inter"/>
-              </a:defRPr>
-            </a:pPr>
-            <a:r>
-              <a:t>Ruben Cherise hands the account to Althea Cassidy. Six venues are reporting and 96% of priority alerts arrive within 15 minutes. Training and QBR dates remain unconfirmed; the Dec 18 goal remains open. [S1, S3]</a:t>
+              <a:t>Due: Confirm date</a:t>
             </a:r>
           </a:p>
         </p:txBody>

</xml_diff>